<commit_message>
Update Collective FAQ outputs
</commit_message>
<xml_diff>
--- a/products/shopify-collective/ja/shopify-collective-architecture-ja.pptx
+++ b/products/shopify-collective/ja/shopify-collective-architecture-ja.pptx
@@ -2,24 +2,24 @@
 <file path=ppt/presentation.xml><?xml version="1.0" encoding="utf-8"?>
 <p:presentation xmlns:p="http://schemas.openxmlformats.org/presentationml/2006/main">
   <p:sldMasterIdLst>
-    <p:sldMasterId xmlns:r="http://schemas.openxmlformats.org/officeDocument/2006/relationships" id="2147483648" r:id="R230f6d165a424d8e"/>
+    <p:sldMasterId xmlns:r="http://schemas.openxmlformats.org/officeDocument/2006/relationships" id="2147483648" r:id="R73d086a09ab04d46"/>
   </p:sldMasterIdLst>
   <p:notesMasterIdLst>
-    <p:notesMasterId xmlns:r="http://schemas.openxmlformats.org/officeDocument/2006/relationships" r:id="Rf0c047a664314ae1"/>
+    <p:notesMasterId xmlns:r="http://schemas.openxmlformats.org/officeDocument/2006/relationships" r:id="R93ce4e7273de4d47"/>
   </p:notesMasterIdLst>
   <p:sldIdLst>
-    <p:sldId xmlns:r="http://schemas.openxmlformats.org/officeDocument/2006/relationships" id="256" r:id="R0e827e2aea854567"/>
-    <p:sldId xmlns:r="http://schemas.openxmlformats.org/officeDocument/2006/relationships" id="257" r:id="R7ec4521eb53747cf"/>
-    <p:sldId xmlns:r="http://schemas.openxmlformats.org/officeDocument/2006/relationships" id="258" r:id="Rca6596332ab64d10"/>
-    <p:sldId xmlns:r="http://schemas.openxmlformats.org/officeDocument/2006/relationships" id="259" r:id="R31c9b2a91b13480a"/>
-    <p:sldId xmlns:r="http://schemas.openxmlformats.org/officeDocument/2006/relationships" id="260" r:id="R24c327b678a14ece"/>
-    <p:sldId xmlns:r="http://schemas.openxmlformats.org/officeDocument/2006/relationships" id="261" r:id="R80ee4155adcf4018"/>
-    <p:sldId xmlns:r="http://schemas.openxmlformats.org/officeDocument/2006/relationships" id="262" r:id="R14c9358e70194707"/>
-    <p:sldId xmlns:r="http://schemas.openxmlformats.org/officeDocument/2006/relationships" id="263" r:id="R41532fc556a1455a"/>
-    <p:sldId xmlns:r="http://schemas.openxmlformats.org/officeDocument/2006/relationships" id="264" r:id="R47b7856951e14e71"/>
-    <p:sldId xmlns:r="http://schemas.openxmlformats.org/officeDocument/2006/relationships" id="265" r:id="R4d7e4540fd404842"/>
-    <p:sldId xmlns:r="http://schemas.openxmlformats.org/officeDocument/2006/relationships" id="266" r:id="Rc2181f3aecd34b99"/>
-    <p:sldId xmlns:r="http://schemas.openxmlformats.org/officeDocument/2006/relationships" id="267" r:id="Re5e73a714e774ce6"/>
+    <p:sldId xmlns:r="http://schemas.openxmlformats.org/officeDocument/2006/relationships" id="256" r:id="Ra5a39a4742794849"/>
+    <p:sldId xmlns:r="http://schemas.openxmlformats.org/officeDocument/2006/relationships" id="257" r:id="R7f96d65e13e34f73"/>
+    <p:sldId xmlns:r="http://schemas.openxmlformats.org/officeDocument/2006/relationships" id="258" r:id="R66d54c435312446a"/>
+    <p:sldId xmlns:r="http://schemas.openxmlformats.org/officeDocument/2006/relationships" id="259" r:id="Ra2aef9ec914a4cf7"/>
+    <p:sldId xmlns:r="http://schemas.openxmlformats.org/officeDocument/2006/relationships" id="260" r:id="Re186dc9ff8f845d9"/>
+    <p:sldId xmlns:r="http://schemas.openxmlformats.org/officeDocument/2006/relationships" id="261" r:id="R0a14561e7ce645a1"/>
+    <p:sldId xmlns:r="http://schemas.openxmlformats.org/officeDocument/2006/relationships" id="262" r:id="R19ecf0cb06f442a0"/>
+    <p:sldId xmlns:r="http://schemas.openxmlformats.org/officeDocument/2006/relationships" id="263" r:id="Rbb8f6a84729f4a35"/>
+    <p:sldId xmlns:r="http://schemas.openxmlformats.org/officeDocument/2006/relationships" id="264" r:id="R1b3ce2954d544d13"/>
+    <p:sldId xmlns:r="http://schemas.openxmlformats.org/officeDocument/2006/relationships" id="265" r:id="R11290b4a9ba14486"/>
+    <p:sldId xmlns:r="http://schemas.openxmlformats.org/officeDocument/2006/relationships" id="266" r:id="Ra6670f9ed0d947ac"/>
+    <p:sldId xmlns:r="http://schemas.openxmlformats.org/officeDocument/2006/relationships" id="267" r:id="Rd53c910913524aa4"/>
   </p:sldIdLst>
   <p:sldSz cx="12192000" cy="6858000"/>
   <p:notesSz cx="6858000" cy="9144000"/>
@@ -1338,7 +1338,7 @@
   </p:cSld>
   <p:clrMap bg1="lt1" tx1="dk1" bg2="lt2" tx2="dk2" accent1="accent1" accent2="accent2" accent3="accent3" accent4="accent4" accent5="accent5" accent6="accent6" hlink="hlink" folHlink="folHlink"/>
   <p:sldLayoutIdLst>
-    <p:sldLayoutId xmlns:r="http://schemas.openxmlformats.org/officeDocument/2006/relationships" id="2147483649" r:id="R6f6a16f1458c4e5c"/>
+    <p:sldLayoutId xmlns:r="http://schemas.openxmlformats.org/officeDocument/2006/relationships" id="2147483649" r:id="R3479a5c2836542a9"/>
   </p:sldLayoutIdLst>
   <p:txStyles>
     <p:titleStyle>
@@ -1889,7 +1889,7 @@
           <p:cNvPr id="1" name="">
             <a:extLst xmlns:a="http://schemas.openxmlformats.org/drawingml/2006/main">
               <a:ext uri="{FF2B5EF4-FFF2-40B4-BE49-F238E27FC236}">
-                <a16:creationId xmlns:a16="http://schemas.microsoft.com/office/drawing/2014/main" id="{E9E12B1E-C672-405A-801F-6AE4FE8BB999}"/>
+                <a16:creationId xmlns:a16="http://schemas.microsoft.com/office/drawing/2014/main" id="{4A742F2A-78E3-4526-873D-B897CB1E4636}"/>
               </a:ext>
             </a:extLst>
           </p:cNvPr>
@@ -1939,7 +1939,7 @@
           <p:cNvPr id="2" name="">
             <a:extLst xmlns:a="http://schemas.openxmlformats.org/drawingml/2006/main">
               <a:ext uri="{FF2B5EF4-FFF2-40B4-BE49-F238E27FC236}">
-                <a16:creationId xmlns:a16="http://schemas.microsoft.com/office/drawing/2014/main" id="{17797EC2-5E00-411C-9E1E-BAED8BF805DA}"/>
+                <a16:creationId xmlns:a16="http://schemas.microsoft.com/office/drawing/2014/main" id="{C774FDA6-4250-4C19-A256-44D8BA8BAFB3}"/>
               </a:ext>
             </a:extLst>
           </p:cNvPr>
@@ -2006,7 +2006,7 @@
           <p:cNvPr id="3" name="">
             <a:extLst xmlns:a="http://schemas.openxmlformats.org/drawingml/2006/main">
               <a:ext uri="{FF2B5EF4-FFF2-40B4-BE49-F238E27FC236}">
-                <a16:creationId xmlns:a16="http://schemas.microsoft.com/office/drawing/2014/main" id="{35FC23B9-35AB-420D-8610-509F675795A4}"/>
+                <a16:creationId xmlns:a16="http://schemas.microsoft.com/office/drawing/2014/main" id="{897A7AC0-A185-4FB3-84C9-D74E178236D9}"/>
               </a:ext>
             </a:extLst>
           </p:cNvPr>
@@ -2046,7 +2046,7 @@
                   <a:srgbClr val="FFFFFF"/>
                 </a:solidFill>
               </a:rPr>
-              <a:t>architecture.mdをもとに、小売とサプライヤーの処理フローを要約</a:t>
+              <a:t>商品同期、注文、支払い、返品までのRetailer/Supplierフロー</a:t>
             </a:r>
           </a:p>
         </p:txBody>
@@ -2056,57 +2056,7 @@
           <p:cNvPr id="4" name="">
             <a:extLst xmlns:a="http://schemas.openxmlformats.org/drawingml/2006/main">
               <a:ext uri="{FF2B5EF4-FFF2-40B4-BE49-F238E27FC236}">
-                <a16:creationId xmlns:a16="http://schemas.microsoft.com/office/drawing/2014/main" id="{BE2C644E-372C-4B1B-9110-79D5C6FC7CC1}"/>
-              </a:ext>
-            </a:extLst>
-          </p:cNvPr>
-          <p:cNvSpPr>
-            <a:spLocks xmlns:a="http://schemas.openxmlformats.org/drawingml/2006/main" noGrp="1"/>
-          </p:cNvSpPr>
-          <p:nvPr/>
-        </p:nvSpPr>
-        <p:spPr>
-          <a:xfrm xmlns:a="http://schemas.openxmlformats.org/drawingml/2006/main">
-            <a:off x="647700" y="5962650"/>
-            <a:ext cx="8096250" cy="247650"/>
-          </a:xfrm>
-          <a:prstGeom xmlns:a="http://schemas.openxmlformats.org/drawingml/2006/main" prst="rect">
-            <a:avLst/>
-          </a:prstGeom>
-          <a:noFill xmlns:a="http://schemas.openxmlformats.org/drawingml/2006/main"/>
-          <a:ln xmlns:a="http://schemas.openxmlformats.org/drawingml/2006/main" w="0">
-            <a:noFill/>
-            <a:prstDash val="solid"/>
-          </a:ln>
-        </p:spPr>
-        <p:txBody>
-          <a:bodyPr xmlns:a="http://schemas.openxmlformats.org/drawingml/2006/main"/>
-          <a:lstStyle xmlns:a="http://schemas.openxmlformats.org/drawingml/2006/main"/>
-          <a:p xmlns:a="http://schemas.openxmlformats.org/drawingml/2006/main">
-            <a:pPr algn="l">
-              <a:defRPr sz="1050" b="0">
-                <a:solidFill>
-                  <a:srgbClr val="D8EEE6"/>
-                </a:solidFill>
-              </a:defRPr>
-            </a:pPr>
-            <a:r>
-              <a:rPr sz="1050" b="0">
-                <a:solidFill>
-                  <a:srgbClr val="D8EEE6"/>
-                </a:solidFill>
-              </a:rPr>
-              <a:t>非公式の補助資料です。内容は通知なく変更される可能性があります。</a:t>
-            </a:r>
-          </a:p>
-        </p:txBody>
-      </p:sp>
-      <p:sp>
-        <p:nvSpPr>
-          <p:cNvPr id="5" name="">
-            <a:extLst xmlns:a="http://schemas.openxmlformats.org/drawingml/2006/main">
-              <a:ext uri="{FF2B5EF4-FFF2-40B4-BE49-F238E27FC236}">
-                <a16:creationId xmlns:a16="http://schemas.microsoft.com/office/drawing/2014/main" id="{B9732AD8-7572-45A0-A903-813EB215D1F5}"/>
+                <a16:creationId xmlns:a16="http://schemas.microsoft.com/office/drawing/2014/main" id="{C0808776-78C4-420F-A496-A7788C114750}"/>
               </a:ext>
             </a:extLst>
           </p:cNvPr>
@@ -2154,7 +2104,7 @@
     </p:spTree>
     <p:extLst>
       <p:ext uri="{BB962C8B-B14F-4D97-AF65-F5344CB8AC3E}">
-        <p14:creationId xmlns:p14="http://schemas.microsoft.com/office/powerpoint/2010/main" val="985817261"/>
+        <p14:creationId xmlns:p14="http://schemas.microsoft.com/office/powerpoint/2010/main" val="310741541"/>
       </p:ext>
     </p:extLst>
   </p:cSld>
@@ -2185,7 +2135,7 @@
           <p:cNvPr id="1" name="">
             <a:extLst xmlns:a="http://schemas.openxmlformats.org/drawingml/2006/main">
               <a:ext uri="{FF2B5EF4-FFF2-40B4-BE49-F238E27FC236}">
-                <a16:creationId xmlns:a16="http://schemas.microsoft.com/office/drawing/2014/main" id="{BF4C9AAA-1B98-4076-938F-8B7F182A9170}"/>
+                <a16:creationId xmlns:a16="http://schemas.microsoft.com/office/drawing/2014/main" id="{C8D6423B-73C3-45B4-B00B-288034C0FB8D}"/>
               </a:ext>
             </a:extLst>
           </p:cNvPr>
@@ -2225,7 +2175,7 @@
                   <a:srgbClr val="004C3F"/>
                 </a:solidFill>
               </a:rPr>
-              <a:t>09 | FAQ: 商品と同期</a:t>
+              <a:t>09 | FAQ: 注文と金額</a:t>
             </a:r>
           </a:p>
         </p:txBody>
@@ -2235,7 +2185,7 @@
           <p:cNvPr id="2" name="">
             <a:extLst xmlns:a="http://schemas.openxmlformats.org/drawingml/2006/main">
               <a:ext uri="{FF2B5EF4-FFF2-40B4-BE49-F238E27FC236}">
-                <a16:creationId xmlns:a16="http://schemas.microsoft.com/office/drawing/2014/main" id="{08C3783D-9CDB-4BC4-A464-AB8076070595}"/>
+                <a16:creationId xmlns:a16="http://schemas.microsoft.com/office/drawing/2014/main" id="{CF315CF5-D872-46F8-86C9-37173A0BC7DE}"/>
               </a:ext>
             </a:extLst>
           </p:cNvPr>
@@ -2275,7 +2225,7 @@
                   <a:srgbClr val="101820"/>
                 </a:solidFill>
               </a:rPr>
-              <a:t>商品系の疑問は管理元を分けると解ける</a:t>
+              <a:t>注文と支払いはWebhookと照合を分ける</a:t>
             </a:r>
           </a:p>
         </p:txBody>
@@ -2285,7 +2235,7 @@
           <p:cNvPr id="3" name="">
             <a:extLst xmlns:a="http://schemas.openxmlformats.org/drawingml/2006/main">
               <a:ext uri="{FF2B5EF4-FFF2-40B4-BE49-F238E27FC236}">
-                <a16:creationId xmlns:a16="http://schemas.microsoft.com/office/drawing/2014/main" id="{C1C786E4-3E6C-4B5A-8EBE-F17381F97FDB}"/>
+                <a16:creationId xmlns:a16="http://schemas.microsoft.com/office/drawing/2014/main" id="{31FC53A7-E69D-41E8-ABA8-E57DC170C4BA}"/>
               </a:ext>
             </a:extLst>
           </p:cNvPr>
@@ -2325,7 +2275,7 @@
                   <a:srgbClr val="52615B"/>
                 </a:solidFill>
               </a:rPr>
-              <a:t>Supplier管理フィールドとRetailerのbuyer-facing表示を分けます。</a:t>
+              <a:t>外部システムはWebhookを変更フィードとして使い、最終金額はpayment adjustmentで照合します。</a:t>
             </a:r>
           </a:p>
         </p:txBody>
@@ -2335,7 +2285,7 @@
           <p:cNvPr id="4" name="">
             <a:extLst xmlns:a="http://schemas.openxmlformats.org/drawingml/2006/main">
               <a:ext uri="{FF2B5EF4-FFF2-40B4-BE49-F238E27FC236}">
-                <a16:creationId xmlns:a16="http://schemas.microsoft.com/office/drawing/2014/main" id="{04551304-2FF2-4B9C-BFF5-C5CFFDCDF52A}"/>
+                <a16:creationId xmlns:a16="http://schemas.microsoft.com/office/drawing/2014/main" id="{7406EE18-36C4-4DCD-B868-DEDFC388DD3A}"/>
               </a:ext>
             </a:extLst>
           </p:cNvPr>
@@ -2366,7 +2316,7 @@
           <p:cNvPr id="5" name="">
             <a:extLst xmlns:a="http://schemas.openxmlformats.org/drawingml/2006/main">
               <a:ext uri="{FF2B5EF4-FFF2-40B4-BE49-F238E27FC236}">
-                <a16:creationId xmlns:a16="http://schemas.microsoft.com/office/drawing/2014/main" id="{99A8911B-ABCA-4E6D-A6CB-C032B9CECB9A}"/>
+                <a16:creationId xmlns:a16="http://schemas.microsoft.com/office/drawing/2014/main" id="{5782B355-2896-4808-ADDC-3030B8192BC6}"/>
               </a:ext>
             </a:extLst>
           </p:cNvPr>
@@ -2406,7 +2356,7 @@
                   <a:srgbClr val="004C3F"/>
                 </a:solidFill>
               </a:rPr>
-              <a:t>商品マスターはSupplier側必須?</a:t>
+              <a:t>Supplier注文はいつ作成?</a:t>
             </a:r>
           </a:p>
         </p:txBody>
@@ -2416,7 +2366,7 @@
           <p:cNvPr id="6" name="">
             <a:extLst xmlns:a="http://schemas.openxmlformats.org/drawingml/2006/main">
               <a:ext uri="{FF2B5EF4-FFF2-40B4-BE49-F238E27FC236}">
-                <a16:creationId xmlns:a16="http://schemas.microsoft.com/office/drawing/2014/main" id="{32BBC847-0EE5-4EFC-BEF6-F87925904CA7}"/>
+                <a16:creationId xmlns:a16="http://schemas.microsoft.com/office/drawing/2014/main" id="{90E8D006-B844-4412-937D-DB10641244C6}"/>
               </a:ext>
             </a:extLst>
           </p:cNvPr>
@@ -2456,7 +2406,7 @@
                   <a:srgbClr val="52615B"/>
                 </a:solidFill>
               </a:rPr>
-              <a:t>Collectiveで共有する商品はSupplierのShopifyストアに存在し、Collectiveへ公開される必要があります。上流はERP/PIMでも構いません。</a:t>
+              <a:t>Retailer注文の支払い後、不正チェックを通過し、保留でなければ作成されます。ERP/OMS/WMS同期は注文作成・更新Webhookを使います。</a:t>
             </a:r>
           </a:p>
         </p:txBody>
@@ -2466,7 +2416,7 @@
           <p:cNvPr id="7" name="">
             <a:extLst xmlns:a="http://schemas.openxmlformats.org/drawingml/2006/main">
               <a:ext uri="{FF2B5EF4-FFF2-40B4-BE49-F238E27FC236}">
-                <a16:creationId xmlns:a16="http://schemas.microsoft.com/office/drawing/2014/main" id="{6BF4163E-AD52-46FA-A727-B506C5FF3DC4}"/>
+                <a16:creationId xmlns:a16="http://schemas.microsoft.com/office/drawing/2014/main" id="{71E06DC9-4323-4D54-B12A-F1C6C7B6220B}"/>
               </a:ext>
             </a:extLst>
           </p:cNvPr>
@@ -2506,7 +2456,7 @@
                   <a:srgbClr val="004C3F"/>
                 </a:solidFill>
               </a:rPr>
-              <a:t>Supplier変更時は?</a:t>
+              <a:t>Supplier金額の決まり方は?</a:t>
             </a:r>
           </a:p>
         </p:txBody>
@@ -2516,7 +2466,7 @@
           <p:cNvPr id="8" name="">
             <a:extLst xmlns:a="http://schemas.openxmlformats.org/drawingml/2006/main">
               <a:ext uri="{FF2B5EF4-FFF2-40B4-BE49-F238E27FC236}">
-                <a16:creationId xmlns:a16="http://schemas.microsoft.com/office/drawing/2014/main" id="{A4B8E4E4-5519-442E-9E8A-C31CF044421C}"/>
+                <a16:creationId xmlns:a16="http://schemas.microsoft.com/office/drawing/2014/main" id="{F01CA8AE-AAC9-4B43-BD6D-FAD4D99C3AB3}"/>
               </a:ext>
             </a:extLst>
           </p:cNvPr>
@@ -2556,7 +2506,7 @@
                   <a:srgbClr val="52615B"/>
                 </a:solidFill>
               </a:rPr>
-              <a:t>在庫とcost priceは同期されます。その他の商品情報はproduct policyや同期設定に依存します。</a:t>
+              <a:t>Cost price、supplier shipping、税、調整で決まり、顧客checkout総額そのものではありません。会計連携では注文Webhookとpayment adjustmentを併用します。</a:t>
             </a:r>
           </a:p>
         </p:txBody>
@@ -2566,7 +2516,7 @@
           <p:cNvPr id="9" name="">
             <a:extLst xmlns:a="http://schemas.openxmlformats.org/drawingml/2006/main">
               <a:ext uri="{FF2B5EF4-FFF2-40B4-BE49-F238E27FC236}">
-                <a16:creationId xmlns:a16="http://schemas.microsoft.com/office/drawing/2014/main" id="{0C3BFCB2-E485-4FE0-916D-6CDCE27A88B6}"/>
+                <a16:creationId xmlns:a16="http://schemas.microsoft.com/office/drawing/2014/main" id="{85C7D499-D0C6-4F47-8712-8887F53B4BD6}"/>
               </a:ext>
             </a:extLst>
           </p:cNvPr>
@@ -2606,7 +2556,7 @@
                   <a:srgbClr val="004C3F"/>
                 </a:solidFill>
               </a:rPr>
-              <a:t>Retailer変更時は?</a:t>
+              <a:t>入金額と注文金額は一致?</a:t>
             </a:r>
           </a:p>
         </p:txBody>
@@ -2616,7 +2566,7 @@
           <p:cNvPr id="10" name="">
             <a:extLst xmlns:a="http://schemas.openxmlformats.org/drawingml/2006/main">
               <a:ext uri="{FF2B5EF4-FFF2-40B4-BE49-F238E27FC236}">
-                <a16:creationId xmlns:a16="http://schemas.microsoft.com/office/drawing/2014/main" id="{677A4476-6853-436C-958C-9466962B1429}"/>
+                <a16:creationId xmlns:a16="http://schemas.microsoft.com/office/drawing/2014/main" id="{8EA71738-372B-46A7-ACEC-F7C67F302254}"/>
               </a:ext>
             </a:extLst>
           </p:cNvPr>
@@ -2656,7 +2606,7 @@
                   <a:srgbClr val="52615B"/>
                 </a:solidFill>
               </a:rPr>
-              <a:t>Retailer編集はSupplierの元商品を更新しません。Supplier管理フィールドはSupplier側が管理します。</a:t>
+              <a:t>一対一とは限りません。返金、返品、reversal、税、送料、タイミング、残高の影響を受けます。</a:t>
             </a:r>
           </a:p>
         </p:txBody>
@@ -2666,7 +2616,7 @@
           <p:cNvPr id="11" name="">
             <a:extLst xmlns:a="http://schemas.openxmlformats.org/drawingml/2006/main">
               <a:ext uri="{FF2B5EF4-FFF2-40B4-BE49-F238E27FC236}">
-                <a16:creationId xmlns:a16="http://schemas.microsoft.com/office/drawing/2014/main" id="{4AE099C9-79CB-4580-8CB8-F56B449FE35C}"/>
+                <a16:creationId xmlns:a16="http://schemas.microsoft.com/office/drawing/2014/main" id="{DD91387A-4378-4DF2-B99F-A31213F89E2E}"/>
               </a:ext>
             </a:extLst>
           </p:cNvPr>
@@ -2706,7 +2656,7 @@
                   <a:srgbClr val="004C3F"/>
                 </a:solidFill>
               </a:rPr>
-              <a:t>在庫は食い違う?</a:t>
+              <a:t>Retailer discount時は?</a:t>
             </a:r>
           </a:p>
         </p:txBody>
@@ -2716,7 +2666,7 @@
           <p:cNvPr id="12" name="">
             <a:extLst xmlns:a="http://schemas.openxmlformats.org/drawingml/2006/main">
               <a:ext uri="{FF2B5EF4-FFF2-40B4-BE49-F238E27FC236}">
-                <a16:creationId xmlns:a16="http://schemas.microsoft.com/office/drawing/2014/main" id="{5B0ECCC1-123B-4F0D-BBCA-0B2C3EF1E55E}"/>
+                <a16:creationId xmlns:a16="http://schemas.microsoft.com/office/drawing/2014/main" id="{AF9469AB-FBE8-4891-A742-D127829C63B3}"/>
               </a:ext>
             </a:extLst>
           </p:cNvPr>
@@ -2756,7 +2706,7 @@
                   <a:srgbClr val="52615B"/>
                 </a:solidFill>
               </a:rPr>
-              <a:t>一時的にはありえます。Shopify checkoutはSupplier在庫を確認しますが、手動注文は例外です。</a:t>
+              <a:t>顧客支払額が下がりRetailer利益が減ります。Supplier cost priceは変わりません。</a:t>
             </a:r>
           </a:p>
         </p:txBody>
@@ -2766,7 +2716,7 @@
           <p:cNvPr id="13" name="">
             <a:extLst xmlns:a="http://schemas.openxmlformats.org/drawingml/2006/main">
               <a:ext uri="{FF2B5EF4-FFF2-40B4-BE49-F238E27FC236}">
-                <a16:creationId xmlns:a16="http://schemas.microsoft.com/office/drawing/2014/main" id="{53A169D9-6E66-47FF-B4A0-DD28AC9ABA24}"/>
+                <a16:creationId xmlns:a16="http://schemas.microsoft.com/office/drawing/2014/main" id="{9A4FA5AF-9087-4CBB-8CD3-B0AF59155B89}"/>
               </a:ext>
             </a:extLst>
           </p:cNvPr>
@@ -2797,7 +2747,7 @@
           <p:cNvPr id="14" name="">
             <a:extLst xmlns:a="http://schemas.openxmlformats.org/drawingml/2006/main">
               <a:ext uri="{FF2B5EF4-FFF2-40B4-BE49-F238E27FC236}">
-                <a16:creationId xmlns:a16="http://schemas.microsoft.com/office/drawing/2014/main" id="{FAC8AE88-5461-4CD6-A85A-25FD0D63C9B8}"/>
+                <a16:creationId xmlns:a16="http://schemas.microsoft.com/office/drawing/2014/main" id="{C42F95AF-F11C-41C4-8D74-25FD9E6FF87D}"/>
               </a:ext>
             </a:extLst>
           </p:cNvPr>
@@ -2809,7 +2759,7 @@
         <p:spPr>
           <a:xfrm xmlns:a="http://schemas.openxmlformats.org/drawingml/2006/main">
             <a:off x="609600" y="6419850"/>
-            <a:ext cx="7810500" cy="209550"/>
+            <a:ext cx="4000500" cy="209550"/>
           </a:xfrm>
           <a:prstGeom xmlns:a="http://schemas.openxmlformats.org/drawingml/2006/main" prst="rect">
             <a:avLst/>
@@ -2837,7 +2787,7 @@
                   <a:srgbClr val="52615B"/>
                 </a:solidFill>
               </a:rPr>
-              <a:t>非公式資料 | Source: products/shopify-collective/architecture.md</a:t>
+              <a:t>Shopify Collective</a:t>
             </a:r>
           </a:p>
         </p:txBody>
@@ -2847,7 +2797,7 @@
           <p:cNvPr id="15" name="">
             <a:extLst xmlns:a="http://schemas.openxmlformats.org/drawingml/2006/main">
               <a:ext uri="{FF2B5EF4-FFF2-40B4-BE49-F238E27FC236}">
-                <a16:creationId xmlns:a16="http://schemas.microsoft.com/office/drawing/2014/main" id="{1F743661-8A24-496D-B347-0CD095750E5C}"/>
+                <a16:creationId xmlns:a16="http://schemas.microsoft.com/office/drawing/2014/main" id="{EA82981B-4A12-42F8-8435-0D2F53991D30}"/>
               </a:ext>
             </a:extLst>
           </p:cNvPr>
@@ -2895,7 +2845,7 @@
     </p:spTree>
     <p:extLst>
       <p:ext uri="{BB962C8B-B14F-4D97-AF65-F5344CB8AC3E}">
-        <p14:creationId xmlns:p14="http://schemas.microsoft.com/office/powerpoint/2010/main" val="1755900333"/>
+        <p14:creationId xmlns:p14="http://schemas.microsoft.com/office/powerpoint/2010/main" val="538913160"/>
       </p:ext>
     </p:extLst>
   </p:cSld>
@@ -2926,7 +2876,7 @@
           <p:cNvPr id="1" name="">
             <a:extLst xmlns:a="http://schemas.openxmlformats.org/drawingml/2006/main">
               <a:ext uri="{FF2B5EF4-FFF2-40B4-BE49-F238E27FC236}">
-                <a16:creationId xmlns:a16="http://schemas.microsoft.com/office/drawing/2014/main" id="{00517F51-42F7-4A3E-B127-CF618A9A6C2E}"/>
+                <a16:creationId xmlns:a16="http://schemas.microsoft.com/office/drawing/2014/main" id="{CF056323-C9DC-473C-9A23-AF8FE37BB379}"/>
               </a:ext>
             </a:extLst>
           </p:cNvPr>
@@ -2966,7 +2916,7 @@
                   <a:srgbClr val="004C3F"/>
                 </a:solidFill>
               </a:rPr>
-              <a:t>10 | FAQ: 金額</a:t>
+              <a:t>10 | FAQ: 商品と在庫</a:t>
             </a:r>
           </a:p>
         </p:txBody>
@@ -2976,7 +2926,7 @@
           <p:cNvPr id="2" name="">
             <a:extLst xmlns:a="http://schemas.openxmlformats.org/drawingml/2006/main">
               <a:ext uri="{FF2B5EF4-FFF2-40B4-BE49-F238E27FC236}">
-                <a16:creationId xmlns:a16="http://schemas.microsoft.com/office/drawing/2014/main" id="{8076E854-7906-4E76-8AD1-186A0C6B7D0D}"/>
+                <a16:creationId xmlns:a16="http://schemas.microsoft.com/office/drawing/2014/main" id="{93C0C2EE-0D41-4735-AEA3-1AE0F40F5CD1}"/>
               </a:ext>
             </a:extLst>
           </p:cNvPr>
@@ -3016,7 +2966,7 @@
                   <a:srgbClr val="101820"/>
                 </a:solidFill>
               </a:rPr>
-              <a:t>金額系は注文とpayment adjustmentで照合する</a:t>
+              <a:t>商品FAQはCollective同期と外部同期を分ける</a:t>
             </a:r>
           </a:p>
         </p:txBody>
@@ -3026,7 +2976,7 @@
           <p:cNvPr id="3" name="">
             <a:extLst xmlns:a="http://schemas.openxmlformats.org/drawingml/2006/main">
               <a:ext uri="{FF2B5EF4-FFF2-40B4-BE49-F238E27FC236}">
-                <a16:creationId xmlns:a16="http://schemas.microsoft.com/office/drawing/2014/main" id="{74A00003-A312-40D1-8789-B118AFAE5F04}"/>
+                <a16:creationId xmlns:a16="http://schemas.microsoft.com/office/drawing/2014/main" id="{83135368-1877-4A50-BA20-A88851674E02}"/>
               </a:ext>
             </a:extLst>
           </p:cNvPr>
@@ -3066,7 +3016,7 @@
                   <a:srgbClr val="52615B"/>
                 </a:solidFill>
               </a:rPr>
-              <a:t>購入者のcheckout総額だけでSupplier側の経済性を判断しないことが重要です。</a:t>
+              <a:t>CollectiveはSupplierからRetailerへの同期を担い、外部システムは接続先ストアのWebhookを購読します。</a:t>
             </a:r>
           </a:p>
         </p:txBody>
@@ -3076,7 +3026,7 @@
           <p:cNvPr id="4" name="">
             <a:extLst xmlns:a="http://schemas.openxmlformats.org/drawingml/2006/main">
               <a:ext uri="{FF2B5EF4-FFF2-40B4-BE49-F238E27FC236}">
-                <a16:creationId xmlns:a16="http://schemas.microsoft.com/office/drawing/2014/main" id="{B4B2EC8E-089A-4ACD-9ACE-72B5D8FDDEEA}"/>
+                <a16:creationId xmlns:a16="http://schemas.microsoft.com/office/drawing/2014/main" id="{F1EAF632-3F05-41EC-A31C-BB440C1F7367}"/>
               </a:ext>
             </a:extLst>
           </p:cNvPr>
@@ -3107,7 +3057,7 @@
           <p:cNvPr id="5" name="">
             <a:extLst xmlns:a="http://schemas.openxmlformats.org/drawingml/2006/main">
               <a:ext uri="{FF2B5EF4-FFF2-40B4-BE49-F238E27FC236}">
-                <a16:creationId xmlns:a16="http://schemas.microsoft.com/office/drawing/2014/main" id="{0E6AFB08-97E4-41A4-BD4D-A23C128EB12F}"/>
+                <a16:creationId xmlns:a16="http://schemas.microsoft.com/office/drawing/2014/main" id="{E5268091-9090-4307-ACBB-ADB3A188A410}"/>
               </a:ext>
             </a:extLst>
           </p:cNvPr>
@@ -3147,7 +3097,7 @@
                   <a:srgbClr val="004C3F"/>
                 </a:solidFill>
               </a:rPr>
-              <a:t>Supplier金額の決まり方は?</a:t>
+              <a:t>在庫同期はどう行われる?</a:t>
             </a:r>
           </a:p>
         </p:txBody>
@@ -3157,7 +3107,7 @@
           <p:cNvPr id="6" name="">
             <a:extLst xmlns:a="http://schemas.openxmlformats.org/drawingml/2006/main">
               <a:ext uri="{FF2B5EF4-FFF2-40B4-BE49-F238E27FC236}">
-                <a16:creationId xmlns:a16="http://schemas.microsoft.com/office/drawing/2014/main" id="{FFFEEFE7-786E-4FDB-8DF5-1859D37A36D2}"/>
+                <a16:creationId xmlns:a16="http://schemas.microsoft.com/office/drawing/2014/main" id="{6AF22B77-A7D1-4183-8E07-566686B8A92D}"/>
               </a:ext>
             </a:extLst>
           </p:cNvPr>
@@ -3197,7 +3147,7 @@
                   <a:srgbClr val="52615B"/>
                 </a:solidFill>
               </a:rPr>
-              <a:t>Cost price、supplier shipping、税、order/payment adjustmentで決まります。顧客checkout総額そのものではありません。</a:t>
+              <a:t>Supplierのオンライン販売可能在庫がRetailer在庫に反映されます。Retailer側の外部ミラーは商品作成・更新・削除Webhookを使います。</a:t>
             </a:r>
           </a:p>
         </p:txBody>
@@ -3207,7 +3157,7 @@
           <p:cNvPr id="7" name="">
             <a:extLst xmlns:a="http://schemas.openxmlformats.org/drawingml/2006/main">
               <a:ext uri="{FF2B5EF4-FFF2-40B4-BE49-F238E27FC236}">
-                <a16:creationId xmlns:a16="http://schemas.microsoft.com/office/drawing/2014/main" id="{90001C71-D64D-459C-9736-A4565187301E}"/>
+                <a16:creationId xmlns:a16="http://schemas.microsoft.com/office/drawing/2014/main" id="{18E6D18C-553A-44A9-B282-20D3A4DC6D0A}"/>
               </a:ext>
             </a:extLst>
           </p:cNvPr>
@@ -3247,7 +3197,7 @@
                   <a:srgbClr val="004C3F"/>
                 </a:solidFill>
               </a:rPr>
-              <a:t>Retailer discount時は?</a:t>
+              <a:t>在庫は食い違う?</a:t>
             </a:r>
           </a:p>
         </p:txBody>
@@ -3257,7 +3207,7 @@
           <p:cNvPr id="8" name="">
             <a:extLst xmlns:a="http://schemas.openxmlformats.org/drawingml/2006/main">
               <a:ext uri="{FF2B5EF4-FFF2-40B4-BE49-F238E27FC236}">
-                <a16:creationId xmlns:a16="http://schemas.microsoft.com/office/drawing/2014/main" id="{621F867A-354F-4F30-BF6F-F1158AE2967C}"/>
+                <a16:creationId xmlns:a16="http://schemas.microsoft.com/office/drawing/2014/main" id="{C5CA57EA-0546-4987-8336-EABCB9BF2AD0}"/>
               </a:ext>
             </a:extLst>
           </p:cNvPr>
@@ -3297,7 +3247,7 @@
                   <a:srgbClr val="52615B"/>
                 </a:solidFill>
               </a:rPr>
-              <a:t>顧客支払額が下がりRetailer利益が減ります。Supplier cost priceは変わりません。</a:t>
+              <a:t>一時的にはありえます。Shopify checkoutはSupplier在庫を確認しますが、手動注文は例外です。</a:t>
             </a:r>
           </a:p>
         </p:txBody>
@@ -3307,7 +3257,7 @@
           <p:cNvPr id="9" name="">
             <a:extLst xmlns:a="http://schemas.openxmlformats.org/drawingml/2006/main">
               <a:ext uri="{FF2B5EF4-FFF2-40B4-BE49-F238E27FC236}">
-                <a16:creationId xmlns:a16="http://schemas.microsoft.com/office/drawing/2014/main" id="{CD6627F6-4D39-457D-940D-CEF6A751FE6E}"/>
+                <a16:creationId xmlns:a16="http://schemas.microsoft.com/office/drawing/2014/main" id="{96682655-CF5A-4C1C-AC1F-C202DED9FEA4}"/>
               </a:ext>
             </a:extLst>
           </p:cNvPr>
@@ -3347,7 +3297,7 @@
                   <a:srgbClr val="004C3F"/>
                 </a:solidFill>
               </a:rPr>
-              <a:t>入金額と注文金額は一致?</a:t>
+              <a:t>商品マスターはSupplier側必須?</a:t>
             </a:r>
           </a:p>
         </p:txBody>
@@ -3357,7 +3307,7 @@
           <p:cNvPr id="10" name="">
             <a:extLst xmlns:a="http://schemas.openxmlformats.org/drawingml/2006/main">
               <a:ext uri="{FF2B5EF4-FFF2-40B4-BE49-F238E27FC236}">
-                <a16:creationId xmlns:a16="http://schemas.microsoft.com/office/drawing/2014/main" id="{411D801D-4114-402E-8CEB-7CAE01C8A4FA}"/>
+                <a16:creationId xmlns:a16="http://schemas.microsoft.com/office/drawing/2014/main" id="{B7320747-B6A2-4A0A-9727-B2040260E4E2}"/>
               </a:ext>
             </a:extLst>
           </p:cNvPr>
@@ -3397,7 +3347,7 @@
                   <a:srgbClr val="52615B"/>
                 </a:solidFill>
               </a:rPr>
-              <a:t>銀行入金として一対一とは限りません。複数支払い、返金、返品、reversal、税、送料、タイミングの影響を受けます。</a:t>
+              <a:t>Collectiveで共有する商品はSupplierのShopifyストアに存在し、Collectiveへ公開される必要があります。上流はERP/PIMでも構いません。</a:t>
             </a:r>
           </a:p>
         </p:txBody>
@@ -3407,7 +3357,7 @@
           <p:cNvPr id="11" name="">
             <a:extLst xmlns:a="http://schemas.openxmlformats.org/drawingml/2006/main">
               <a:ext uri="{FF2B5EF4-FFF2-40B4-BE49-F238E27FC236}">
-                <a16:creationId xmlns:a16="http://schemas.microsoft.com/office/drawing/2014/main" id="{6E2EAFF8-0D50-405E-B5E7-29835D941634}"/>
+                <a16:creationId xmlns:a16="http://schemas.microsoft.com/office/drawing/2014/main" id="{8D310D53-D564-4270-89C5-4B64CA24A09B}"/>
               </a:ext>
             </a:extLst>
           </p:cNvPr>
@@ -3447,7 +3397,7 @@
                   <a:srgbClr val="004C3F"/>
                 </a:solidFill>
               </a:rPr>
-              <a:t>どこで照合する?</a:t>
+              <a:t>Supplier変更時は?</a:t>
             </a:r>
           </a:p>
         </p:txBody>
@@ -3457,7 +3407,7 @@
           <p:cNvPr id="12" name="">
             <a:extLst xmlns:a="http://schemas.openxmlformats.org/drawingml/2006/main">
               <a:ext uri="{FF2B5EF4-FFF2-40B4-BE49-F238E27FC236}">
-                <a16:creationId xmlns:a16="http://schemas.microsoft.com/office/drawing/2014/main" id="{67BAEE5E-C82F-408F-8F72-997DD015C51C}"/>
+                <a16:creationId xmlns:a16="http://schemas.microsoft.com/office/drawing/2014/main" id="{0F40BB7B-13F6-4E41-9D3A-2B36801DE1A7}"/>
               </a:ext>
             </a:extLst>
           </p:cNvPr>
@@ -3497,7 +3447,7 @@
                   <a:srgbClr val="52615B"/>
                 </a:solidFill>
               </a:rPr>
-              <a:t>Supplier注文、Retailer注文notes/custom attributes、associated orderのShopify Payments adjustmentsを使います。</a:t>
+              <a:t>在庫とcost priceは同期されます。その他の商品情報は設定次第です。Retailer側の外部連携は商品Webhookで追従します。</a:t>
             </a:r>
           </a:p>
         </p:txBody>
@@ -3507,7 +3457,7 @@
           <p:cNvPr id="13" name="">
             <a:extLst xmlns:a="http://schemas.openxmlformats.org/drawingml/2006/main">
               <a:ext uri="{FF2B5EF4-FFF2-40B4-BE49-F238E27FC236}">
-                <a16:creationId xmlns:a16="http://schemas.microsoft.com/office/drawing/2014/main" id="{AAC83073-DAF5-4DF5-8D71-C80EDAAF0602}"/>
+                <a16:creationId xmlns:a16="http://schemas.microsoft.com/office/drawing/2014/main" id="{C17744A7-B9E2-4719-BFF4-BF541D494FD1}"/>
               </a:ext>
             </a:extLst>
           </p:cNvPr>
@@ -3538,7 +3488,7 @@
           <p:cNvPr id="14" name="">
             <a:extLst xmlns:a="http://schemas.openxmlformats.org/drawingml/2006/main">
               <a:ext uri="{FF2B5EF4-FFF2-40B4-BE49-F238E27FC236}">
-                <a16:creationId xmlns:a16="http://schemas.microsoft.com/office/drawing/2014/main" id="{9A49AF91-EB1C-4132-9261-401288BF88E8}"/>
+                <a16:creationId xmlns:a16="http://schemas.microsoft.com/office/drawing/2014/main" id="{8294CBD3-F0B2-4DF4-8B8C-A020A87930D7}"/>
               </a:ext>
             </a:extLst>
           </p:cNvPr>
@@ -3550,7 +3500,7 @@
         <p:spPr>
           <a:xfrm xmlns:a="http://schemas.openxmlformats.org/drawingml/2006/main">
             <a:off x="609600" y="6419850"/>
-            <a:ext cx="7810500" cy="209550"/>
+            <a:ext cx="4000500" cy="209550"/>
           </a:xfrm>
           <a:prstGeom xmlns:a="http://schemas.openxmlformats.org/drawingml/2006/main" prst="rect">
             <a:avLst/>
@@ -3578,7 +3528,7 @@
                   <a:srgbClr val="52615B"/>
                 </a:solidFill>
               </a:rPr>
-              <a:t>非公式資料 | Source: products/shopify-collective/architecture.md</a:t>
+              <a:t>Shopify Collective</a:t>
             </a:r>
           </a:p>
         </p:txBody>
@@ -3588,7 +3538,7 @@
           <p:cNvPr id="15" name="">
             <a:extLst xmlns:a="http://schemas.openxmlformats.org/drawingml/2006/main">
               <a:ext uri="{FF2B5EF4-FFF2-40B4-BE49-F238E27FC236}">
-                <a16:creationId xmlns:a16="http://schemas.microsoft.com/office/drawing/2014/main" id="{F4CAB04F-0196-4F7A-8290-6B00596F5E9B}"/>
+                <a16:creationId xmlns:a16="http://schemas.microsoft.com/office/drawing/2014/main" id="{E21DE1F1-6130-4423-8134-8A302338425E}"/>
               </a:ext>
             </a:extLst>
           </p:cNvPr>
@@ -3636,7 +3586,7 @@
     </p:spTree>
     <p:extLst>
       <p:ext uri="{BB962C8B-B14F-4D97-AF65-F5344CB8AC3E}">
-        <p14:creationId xmlns:p14="http://schemas.microsoft.com/office/powerpoint/2010/main" val="1591350443"/>
+        <p14:creationId xmlns:p14="http://schemas.microsoft.com/office/powerpoint/2010/main" val="1804768431"/>
       </p:ext>
     </p:extLst>
   </p:cSld>
@@ -3667,7 +3617,7 @@
           <p:cNvPr id="1" name="">
             <a:extLst xmlns:a="http://schemas.openxmlformats.org/drawingml/2006/main">
               <a:ext uri="{FF2B5EF4-FFF2-40B4-BE49-F238E27FC236}">
-                <a16:creationId xmlns:a16="http://schemas.microsoft.com/office/drawing/2014/main" id="{090DF722-5297-4BA8-9552-40BCC10D8540}"/>
+                <a16:creationId xmlns:a16="http://schemas.microsoft.com/office/drawing/2014/main" id="{48F3E185-9F68-4093-9AEB-DEC6F3C208F4}"/>
               </a:ext>
             </a:extLst>
           </p:cNvPr>
@@ -3707,7 +3657,7 @@
                   <a:srgbClr val="004C3F"/>
                 </a:solidFill>
               </a:rPr>
-              <a:t>11 | 利用上の注意</a:t>
+              <a:t>11 | FAQ: Retailer変更</a:t>
             </a:r>
           </a:p>
         </p:txBody>
@@ -3717,7 +3667,7 @@
           <p:cNvPr id="2" name="">
             <a:extLst xmlns:a="http://schemas.openxmlformats.org/drawingml/2006/main">
               <a:ext uri="{FF2B5EF4-FFF2-40B4-BE49-F238E27FC236}">
-                <a16:creationId xmlns:a16="http://schemas.microsoft.com/office/drawing/2014/main" id="{6D5328A4-BFA8-4ECA-9C9C-C9EC24B3610D}"/>
+                <a16:creationId xmlns:a16="http://schemas.microsoft.com/office/drawing/2014/main" id="{4EBF0DF5-EB9A-48A0-BFD2-EBA4BF9F0B43}"/>
               </a:ext>
             </a:extLst>
           </p:cNvPr>
@@ -3757,7 +3707,7 @@
                   <a:srgbClr val="101820"/>
                 </a:solidFill>
               </a:rPr>
-              <a:t>このPPTXは公式資料ではなく、理解補助です</a:t>
+              <a:t>Retailer側の変更はSupplierマスターを更新しない</a:t>
             </a:r>
           </a:p>
         </p:txBody>
@@ -3767,7 +3717,7 @@
           <p:cNvPr id="3" name="">
             <a:extLst xmlns:a="http://schemas.openxmlformats.org/drawingml/2006/main">
               <a:ext uri="{FF2B5EF4-FFF2-40B4-BE49-F238E27FC236}">
-                <a16:creationId xmlns:a16="http://schemas.microsoft.com/office/drawing/2014/main" id="{441E1C13-7CD1-4CAB-A67E-D3576AB528AF}"/>
+                <a16:creationId xmlns:a16="http://schemas.microsoft.com/office/drawing/2014/main" id="{B3119D9B-D16F-444C-B6F8-54C5818B7257}"/>
               </a:ext>
             </a:extLst>
           </p:cNvPr>
@@ -3807,7 +3757,7 @@
                   <a:srgbClr val="52615B"/>
                 </a:solidFill>
               </a:rPr>
-              <a:t>このリポジトリではMarkdownソースを正とします。</a:t>
+              <a:t>RetailerストアのWebhookはRetailer側イベントとして扱い、Supplierの元商品変更とは区別します。</a:t>
             </a:r>
           </a:p>
         </p:txBody>
@@ -3817,7 +3767,7 @@
           <p:cNvPr id="4" name="">
             <a:extLst xmlns:a="http://schemas.openxmlformats.org/drawingml/2006/main">
               <a:ext uri="{FF2B5EF4-FFF2-40B4-BE49-F238E27FC236}">
-                <a16:creationId xmlns:a16="http://schemas.microsoft.com/office/drawing/2014/main" id="{62F1163D-4978-4924-9FED-7783988A491C}"/>
+                <a16:creationId xmlns:a16="http://schemas.microsoft.com/office/drawing/2014/main" id="{948615C6-E3F7-41B2-BC78-C308081928BE}"/>
               </a:ext>
             </a:extLst>
           </p:cNvPr>
@@ -3848,53 +3798,47 @@
           <p:cNvPr id="5" name="">
             <a:extLst xmlns:a="http://schemas.openxmlformats.org/drawingml/2006/main">
               <a:ext uri="{FF2B5EF4-FFF2-40B4-BE49-F238E27FC236}">
-                <a16:creationId xmlns:a16="http://schemas.microsoft.com/office/drawing/2014/main" id="{CF1DD97E-D4C8-4307-8C03-8AEF60D44BE4}"/>
-              </a:ext>
-            </a:extLst>
-          </p:cNvPr>
-          <p:cNvSpPr>
-            <a:spLocks xmlns:a="http://schemas.openxmlformats.org/drawingml/2006/main" noGrp="1"/>
-          </p:cNvSpPr>
-          <p:nvPr/>
-        </p:nvSpPr>
-        <p:spPr>
-          <a:xfrm xmlns:a="http://schemas.openxmlformats.org/drawingml/2006/main">
-            <a:off x="609600" y="2781300"/>
-            <a:ext cx="5143500" cy="2476500"/>
-          </a:xfrm>
-          <a:prstGeom xmlns:a="http://schemas.openxmlformats.org/drawingml/2006/main" prst="roundRect">
-            <a:avLst>
-              <a:gd name="adj" fmla="val 3077"/>
-            </a:avLst>
-          </a:prstGeom>
-          <a:solidFill xmlns:a="http://schemas.openxmlformats.org/drawingml/2006/main">
-            <a:srgbClr val="E9F7EF"/>
-          </a:solidFill>
-          <a:ln xmlns:a="http://schemas.openxmlformats.org/drawingml/2006/main" w="9525">
-            <a:solidFill>
-              <a:srgbClr val="A6DFC0"/>
-            </a:solidFill>
-            <a:prstDash val="solid"/>
-          </a:ln>
-        </p:spPr>
-        <p:txBody>
-          <a:bodyPr xmlns:a="http://schemas.openxmlformats.org/drawingml/2006/main"/>
-          <a:lstStyle xmlns:a="http://schemas.openxmlformats.org/drawingml/2006/main"/>
-          <a:p xmlns:a="http://schemas.openxmlformats.org/drawingml/2006/main">
-            <a:pPr algn="ctr">
-              <a:defRPr sz="1950" b="1">
+                <a16:creationId xmlns:a16="http://schemas.microsoft.com/office/drawing/2014/main" id="{34579E86-61BE-4960-A641-28A343D2380B}"/>
+              </a:ext>
+            </a:extLst>
+          </p:cNvPr>
+          <p:cNvSpPr>
+            <a:spLocks xmlns:a="http://schemas.openxmlformats.org/drawingml/2006/main" noGrp="1"/>
+          </p:cNvSpPr>
+          <p:nvPr/>
+        </p:nvSpPr>
+        <p:spPr>
+          <a:xfrm xmlns:a="http://schemas.openxmlformats.org/drawingml/2006/main">
+            <a:off x="609600" y="2724150"/>
+            <a:ext cx="4953000" cy="361950"/>
+          </a:xfrm>
+          <a:prstGeom xmlns:a="http://schemas.openxmlformats.org/drawingml/2006/main" prst="rect">
+            <a:avLst/>
+          </a:prstGeom>
+          <a:noFill xmlns:a="http://schemas.openxmlformats.org/drawingml/2006/main"/>
+          <a:ln xmlns:a="http://schemas.openxmlformats.org/drawingml/2006/main" w="0">
+            <a:noFill/>
+            <a:prstDash val="solid"/>
+          </a:ln>
+        </p:spPr>
+        <p:txBody>
+          <a:bodyPr xmlns:a="http://schemas.openxmlformats.org/drawingml/2006/main"/>
+          <a:lstStyle xmlns:a="http://schemas.openxmlformats.org/drawingml/2006/main"/>
+          <a:p xmlns:a="http://schemas.openxmlformats.org/drawingml/2006/main">
+            <a:pPr algn="l">
+              <a:defRPr sz="1350" b="1">
                 <a:solidFill>
                   <a:srgbClr val="004C3F"/>
                 </a:solidFill>
               </a:defRPr>
             </a:pPr>
             <a:r>
-              <a:rPr sz="1950" b="1">
+              <a:rPr sz="1350" b="1">
                 <a:solidFill>
                   <a:srgbClr val="004C3F"/>
                 </a:solidFill>
               </a:rPr>
-              <a:t>Source of truth</a:t>
+              <a:t>Retailerが商品を変更したら?</a:t>
             </a:r>
           </a:p>
         </p:txBody>
@@ -3904,47 +3848,47 @@
           <p:cNvPr id="6" name="">
             <a:extLst xmlns:a="http://schemas.openxmlformats.org/drawingml/2006/main">
               <a:ext uri="{FF2B5EF4-FFF2-40B4-BE49-F238E27FC236}">
-                <a16:creationId xmlns:a16="http://schemas.microsoft.com/office/drawing/2014/main" id="{C938C02F-06AF-46B9-A332-C5F258362143}"/>
-              </a:ext>
-            </a:extLst>
-          </p:cNvPr>
-          <p:cNvSpPr>
-            <a:spLocks xmlns:a="http://schemas.openxmlformats.org/drawingml/2006/main" noGrp="1"/>
-          </p:cNvSpPr>
-          <p:nvPr/>
-        </p:nvSpPr>
-        <p:spPr>
-          <a:xfrm xmlns:a="http://schemas.openxmlformats.org/drawingml/2006/main">
-            <a:off x="990600" y="3657600"/>
-            <a:ext cx="4381500" cy="1123950"/>
-          </a:xfrm>
-          <a:prstGeom xmlns:a="http://schemas.openxmlformats.org/drawingml/2006/main" prst="rect">
-            <a:avLst/>
-          </a:prstGeom>
-          <a:noFill xmlns:a="http://schemas.openxmlformats.org/drawingml/2006/main"/>
-          <a:ln xmlns:a="http://schemas.openxmlformats.org/drawingml/2006/main" w="0">
-            <a:noFill/>
-            <a:prstDash val="solid"/>
-          </a:ln>
-        </p:spPr>
-        <p:txBody>
-          <a:bodyPr xmlns:a="http://schemas.openxmlformats.org/drawingml/2006/main"/>
-          <a:lstStyle xmlns:a="http://schemas.openxmlformats.org/drawingml/2006/main"/>
-          <a:p xmlns:a="http://schemas.openxmlformats.org/drawingml/2006/main">
-            <a:pPr algn="ctr">
-              <a:defRPr sz="1500" b="0">
-                <a:solidFill>
-                  <a:srgbClr val="101820"/>
-                </a:solidFill>
-              </a:defRPr>
-            </a:pPr>
-            <a:r>
-              <a:rPr sz="1500" b="0">
-                <a:solidFill>
-                  <a:srgbClr val="101820"/>
-                </a:solidFill>
-              </a:rPr>
-              <a:t>products/shopify-collective/architecture.md に英語ソースと参照リンクを保持します。</a:t>
+                <a16:creationId xmlns:a16="http://schemas.microsoft.com/office/drawing/2014/main" id="{0F77266C-43A4-471A-B93D-7771B40E8F0F}"/>
+              </a:ext>
+            </a:extLst>
+          </p:cNvPr>
+          <p:cNvSpPr>
+            <a:spLocks xmlns:a="http://schemas.openxmlformats.org/drawingml/2006/main" noGrp="1"/>
+          </p:cNvSpPr>
+          <p:nvPr/>
+        </p:nvSpPr>
+        <p:spPr>
+          <a:xfrm xmlns:a="http://schemas.openxmlformats.org/drawingml/2006/main">
+            <a:off x="609600" y="3124200"/>
+            <a:ext cx="4953000" cy="552450"/>
+          </a:xfrm>
+          <a:prstGeom xmlns:a="http://schemas.openxmlformats.org/drawingml/2006/main" prst="rect">
+            <a:avLst/>
+          </a:prstGeom>
+          <a:noFill xmlns:a="http://schemas.openxmlformats.org/drawingml/2006/main"/>
+          <a:ln xmlns:a="http://schemas.openxmlformats.org/drawingml/2006/main" w="0">
+            <a:noFill/>
+            <a:prstDash val="solid"/>
+          </a:ln>
+        </p:spPr>
+        <p:txBody>
+          <a:bodyPr xmlns:a="http://schemas.openxmlformats.org/drawingml/2006/main"/>
+          <a:lstStyle xmlns:a="http://schemas.openxmlformats.org/drawingml/2006/main"/>
+          <a:p xmlns:a="http://schemas.openxmlformats.org/drawingml/2006/main">
+            <a:pPr algn="l">
+              <a:defRPr sz="1088" b="0">
+                <a:solidFill>
+                  <a:srgbClr val="52615B"/>
+                </a:solidFill>
+              </a:defRPr>
+            </a:pPr>
+            <a:r>
+              <a:rPr sz="1088" b="0">
+                <a:solidFill>
+                  <a:srgbClr val="52615B"/>
+                </a:solidFill>
+              </a:rPr>
+              <a:t>Retailer編集はSupplierの元商品を更新しません。Supplier管理フィールドはSupplier側が管理します。</a:t>
             </a:r>
           </a:p>
         </p:txBody>
@@ -3954,53 +3898,47 @@
           <p:cNvPr id="7" name="">
             <a:extLst xmlns:a="http://schemas.openxmlformats.org/drawingml/2006/main">
               <a:ext uri="{FF2B5EF4-FFF2-40B4-BE49-F238E27FC236}">
-                <a16:creationId xmlns:a16="http://schemas.microsoft.com/office/drawing/2014/main" id="{4B7DF8FD-027B-49F7-9D5E-2E27B1860834}"/>
-              </a:ext>
-            </a:extLst>
-          </p:cNvPr>
-          <p:cNvSpPr>
-            <a:spLocks xmlns:a="http://schemas.openxmlformats.org/drawingml/2006/main" noGrp="1"/>
-          </p:cNvSpPr>
-          <p:nvPr/>
-        </p:nvSpPr>
-        <p:spPr>
-          <a:xfrm xmlns:a="http://schemas.openxmlformats.org/drawingml/2006/main">
-            <a:off x="6438900" y="2781300"/>
-            <a:ext cx="5143500" cy="2476500"/>
-          </a:xfrm>
-          <a:prstGeom xmlns:a="http://schemas.openxmlformats.org/drawingml/2006/main" prst="roundRect">
-            <a:avLst>
-              <a:gd name="adj" fmla="val 3077"/>
-            </a:avLst>
-          </a:prstGeom>
-          <a:solidFill xmlns:a="http://schemas.openxmlformats.org/drawingml/2006/main">
-            <a:srgbClr val="FFF7E6"/>
-          </a:solidFill>
-          <a:ln xmlns:a="http://schemas.openxmlformats.org/drawingml/2006/main" w="9525">
-            <a:solidFill>
-              <a:srgbClr val="F6C979"/>
-            </a:solidFill>
-            <a:prstDash val="solid"/>
-          </a:ln>
-        </p:spPr>
-        <p:txBody>
-          <a:bodyPr xmlns:a="http://schemas.openxmlformats.org/drawingml/2006/main"/>
-          <a:lstStyle xmlns:a="http://schemas.openxmlformats.org/drawingml/2006/main"/>
-          <a:p xmlns:a="http://schemas.openxmlformats.org/drawingml/2006/main">
-            <a:pPr algn="ctr">
-              <a:defRPr sz="1950" b="1">
-                <a:solidFill>
-                  <a:srgbClr val="D97706"/>
-                </a:solidFill>
-              </a:defRPr>
-            </a:pPr>
-            <a:r>
-              <a:rPr sz="1950" b="1">
-                <a:solidFill>
-                  <a:srgbClr val="D97706"/>
-                </a:solidFill>
-              </a:rPr>
-              <a:t>Disclaimer</a:t>
+                <a16:creationId xmlns:a16="http://schemas.microsoft.com/office/drawing/2014/main" id="{B86C2FE8-AC67-49DA-A959-05E03E77A450}"/>
+              </a:ext>
+            </a:extLst>
+          </p:cNvPr>
+          <p:cNvSpPr>
+            <a:spLocks xmlns:a="http://schemas.openxmlformats.org/drawingml/2006/main" noGrp="1"/>
+          </p:cNvSpPr>
+          <p:nvPr/>
+        </p:nvSpPr>
+        <p:spPr>
+          <a:xfrm xmlns:a="http://schemas.openxmlformats.org/drawingml/2006/main">
+            <a:off x="6305550" y="2724150"/>
+            <a:ext cx="4953000" cy="361950"/>
+          </a:xfrm>
+          <a:prstGeom xmlns:a="http://schemas.openxmlformats.org/drawingml/2006/main" prst="rect">
+            <a:avLst/>
+          </a:prstGeom>
+          <a:noFill xmlns:a="http://schemas.openxmlformats.org/drawingml/2006/main"/>
+          <a:ln xmlns:a="http://schemas.openxmlformats.org/drawingml/2006/main" w="0">
+            <a:noFill/>
+            <a:prstDash val="solid"/>
+          </a:ln>
+        </p:spPr>
+        <p:txBody>
+          <a:bodyPr xmlns:a="http://schemas.openxmlformats.org/drawingml/2006/main"/>
+          <a:lstStyle xmlns:a="http://schemas.openxmlformats.org/drawingml/2006/main"/>
+          <a:p xmlns:a="http://schemas.openxmlformats.org/drawingml/2006/main">
+            <a:pPr algn="l">
+              <a:defRPr sz="1350" b="1">
+                <a:solidFill>
+                  <a:srgbClr val="004C3F"/>
+                </a:solidFill>
+              </a:defRPr>
+            </a:pPr>
+            <a:r>
+              <a:rPr sz="1350" b="1">
+                <a:solidFill>
+                  <a:srgbClr val="004C3F"/>
+                </a:solidFill>
+              </a:rPr>
+              <a:t>Retailerが価格を変更したら?</a:t>
             </a:r>
           </a:p>
         </p:txBody>
@@ -4010,47 +3948,47 @@
           <p:cNvPr id="8" name="">
             <a:extLst xmlns:a="http://schemas.openxmlformats.org/drawingml/2006/main">
               <a:ext uri="{FF2B5EF4-FFF2-40B4-BE49-F238E27FC236}">
-                <a16:creationId xmlns:a16="http://schemas.microsoft.com/office/drawing/2014/main" id="{77A037B0-0574-4AAA-9233-DC2FB378CB62}"/>
-              </a:ext>
-            </a:extLst>
-          </p:cNvPr>
-          <p:cNvSpPr>
-            <a:spLocks xmlns:a="http://schemas.openxmlformats.org/drawingml/2006/main" noGrp="1"/>
-          </p:cNvSpPr>
-          <p:nvPr/>
-        </p:nvSpPr>
-        <p:spPr>
-          <a:xfrm xmlns:a="http://schemas.openxmlformats.org/drawingml/2006/main">
-            <a:off x="6819900" y="3657600"/>
-            <a:ext cx="4381500" cy="1123950"/>
-          </a:xfrm>
-          <a:prstGeom xmlns:a="http://schemas.openxmlformats.org/drawingml/2006/main" prst="rect">
-            <a:avLst/>
-          </a:prstGeom>
-          <a:noFill xmlns:a="http://schemas.openxmlformats.org/drawingml/2006/main"/>
-          <a:ln xmlns:a="http://schemas.openxmlformats.org/drawingml/2006/main" w="0">
-            <a:noFill/>
-            <a:prstDash val="solid"/>
-          </a:ln>
-        </p:spPr>
-        <p:txBody>
-          <a:bodyPr xmlns:a="http://schemas.openxmlformats.org/drawingml/2006/main"/>
-          <a:lstStyle xmlns:a="http://schemas.openxmlformats.org/drawingml/2006/main"/>
-          <a:p xmlns:a="http://schemas.openxmlformats.org/drawingml/2006/main">
-            <a:pPr algn="ctr">
-              <a:defRPr sz="1500" b="0">
-                <a:solidFill>
-                  <a:srgbClr val="101820"/>
-                </a:solidFill>
-              </a:defRPr>
-            </a:pPr>
-            <a:r>
-              <a:rPr sz="1500" b="0">
-                <a:solidFill>
-                  <a:srgbClr val="101820"/>
-                </a:solidFill>
-              </a:rPr>
-              <a:t>Shopify公式ドキュメントではありません。実装判断はShopify docsとストア挙動で確認してください。</a:t>
+                <a16:creationId xmlns:a16="http://schemas.microsoft.com/office/drawing/2014/main" id="{3E74FC66-89E4-4980-AB1D-296C5E7301EC}"/>
+              </a:ext>
+            </a:extLst>
+          </p:cNvPr>
+          <p:cNvSpPr>
+            <a:spLocks xmlns:a="http://schemas.openxmlformats.org/drawingml/2006/main" noGrp="1"/>
+          </p:cNvSpPr>
+          <p:nvPr/>
+        </p:nvSpPr>
+        <p:spPr>
+          <a:xfrm xmlns:a="http://schemas.openxmlformats.org/drawingml/2006/main">
+            <a:off x="6305550" y="3124200"/>
+            <a:ext cx="4953000" cy="552450"/>
+          </a:xfrm>
+          <a:prstGeom xmlns:a="http://schemas.openxmlformats.org/drawingml/2006/main" prst="rect">
+            <a:avLst/>
+          </a:prstGeom>
+          <a:noFill xmlns:a="http://schemas.openxmlformats.org/drawingml/2006/main"/>
+          <a:ln xmlns:a="http://schemas.openxmlformats.org/drawingml/2006/main" w="0">
+            <a:noFill/>
+            <a:prstDash val="solid"/>
+          </a:ln>
+        </p:spPr>
+        <p:txBody>
+          <a:bodyPr xmlns:a="http://schemas.openxmlformats.org/drawingml/2006/main"/>
+          <a:lstStyle xmlns:a="http://schemas.openxmlformats.org/drawingml/2006/main"/>
+          <a:p xmlns:a="http://schemas.openxmlformats.org/drawingml/2006/main">
+            <a:pPr algn="l">
+              <a:defRPr sz="1088" b="0">
+                <a:solidFill>
+                  <a:srgbClr val="52615B"/>
+                </a:solidFill>
+              </a:defRPr>
+            </a:pPr>
+            <a:r>
+              <a:rPr sz="1088" b="0">
+                <a:solidFill>
+                  <a:srgbClr val="52615B"/>
+                </a:solidFill>
+              </a:rPr>
+              <a:t>Retail price syncがOFFならRetailerがretail priceを管理できます。Supplier cost priceはSupplier管理です。</a:t>
             </a:r>
           </a:p>
         </p:txBody>
@@ -4060,47 +3998,47 @@
           <p:cNvPr id="9" name="">
             <a:extLst xmlns:a="http://schemas.openxmlformats.org/drawingml/2006/main">
               <a:ext uri="{FF2B5EF4-FFF2-40B4-BE49-F238E27FC236}">
-                <a16:creationId xmlns:a16="http://schemas.microsoft.com/office/drawing/2014/main" id="{D558A5AD-F3A0-44A0-9068-FD7FB50A2C95}"/>
-              </a:ext>
-            </a:extLst>
-          </p:cNvPr>
-          <p:cNvSpPr>
-            <a:spLocks xmlns:a="http://schemas.openxmlformats.org/drawingml/2006/main" noGrp="1"/>
-          </p:cNvSpPr>
-          <p:nvPr/>
-        </p:nvSpPr>
-        <p:spPr>
-          <a:xfrm xmlns:a="http://schemas.openxmlformats.org/drawingml/2006/main">
-            <a:off x="1143000" y="5657850"/>
-            <a:ext cx="9906000" cy="323850"/>
-          </a:xfrm>
-          <a:prstGeom xmlns:a="http://schemas.openxmlformats.org/drawingml/2006/main" prst="rect">
-            <a:avLst/>
-          </a:prstGeom>
-          <a:noFill xmlns:a="http://schemas.openxmlformats.org/drawingml/2006/main"/>
-          <a:ln xmlns:a="http://schemas.openxmlformats.org/drawingml/2006/main" w="0">
-            <a:noFill/>
-            <a:prstDash val="solid"/>
-          </a:ln>
-        </p:spPr>
-        <p:txBody>
-          <a:bodyPr xmlns:a="http://schemas.openxmlformats.org/drawingml/2006/main"/>
-          <a:lstStyle xmlns:a="http://schemas.openxmlformats.org/drawingml/2006/main"/>
-          <a:p xmlns:a="http://schemas.openxmlformats.org/drawingml/2006/main">
-            <a:pPr algn="ctr">
-              <a:defRPr sz="1350" b="0">
-                <a:solidFill>
-                  <a:srgbClr val="52615B"/>
-                </a:solidFill>
-              </a:defRPr>
-            </a:pPr>
-            <a:r>
-              <a:rPr sz="1350" b="0">
-                <a:solidFill>
-                  <a:srgbClr val="52615B"/>
-                </a:solidFill>
-              </a:rPr>
-              <a:t>Source Markdownを変更したら、このPPTXも更新してください。</a:t>
+                <a16:creationId xmlns:a16="http://schemas.microsoft.com/office/drawing/2014/main" id="{51407CFE-5032-423F-8B94-9A8F9CEE8F21}"/>
+              </a:ext>
+            </a:extLst>
+          </p:cNvPr>
+          <p:cNvSpPr>
+            <a:spLocks xmlns:a="http://schemas.openxmlformats.org/drawingml/2006/main" noGrp="1"/>
+          </p:cNvSpPr>
+          <p:nvPr/>
+        </p:nvSpPr>
+        <p:spPr>
+          <a:xfrm xmlns:a="http://schemas.openxmlformats.org/drawingml/2006/main">
+            <a:off x="609600" y="3829050"/>
+            <a:ext cx="4953000" cy="361950"/>
+          </a:xfrm>
+          <a:prstGeom xmlns:a="http://schemas.openxmlformats.org/drawingml/2006/main" prst="rect">
+            <a:avLst/>
+          </a:prstGeom>
+          <a:noFill xmlns:a="http://schemas.openxmlformats.org/drawingml/2006/main"/>
+          <a:ln xmlns:a="http://schemas.openxmlformats.org/drawingml/2006/main" w="0">
+            <a:noFill/>
+            <a:prstDash val="solid"/>
+          </a:ln>
+        </p:spPr>
+        <p:txBody>
+          <a:bodyPr xmlns:a="http://schemas.openxmlformats.org/drawingml/2006/main"/>
+          <a:lstStyle xmlns:a="http://schemas.openxmlformats.org/drawingml/2006/main"/>
+          <a:p xmlns:a="http://schemas.openxmlformats.org/drawingml/2006/main">
+            <a:pPr algn="l">
+              <a:defRPr sz="1350" b="1">
+                <a:solidFill>
+                  <a:srgbClr val="004C3F"/>
+                </a:solidFill>
+              </a:defRPr>
+            </a:pPr>
+            <a:r>
+              <a:rPr sz="1350" b="1">
+                <a:solidFill>
+                  <a:srgbClr val="004C3F"/>
+                </a:solidFill>
+              </a:rPr>
+              <a:t>Retailerが在庫を変更したら?</a:t>
             </a:r>
           </a:p>
         </p:txBody>
@@ -4110,7 +4048,157 @@
           <p:cNvPr id="10" name="">
             <a:extLst xmlns:a="http://schemas.openxmlformats.org/drawingml/2006/main">
               <a:ext uri="{FF2B5EF4-FFF2-40B4-BE49-F238E27FC236}">
-                <a16:creationId xmlns:a16="http://schemas.microsoft.com/office/drawing/2014/main" id="{5EA2E960-9F28-4649-8184-95F14278426D}"/>
+                <a16:creationId xmlns:a16="http://schemas.microsoft.com/office/drawing/2014/main" id="{F38E8436-272F-4467-8078-B2866108F9FE}"/>
+              </a:ext>
+            </a:extLst>
+          </p:cNvPr>
+          <p:cNvSpPr>
+            <a:spLocks xmlns:a="http://schemas.openxmlformats.org/drawingml/2006/main" noGrp="1"/>
+          </p:cNvSpPr>
+          <p:nvPr/>
+        </p:nvSpPr>
+        <p:spPr>
+          <a:xfrm xmlns:a="http://schemas.openxmlformats.org/drawingml/2006/main">
+            <a:off x="609600" y="4229100"/>
+            <a:ext cx="4953000" cy="552450"/>
+          </a:xfrm>
+          <a:prstGeom xmlns:a="http://schemas.openxmlformats.org/drawingml/2006/main" prst="rect">
+            <a:avLst/>
+          </a:prstGeom>
+          <a:noFill xmlns:a="http://schemas.openxmlformats.org/drawingml/2006/main"/>
+          <a:ln xmlns:a="http://schemas.openxmlformats.org/drawingml/2006/main" w="0">
+            <a:noFill/>
+            <a:prstDash val="solid"/>
+          </a:ln>
+        </p:spPr>
+        <p:txBody>
+          <a:bodyPr xmlns:a="http://schemas.openxmlformats.org/drawingml/2006/main"/>
+          <a:lstStyle xmlns:a="http://schemas.openxmlformats.org/drawingml/2006/main"/>
+          <a:p xmlns:a="http://schemas.openxmlformats.org/drawingml/2006/main">
+            <a:pPr algn="l">
+              <a:defRPr sz="1088" b="0">
+                <a:solidFill>
+                  <a:srgbClr val="52615B"/>
+                </a:solidFill>
+              </a:defRPr>
+            </a:pPr>
+            <a:r>
+              <a:rPr sz="1088" b="0">
+                <a:solidFill>
+                  <a:srgbClr val="52615B"/>
+                </a:solidFill>
+              </a:rPr>
+              <a:t>インポートされたCollective在庫はSupplier管理で、Retailer adminでは読み取り専用です。</a:t>
+            </a:r>
+          </a:p>
+        </p:txBody>
+      </p:sp>
+      <p:sp>
+        <p:nvSpPr>
+          <p:cNvPr id="11" name="">
+            <a:extLst xmlns:a="http://schemas.openxmlformats.org/drawingml/2006/main">
+              <a:ext uri="{FF2B5EF4-FFF2-40B4-BE49-F238E27FC236}">
+                <a16:creationId xmlns:a16="http://schemas.microsoft.com/office/drawing/2014/main" id="{8FD73F45-19FD-425E-9408-AFAC0F655134}"/>
+              </a:ext>
+            </a:extLst>
+          </p:cNvPr>
+          <p:cNvSpPr>
+            <a:spLocks xmlns:a="http://schemas.openxmlformats.org/drawingml/2006/main" noGrp="1"/>
+          </p:cNvSpPr>
+          <p:nvPr/>
+        </p:nvSpPr>
+        <p:spPr>
+          <a:xfrm xmlns:a="http://schemas.openxmlformats.org/drawingml/2006/main">
+            <a:off x="6305550" y="3829050"/>
+            <a:ext cx="4953000" cy="361950"/>
+          </a:xfrm>
+          <a:prstGeom xmlns:a="http://schemas.openxmlformats.org/drawingml/2006/main" prst="rect">
+            <a:avLst/>
+          </a:prstGeom>
+          <a:noFill xmlns:a="http://schemas.openxmlformats.org/drawingml/2006/main"/>
+          <a:ln xmlns:a="http://schemas.openxmlformats.org/drawingml/2006/main" w="0">
+            <a:noFill/>
+            <a:prstDash val="solid"/>
+          </a:ln>
+        </p:spPr>
+        <p:txBody>
+          <a:bodyPr xmlns:a="http://schemas.openxmlformats.org/drawingml/2006/main"/>
+          <a:lstStyle xmlns:a="http://schemas.openxmlformats.org/drawingml/2006/main"/>
+          <a:p xmlns:a="http://schemas.openxmlformats.org/drawingml/2006/main">
+            <a:pPr algn="l">
+              <a:defRPr sz="1350" b="1">
+                <a:solidFill>
+                  <a:srgbClr val="004C3F"/>
+                </a:solidFill>
+              </a:defRPr>
+            </a:pPr>
+            <a:r>
+              <a:rPr sz="1350" b="1">
+                <a:solidFill>
+                  <a:srgbClr val="004C3F"/>
+                </a:solidFill>
+              </a:rPr>
+              <a:t>どのWebhookを見る?</a:t>
+            </a:r>
+          </a:p>
+        </p:txBody>
+      </p:sp>
+      <p:sp>
+        <p:nvSpPr>
+          <p:cNvPr id="12" name="">
+            <a:extLst xmlns:a="http://schemas.openxmlformats.org/drawingml/2006/main">
+              <a:ext uri="{FF2B5EF4-FFF2-40B4-BE49-F238E27FC236}">
+                <a16:creationId xmlns:a16="http://schemas.microsoft.com/office/drawing/2014/main" id="{687B81F8-DEE0-4743-ABE2-9A990651484A}"/>
+              </a:ext>
+            </a:extLst>
+          </p:cNvPr>
+          <p:cNvSpPr>
+            <a:spLocks xmlns:a="http://schemas.openxmlformats.org/drawingml/2006/main" noGrp="1"/>
+          </p:cNvSpPr>
+          <p:nvPr/>
+        </p:nvSpPr>
+        <p:spPr>
+          <a:xfrm xmlns:a="http://schemas.openxmlformats.org/drawingml/2006/main">
+            <a:off x="6305550" y="4229100"/>
+            <a:ext cx="4953000" cy="552450"/>
+          </a:xfrm>
+          <a:prstGeom xmlns:a="http://schemas.openxmlformats.org/drawingml/2006/main" prst="rect">
+            <a:avLst/>
+          </a:prstGeom>
+          <a:noFill xmlns:a="http://schemas.openxmlformats.org/drawingml/2006/main"/>
+          <a:ln xmlns:a="http://schemas.openxmlformats.org/drawingml/2006/main" w="0">
+            <a:noFill/>
+            <a:prstDash val="solid"/>
+          </a:ln>
+        </p:spPr>
+        <p:txBody>
+          <a:bodyPr xmlns:a="http://schemas.openxmlformats.org/drawingml/2006/main"/>
+          <a:lstStyle xmlns:a="http://schemas.openxmlformats.org/drawingml/2006/main"/>
+          <a:p xmlns:a="http://schemas.openxmlformats.org/drawingml/2006/main">
+            <a:pPr algn="l">
+              <a:defRPr sz="1088" b="0">
+                <a:solidFill>
+                  <a:srgbClr val="52615B"/>
+                </a:solidFill>
+              </a:defRPr>
+            </a:pPr>
+            <a:r>
+              <a:rPr sz="1088" b="0">
+                <a:solidFill>
+                  <a:srgbClr val="52615B"/>
+                </a:solidFill>
+              </a:rPr>
+              <a:t>商品変更、注文、返品・返金の各Webhookで外部システムへ同期します。</a:t>
+            </a:r>
+          </a:p>
+        </p:txBody>
+      </p:sp>
+      <p:sp>
+        <p:nvSpPr>
+          <p:cNvPr id="13" name="">
+            <a:extLst xmlns:a="http://schemas.openxmlformats.org/drawingml/2006/main">
+              <a:ext uri="{FF2B5EF4-FFF2-40B4-BE49-F238E27FC236}">
+                <a16:creationId xmlns:a16="http://schemas.microsoft.com/office/drawing/2014/main" id="{E7EEFBDD-D79A-4C93-B72E-820041B5D6F1}"/>
               </a:ext>
             </a:extLst>
           </p:cNvPr>
@@ -4138,10 +4226,10 @@
       </p:sp>
       <p:sp>
         <p:nvSpPr>
-          <p:cNvPr id="11" name="">
-            <a:extLst xmlns:a="http://schemas.openxmlformats.org/drawingml/2006/main">
-              <a:ext uri="{FF2B5EF4-FFF2-40B4-BE49-F238E27FC236}">
-                <a16:creationId xmlns:a16="http://schemas.microsoft.com/office/drawing/2014/main" id="{F4FB51C7-FB01-48DC-911C-90C17E780ECE}"/>
+          <p:cNvPr id="14" name="">
+            <a:extLst xmlns:a="http://schemas.openxmlformats.org/drawingml/2006/main">
+              <a:ext uri="{FF2B5EF4-FFF2-40B4-BE49-F238E27FC236}">
+                <a16:creationId xmlns:a16="http://schemas.microsoft.com/office/drawing/2014/main" id="{1564EFFD-0F92-4592-A067-62AA5CE3CCE2}"/>
               </a:ext>
             </a:extLst>
           </p:cNvPr>
@@ -4153,7 +4241,7 @@
         <p:spPr>
           <a:xfrm xmlns:a="http://schemas.openxmlformats.org/drawingml/2006/main">
             <a:off x="609600" y="6419850"/>
-            <a:ext cx="7810500" cy="209550"/>
+            <a:ext cx="4000500" cy="209550"/>
           </a:xfrm>
           <a:prstGeom xmlns:a="http://schemas.openxmlformats.org/drawingml/2006/main" prst="rect">
             <a:avLst/>
@@ -4181,17 +4269,17 @@
                   <a:srgbClr val="52615B"/>
                 </a:solidFill>
               </a:rPr>
-              <a:t>非公式資料 | Source: products/shopify-collective/architecture.md</a:t>
-            </a:r>
-          </a:p>
-        </p:txBody>
-      </p:sp>
-      <p:sp>
-        <p:nvSpPr>
-          <p:cNvPr id="12" name="">
-            <a:extLst xmlns:a="http://schemas.openxmlformats.org/drawingml/2006/main">
-              <a:ext uri="{FF2B5EF4-FFF2-40B4-BE49-F238E27FC236}">
-                <a16:creationId xmlns:a16="http://schemas.microsoft.com/office/drawing/2014/main" id="{CB966F48-D9F5-4F60-A32A-153FD564F23D}"/>
+              <a:t>Shopify Collective</a:t>
+            </a:r>
+          </a:p>
+        </p:txBody>
+      </p:sp>
+      <p:sp>
+        <p:nvSpPr>
+          <p:cNvPr id="15" name="">
+            <a:extLst xmlns:a="http://schemas.openxmlformats.org/drawingml/2006/main">
+              <a:ext uri="{FF2B5EF4-FFF2-40B4-BE49-F238E27FC236}">
+                <a16:creationId xmlns:a16="http://schemas.microsoft.com/office/drawing/2014/main" id="{78B31163-8B5A-4A92-88E4-6DB0C90BD7BA}"/>
               </a:ext>
             </a:extLst>
           </p:cNvPr>
@@ -4239,7 +4327,7 @@
     </p:spTree>
     <p:extLst>
       <p:ext uri="{BB962C8B-B14F-4D97-AF65-F5344CB8AC3E}">
-        <p14:creationId xmlns:p14="http://schemas.microsoft.com/office/powerpoint/2010/main" val="187663738"/>
+        <p14:creationId xmlns:p14="http://schemas.microsoft.com/office/powerpoint/2010/main" val="1498199076"/>
       </p:ext>
     </p:extLst>
   </p:cSld>
@@ -4270,7 +4358,7 @@
           <p:cNvPr id="1" name="">
             <a:extLst xmlns:a="http://schemas.openxmlformats.org/drawingml/2006/main">
               <a:ext uri="{FF2B5EF4-FFF2-40B4-BE49-F238E27FC236}">
-                <a16:creationId xmlns:a16="http://schemas.microsoft.com/office/drawing/2014/main" id="{DC588304-2829-42DD-AA0F-DB872555DDF9}"/>
+                <a16:creationId xmlns:a16="http://schemas.microsoft.com/office/drawing/2014/main" id="{A4D334EB-2126-4053-BB06-EC0DD219131D}"/>
               </a:ext>
             </a:extLst>
           </p:cNvPr>
@@ -4320,7 +4408,7 @@
           <p:cNvPr id="2" name="">
             <a:extLst xmlns:a="http://schemas.openxmlformats.org/drawingml/2006/main">
               <a:ext uri="{FF2B5EF4-FFF2-40B4-BE49-F238E27FC236}">
-                <a16:creationId xmlns:a16="http://schemas.microsoft.com/office/drawing/2014/main" id="{20566736-7E30-4DB3-A93E-4C0E8BEDA227}"/>
+                <a16:creationId xmlns:a16="http://schemas.microsoft.com/office/drawing/2014/main" id="{010372C0-563E-4F8F-B829-77E720D78C83}"/>
               </a:ext>
             </a:extLst>
           </p:cNvPr>
@@ -4370,7 +4458,7 @@
           <p:cNvPr id="3" name="">
             <a:extLst xmlns:a="http://schemas.openxmlformats.org/drawingml/2006/main">
               <a:ext uri="{FF2B5EF4-FFF2-40B4-BE49-F238E27FC236}">
-                <a16:creationId xmlns:a16="http://schemas.microsoft.com/office/drawing/2014/main" id="{485B8AEB-C5BA-4A0F-991B-06D66F7CA938}"/>
+                <a16:creationId xmlns:a16="http://schemas.microsoft.com/office/drawing/2014/main" id="{30FB4C1E-EA7C-4CF9-8657-0ED7B9F5BB75}"/>
               </a:ext>
             </a:extLst>
           </p:cNvPr>
@@ -4420,7 +4508,7 @@
           <p:cNvPr id="4" name="">
             <a:extLst xmlns:a="http://schemas.openxmlformats.org/drawingml/2006/main">
               <a:ext uri="{FF2B5EF4-FFF2-40B4-BE49-F238E27FC236}">
-                <a16:creationId xmlns:a16="http://schemas.microsoft.com/office/drawing/2014/main" id="{D0A50781-B01A-48C1-A0A8-25458DE76DE6}"/>
+                <a16:creationId xmlns:a16="http://schemas.microsoft.com/office/drawing/2014/main" id="{F81FAE79-7C3B-4C60-973A-06FB629A2279}"/>
               </a:ext>
             </a:extLst>
           </p:cNvPr>
@@ -4451,7 +4539,7 @@
           <p:cNvPr id="5" name="">
             <a:extLst xmlns:a="http://schemas.openxmlformats.org/drawingml/2006/main">
               <a:ext uri="{FF2B5EF4-FFF2-40B4-BE49-F238E27FC236}">
-                <a16:creationId xmlns:a16="http://schemas.microsoft.com/office/drawing/2014/main" id="{3A4B888B-4783-4FCD-AB28-EE13BEC369A7}"/>
+                <a16:creationId xmlns:a16="http://schemas.microsoft.com/office/drawing/2014/main" id="{10B16318-07A2-4E07-93E2-BEDAF31273B2}"/>
               </a:ext>
             </a:extLst>
           </p:cNvPr>
@@ -4507,7 +4595,7 @@
           <p:cNvPr id="6" name="">
             <a:extLst xmlns:a="http://schemas.openxmlformats.org/drawingml/2006/main">
               <a:ext uri="{FF2B5EF4-FFF2-40B4-BE49-F238E27FC236}">
-                <a16:creationId xmlns:a16="http://schemas.microsoft.com/office/drawing/2014/main" id="{CDC9C62C-C991-499C-809A-C54D4F656FAB}"/>
+                <a16:creationId xmlns:a16="http://schemas.microsoft.com/office/drawing/2014/main" id="{41D18A2F-D0F7-4206-8B90-8AA19DE4490C}"/>
               </a:ext>
             </a:extLst>
           </p:cNvPr>
@@ -4557,7 +4645,7 @@
           <p:cNvPr id="7" name="">
             <a:extLst xmlns:a="http://schemas.openxmlformats.org/drawingml/2006/main">
               <a:ext uri="{FF2B5EF4-FFF2-40B4-BE49-F238E27FC236}">
-                <a16:creationId xmlns:a16="http://schemas.microsoft.com/office/drawing/2014/main" id="{7AA485C8-0AEC-4A6A-98A7-C70DC45A243E}"/>
+                <a16:creationId xmlns:a16="http://schemas.microsoft.com/office/drawing/2014/main" id="{18BCE863-5928-4C91-99C5-B1F350B22DFC}"/>
               </a:ext>
             </a:extLst>
           </p:cNvPr>
@@ -4613,7 +4701,7 @@
           <p:cNvPr id="8" name="">
             <a:extLst xmlns:a="http://schemas.openxmlformats.org/drawingml/2006/main">
               <a:ext uri="{FF2B5EF4-FFF2-40B4-BE49-F238E27FC236}">
-                <a16:creationId xmlns:a16="http://schemas.microsoft.com/office/drawing/2014/main" id="{694E9D7E-503E-4DB9-9044-59DEA8556EBD}"/>
+                <a16:creationId xmlns:a16="http://schemas.microsoft.com/office/drawing/2014/main" id="{AA3B1A33-83FE-49E5-BDB6-CFAB171793DD}"/>
               </a:ext>
             </a:extLst>
           </p:cNvPr>
@@ -4663,7 +4751,7 @@
           <p:cNvPr id="9" name="">
             <a:extLst xmlns:a="http://schemas.openxmlformats.org/drawingml/2006/main">
               <a:ext uri="{FF2B5EF4-FFF2-40B4-BE49-F238E27FC236}">
-                <a16:creationId xmlns:a16="http://schemas.microsoft.com/office/drawing/2014/main" id="{B08D100E-5645-4019-AB7E-106F0FC20DD1}"/>
+                <a16:creationId xmlns:a16="http://schemas.microsoft.com/office/drawing/2014/main" id="{27BBBE99-DA75-4A7C-BBEC-7B878E99A58D}"/>
               </a:ext>
             </a:extLst>
           </p:cNvPr>
@@ -4719,7 +4807,7 @@
           <p:cNvPr id="10" name="">
             <a:extLst xmlns:a="http://schemas.openxmlformats.org/drawingml/2006/main">
               <a:ext uri="{FF2B5EF4-FFF2-40B4-BE49-F238E27FC236}">
-                <a16:creationId xmlns:a16="http://schemas.microsoft.com/office/drawing/2014/main" id="{83B7F292-93D8-4B2F-A434-8A15BD6880C1}"/>
+                <a16:creationId xmlns:a16="http://schemas.microsoft.com/office/drawing/2014/main" id="{D4A1926E-54B6-439A-B2E5-5CFEC22067E8}"/>
               </a:ext>
             </a:extLst>
           </p:cNvPr>
@@ -4769,7 +4857,7 @@
           <p:cNvPr id="11" name="">
             <a:extLst xmlns:a="http://schemas.openxmlformats.org/drawingml/2006/main">
               <a:ext uri="{FF2B5EF4-FFF2-40B4-BE49-F238E27FC236}">
-                <a16:creationId xmlns:a16="http://schemas.microsoft.com/office/drawing/2014/main" id="{0052DAD3-09C5-4D2F-9998-357F6C5DF240}"/>
+                <a16:creationId xmlns:a16="http://schemas.microsoft.com/office/drawing/2014/main" id="{6FC357B0-FEB1-4AFB-AE72-7D953E2BEBB2}"/>
               </a:ext>
             </a:extLst>
           </p:cNvPr>
@@ -4800,7 +4888,7 @@
           <p:cNvPr id="12" name="">
             <a:extLst xmlns:a="http://schemas.openxmlformats.org/drawingml/2006/main">
               <a:ext uri="{FF2B5EF4-FFF2-40B4-BE49-F238E27FC236}">
-                <a16:creationId xmlns:a16="http://schemas.microsoft.com/office/drawing/2014/main" id="{1FDDAF54-0428-4937-BBDF-66879397937B}"/>
+                <a16:creationId xmlns:a16="http://schemas.microsoft.com/office/drawing/2014/main" id="{D9D1A3DD-C1BE-4161-83D6-8FEBEC2E6502}"/>
               </a:ext>
             </a:extLst>
           </p:cNvPr>
@@ -4812,7 +4900,7 @@
         <p:spPr>
           <a:xfrm xmlns:a="http://schemas.openxmlformats.org/drawingml/2006/main">
             <a:off x="609600" y="6419850"/>
-            <a:ext cx="7810500" cy="209550"/>
+            <a:ext cx="4000500" cy="209550"/>
           </a:xfrm>
           <a:prstGeom xmlns:a="http://schemas.openxmlformats.org/drawingml/2006/main" prst="rect">
             <a:avLst/>
@@ -4840,7 +4928,7 @@
                   <a:srgbClr val="52615B"/>
                 </a:solidFill>
               </a:rPr>
-              <a:t>非公式資料 | Source: products/shopify-collective/architecture.md</a:t>
+              <a:t>Shopify Collective</a:t>
             </a:r>
           </a:p>
         </p:txBody>
@@ -4850,7 +4938,7 @@
           <p:cNvPr id="13" name="">
             <a:extLst xmlns:a="http://schemas.openxmlformats.org/drawingml/2006/main">
               <a:ext uri="{FF2B5EF4-FFF2-40B4-BE49-F238E27FC236}">
-                <a16:creationId xmlns:a16="http://schemas.microsoft.com/office/drawing/2014/main" id="{1C264E42-E08C-47ED-A8B6-7A0D8E628CB5}"/>
+                <a16:creationId xmlns:a16="http://schemas.microsoft.com/office/drawing/2014/main" id="{510F510E-BD20-421A-9E49-A6BC04F7C985}"/>
               </a:ext>
             </a:extLst>
           </p:cNvPr>
@@ -4898,7 +4986,7 @@
     </p:spTree>
     <p:extLst>
       <p:ext uri="{BB962C8B-B14F-4D97-AF65-F5344CB8AC3E}">
-        <p14:creationId xmlns:p14="http://schemas.microsoft.com/office/powerpoint/2010/main" val="1869764634"/>
+        <p14:creationId xmlns:p14="http://schemas.microsoft.com/office/powerpoint/2010/main" val="1175628177"/>
       </p:ext>
     </p:extLst>
   </p:cSld>
@@ -4929,7 +5017,7 @@
           <p:cNvPr id="1" name="">
             <a:extLst xmlns:a="http://schemas.openxmlformats.org/drawingml/2006/main">
               <a:ext uri="{FF2B5EF4-FFF2-40B4-BE49-F238E27FC236}">
-                <a16:creationId xmlns:a16="http://schemas.microsoft.com/office/drawing/2014/main" id="{10DB7EC5-C831-4891-9738-37C0C14448B2}"/>
+                <a16:creationId xmlns:a16="http://schemas.microsoft.com/office/drawing/2014/main" id="{BBBFD532-534E-4B9D-9BE1-E70A48F30478}"/>
               </a:ext>
             </a:extLst>
           </p:cNvPr>
@@ -4979,7 +5067,7 @@
           <p:cNvPr id="2" name="">
             <a:extLst xmlns:a="http://schemas.openxmlformats.org/drawingml/2006/main">
               <a:ext uri="{FF2B5EF4-FFF2-40B4-BE49-F238E27FC236}">
-                <a16:creationId xmlns:a16="http://schemas.microsoft.com/office/drawing/2014/main" id="{85AEBE7B-AB2F-46B5-A7F3-A09D4D4EB299}"/>
+                <a16:creationId xmlns:a16="http://schemas.microsoft.com/office/drawing/2014/main" id="{8037E3EA-FDE8-450C-9F89-5B94C6992D6E}"/>
               </a:ext>
             </a:extLst>
           </p:cNvPr>
@@ -5029,7 +5117,7 @@
           <p:cNvPr id="3" name="">
             <a:extLst xmlns:a="http://schemas.openxmlformats.org/drawingml/2006/main">
               <a:ext uri="{FF2B5EF4-FFF2-40B4-BE49-F238E27FC236}">
-                <a16:creationId xmlns:a16="http://schemas.microsoft.com/office/drawing/2014/main" id="{28D5E050-6A9E-4028-BDF3-B505DDCDA5D7}"/>
+                <a16:creationId xmlns:a16="http://schemas.microsoft.com/office/drawing/2014/main" id="{7146DE3B-8951-443E-9EBD-127259AAE83C}"/>
               </a:ext>
             </a:extLst>
           </p:cNvPr>
@@ -5079,7 +5167,7 @@
           <p:cNvPr id="4" name="">
             <a:extLst xmlns:a="http://schemas.openxmlformats.org/drawingml/2006/main">
               <a:ext uri="{FF2B5EF4-FFF2-40B4-BE49-F238E27FC236}">
-                <a16:creationId xmlns:a16="http://schemas.microsoft.com/office/drawing/2014/main" id="{75CA94EE-48A8-47BA-85E8-AA33552DE2D7}"/>
+                <a16:creationId xmlns:a16="http://schemas.microsoft.com/office/drawing/2014/main" id="{15C512C5-AE53-4128-BC1C-A4321B70B1FF}"/>
               </a:ext>
             </a:extLst>
           </p:cNvPr>
@@ -5110,7 +5198,7 @@
           <p:cNvPr id="5" name="">
             <a:extLst xmlns:a="http://schemas.openxmlformats.org/drawingml/2006/main">
               <a:ext uri="{FF2B5EF4-FFF2-40B4-BE49-F238E27FC236}">
-                <a16:creationId xmlns:a16="http://schemas.microsoft.com/office/drawing/2014/main" id="{1026D0CD-3B43-4FE5-883D-BBCE9160FD8B}"/>
+                <a16:creationId xmlns:a16="http://schemas.microsoft.com/office/drawing/2014/main" id="{83F53AE4-B8D9-497C-9DB4-2DD7CF25C76F}"/>
               </a:ext>
             </a:extLst>
           </p:cNvPr>
@@ -5166,7 +5254,7 @@
           <p:cNvPr id="6" name="">
             <a:extLst xmlns:a="http://schemas.openxmlformats.org/drawingml/2006/main">
               <a:ext uri="{FF2B5EF4-FFF2-40B4-BE49-F238E27FC236}">
-                <a16:creationId xmlns:a16="http://schemas.microsoft.com/office/drawing/2014/main" id="{CF9D6A8D-7157-4AD3-9355-F9E270ABD5D5}"/>
+                <a16:creationId xmlns:a16="http://schemas.microsoft.com/office/drawing/2014/main" id="{74604EEC-7F50-41E2-A260-F49F56D489DE}"/>
               </a:ext>
             </a:extLst>
           </p:cNvPr>
@@ -5216,7 +5304,7 @@
           <p:cNvPr id="7" name="">
             <a:extLst xmlns:a="http://schemas.openxmlformats.org/drawingml/2006/main">
               <a:ext uri="{FF2B5EF4-FFF2-40B4-BE49-F238E27FC236}">
-                <a16:creationId xmlns:a16="http://schemas.microsoft.com/office/drawing/2014/main" id="{EF85E903-AC92-492C-9A17-140596D025DD}"/>
+                <a16:creationId xmlns:a16="http://schemas.microsoft.com/office/drawing/2014/main" id="{850B62AE-EEC2-4755-AF76-9ED78F46AC78}"/>
               </a:ext>
             </a:extLst>
           </p:cNvPr>
@@ -5266,7 +5354,7 @@
           <p:cNvPr id="8" name="">
             <a:extLst xmlns:a="http://schemas.openxmlformats.org/drawingml/2006/main">
               <a:ext uri="{FF2B5EF4-FFF2-40B4-BE49-F238E27FC236}">
-                <a16:creationId xmlns:a16="http://schemas.microsoft.com/office/drawing/2014/main" id="{55259344-EE87-4CD4-8405-B218A3036C5E}"/>
+                <a16:creationId xmlns:a16="http://schemas.microsoft.com/office/drawing/2014/main" id="{B8FBC3B8-93BA-429D-BAF0-84BD52EEDC19}"/>
               </a:ext>
             </a:extLst>
           </p:cNvPr>
@@ -5322,7 +5410,7 @@
           <p:cNvPr id="9" name="">
             <a:extLst xmlns:a="http://schemas.openxmlformats.org/drawingml/2006/main">
               <a:ext uri="{FF2B5EF4-FFF2-40B4-BE49-F238E27FC236}">
-                <a16:creationId xmlns:a16="http://schemas.microsoft.com/office/drawing/2014/main" id="{B9F155E5-1112-4606-B32D-5D650BBD3B41}"/>
+                <a16:creationId xmlns:a16="http://schemas.microsoft.com/office/drawing/2014/main" id="{51403B28-8528-40BD-8F7B-96199571E472}"/>
               </a:ext>
             </a:extLst>
           </p:cNvPr>
@@ -5372,7 +5460,7 @@
           <p:cNvPr id="10" name="">
             <a:extLst xmlns:a="http://schemas.openxmlformats.org/drawingml/2006/main">
               <a:ext uri="{FF2B5EF4-FFF2-40B4-BE49-F238E27FC236}">
-                <a16:creationId xmlns:a16="http://schemas.microsoft.com/office/drawing/2014/main" id="{935AD902-BC2A-4C46-A68A-91DDFF875AFF}"/>
+                <a16:creationId xmlns:a16="http://schemas.microsoft.com/office/drawing/2014/main" id="{7B08F3C6-2A27-4352-9C63-82D10A504844}"/>
               </a:ext>
             </a:extLst>
           </p:cNvPr>
@@ -5422,7 +5510,7 @@
           <p:cNvPr id="11" name="">
             <a:extLst xmlns:a="http://schemas.openxmlformats.org/drawingml/2006/main">
               <a:ext uri="{FF2B5EF4-FFF2-40B4-BE49-F238E27FC236}">
-                <a16:creationId xmlns:a16="http://schemas.microsoft.com/office/drawing/2014/main" id="{9FB8CD09-379C-447D-BF8C-8949C3CFB6D7}"/>
+                <a16:creationId xmlns:a16="http://schemas.microsoft.com/office/drawing/2014/main" id="{02159132-44D8-4032-B961-B4B732ADD79A}"/>
               </a:ext>
             </a:extLst>
           </p:cNvPr>
@@ -5478,7 +5566,7 @@
           <p:cNvPr id="12" name="">
             <a:extLst xmlns:a="http://schemas.openxmlformats.org/drawingml/2006/main">
               <a:ext uri="{FF2B5EF4-FFF2-40B4-BE49-F238E27FC236}">
-                <a16:creationId xmlns:a16="http://schemas.microsoft.com/office/drawing/2014/main" id="{39EE72AF-10F3-4470-B331-E88C6DD1EBA5}"/>
+                <a16:creationId xmlns:a16="http://schemas.microsoft.com/office/drawing/2014/main" id="{F0281841-EB0C-4B9A-BDA0-54B42855D939}"/>
               </a:ext>
             </a:extLst>
           </p:cNvPr>
@@ -5528,7 +5616,7 @@
           <p:cNvPr id="13" name="">
             <a:extLst xmlns:a="http://schemas.openxmlformats.org/drawingml/2006/main">
               <a:ext uri="{FF2B5EF4-FFF2-40B4-BE49-F238E27FC236}">
-                <a16:creationId xmlns:a16="http://schemas.microsoft.com/office/drawing/2014/main" id="{E2F0F86C-C8D4-4B94-B614-1B0ACCA499BD}"/>
+                <a16:creationId xmlns:a16="http://schemas.microsoft.com/office/drawing/2014/main" id="{CEE0AA85-13E4-4169-9524-65FAC388B2DE}"/>
               </a:ext>
             </a:extLst>
           </p:cNvPr>
@@ -5578,7 +5666,7 @@
           <p:cNvPr id="14" name="">
             <a:extLst xmlns:a="http://schemas.openxmlformats.org/drawingml/2006/main">
               <a:ext uri="{FF2B5EF4-FFF2-40B4-BE49-F238E27FC236}">
-                <a16:creationId xmlns:a16="http://schemas.microsoft.com/office/drawing/2014/main" id="{4ACF1620-0DE8-4588-934D-ADDE5E0DEF32}"/>
+                <a16:creationId xmlns:a16="http://schemas.microsoft.com/office/drawing/2014/main" id="{605B9A65-A5EA-45ED-B91B-4036D664F80B}"/>
               </a:ext>
             </a:extLst>
           </p:cNvPr>
@@ -5634,7 +5722,7 @@
           <p:cNvPr id="15" name="">
             <a:extLst xmlns:a="http://schemas.openxmlformats.org/drawingml/2006/main">
               <a:ext uri="{FF2B5EF4-FFF2-40B4-BE49-F238E27FC236}">
-                <a16:creationId xmlns:a16="http://schemas.microsoft.com/office/drawing/2014/main" id="{C1A0D622-B694-4CBA-8920-21DBB7317A50}"/>
+                <a16:creationId xmlns:a16="http://schemas.microsoft.com/office/drawing/2014/main" id="{CAC49E68-6FD4-4B50-9F83-DE8E7FF1796E}"/>
               </a:ext>
             </a:extLst>
           </p:cNvPr>
@@ -5684,7 +5772,7 @@
           <p:cNvPr id="16" name="">
             <a:extLst xmlns:a="http://schemas.openxmlformats.org/drawingml/2006/main">
               <a:ext uri="{FF2B5EF4-FFF2-40B4-BE49-F238E27FC236}">
-                <a16:creationId xmlns:a16="http://schemas.microsoft.com/office/drawing/2014/main" id="{62414EEC-FB9A-4A02-B76F-C08656F74D21}"/>
+                <a16:creationId xmlns:a16="http://schemas.microsoft.com/office/drawing/2014/main" id="{220D2A95-A0CC-4F6C-A27D-F15CDE9A67EC}"/>
               </a:ext>
             </a:extLst>
           </p:cNvPr>
@@ -5734,7 +5822,7 @@
           <p:cNvPr id="17" name="">
             <a:extLst xmlns:a="http://schemas.openxmlformats.org/drawingml/2006/main">
               <a:ext uri="{FF2B5EF4-FFF2-40B4-BE49-F238E27FC236}">
-                <a16:creationId xmlns:a16="http://schemas.microsoft.com/office/drawing/2014/main" id="{21B6FC57-FBB0-47E7-AAB4-7D35CC272221}"/>
+                <a16:creationId xmlns:a16="http://schemas.microsoft.com/office/drawing/2014/main" id="{9FC2A99B-D0EB-4360-9B9C-B2279FA7DCCF}"/>
               </a:ext>
             </a:extLst>
           </p:cNvPr>
@@ -5784,7 +5872,7 @@
           <p:cNvPr id="18" name="">
             <a:extLst xmlns:a="http://schemas.openxmlformats.org/drawingml/2006/main">
               <a:ext uri="{FF2B5EF4-FFF2-40B4-BE49-F238E27FC236}">
-                <a16:creationId xmlns:a16="http://schemas.microsoft.com/office/drawing/2014/main" id="{32226353-7A4B-4B12-BCAE-42C0ECF4DF29}"/>
+                <a16:creationId xmlns:a16="http://schemas.microsoft.com/office/drawing/2014/main" id="{99B19D55-0742-4EB6-A92F-9F0E92F3DAA4}"/>
               </a:ext>
             </a:extLst>
           </p:cNvPr>
@@ -5834,7 +5922,7 @@
           <p:cNvPr id="19" name="">
             <a:extLst xmlns:a="http://schemas.openxmlformats.org/drawingml/2006/main">
               <a:ext uri="{FF2B5EF4-FFF2-40B4-BE49-F238E27FC236}">
-                <a16:creationId xmlns:a16="http://schemas.microsoft.com/office/drawing/2014/main" id="{AFFDAA5C-6D93-4221-B6CE-D9466DFEAC5E}"/>
+                <a16:creationId xmlns:a16="http://schemas.microsoft.com/office/drawing/2014/main" id="{9254AB28-29E9-49C7-8229-03DA510B2EB3}"/>
               </a:ext>
             </a:extLst>
           </p:cNvPr>
@@ -5865,7 +5953,7 @@
           <p:cNvPr id="20" name="">
             <a:extLst xmlns:a="http://schemas.openxmlformats.org/drawingml/2006/main">
               <a:ext uri="{FF2B5EF4-FFF2-40B4-BE49-F238E27FC236}">
-                <a16:creationId xmlns:a16="http://schemas.microsoft.com/office/drawing/2014/main" id="{4237C8E0-13F7-48DB-BEDB-39C89B0DA20B}"/>
+                <a16:creationId xmlns:a16="http://schemas.microsoft.com/office/drawing/2014/main" id="{04D06A5B-D947-4F33-B571-C2E291A9B0A2}"/>
               </a:ext>
             </a:extLst>
           </p:cNvPr>
@@ -5877,7 +5965,7 @@
         <p:spPr>
           <a:xfrm xmlns:a="http://schemas.openxmlformats.org/drawingml/2006/main">
             <a:off x="609600" y="6419850"/>
-            <a:ext cx="7810500" cy="209550"/>
+            <a:ext cx="4000500" cy="209550"/>
           </a:xfrm>
           <a:prstGeom xmlns:a="http://schemas.openxmlformats.org/drawingml/2006/main" prst="rect">
             <a:avLst/>
@@ -5905,7 +5993,7 @@
                   <a:srgbClr val="52615B"/>
                 </a:solidFill>
               </a:rPr>
-              <a:t>非公式資料 | Source: products/shopify-collective/architecture.md</a:t>
+              <a:t>Shopify Collective</a:t>
             </a:r>
           </a:p>
         </p:txBody>
@@ -5915,7 +6003,7 @@
           <p:cNvPr id="21" name="">
             <a:extLst xmlns:a="http://schemas.openxmlformats.org/drawingml/2006/main">
               <a:ext uri="{FF2B5EF4-FFF2-40B4-BE49-F238E27FC236}">
-                <a16:creationId xmlns:a16="http://schemas.microsoft.com/office/drawing/2014/main" id="{1CD6C276-065F-4868-9141-5F12F3431E30}"/>
+                <a16:creationId xmlns:a16="http://schemas.microsoft.com/office/drawing/2014/main" id="{C223A6D6-B20C-483D-AC5F-91042EBB93C1}"/>
               </a:ext>
             </a:extLst>
           </p:cNvPr>
@@ -5963,7 +6051,7 @@
     </p:spTree>
     <p:extLst>
       <p:ext uri="{BB962C8B-B14F-4D97-AF65-F5344CB8AC3E}">
-        <p14:creationId xmlns:p14="http://schemas.microsoft.com/office/powerpoint/2010/main" val="1394926860"/>
+        <p14:creationId xmlns:p14="http://schemas.microsoft.com/office/powerpoint/2010/main" val="840534476"/>
       </p:ext>
     </p:extLst>
   </p:cSld>
@@ -5994,7 +6082,7 @@
           <p:cNvPr id="1" name="">
             <a:extLst xmlns:a="http://schemas.openxmlformats.org/drawingml/2006/main">
               <a:ext uri="{FF2B5EF4-FFF2-40B4-BE49-F238E27FC236}">
-                <a16:creationId xmlns:a16="http://schemas.microsoft.com/office/drawing/2014/main" id="{CA701B70-117E-40BD-836F-BEFD06FEEB3F}"/>
+                <a16:creationId xmlns:a16="http://schemas.microsoft.com/office/drawing/2014/main" id="{1A68F24C-9BE1-4BE5-954A-6FF71EB73487}"/>
               </a:ext>
             </a:extLst>
           </p:cNvPr>
@@ -6044,7 +6132,7 @@
           <p:cNvPr id="2" name="">
             <a:extLst xmlns:a="http://schemas.openxmlformats.org/drawingml/2006/main">
               <a:ext uri="{FF2B5EF4-FFF2-40B4-BE49-F238E27FC236}">
-                <a16:creationId xmlns:a16="http://schemas.microsoft.com/office/drawing/2014/main" id="{4DF1E44F-8775-441B-A193-BF5ECE6BB37F}"/>
+                <a16:creationId xmlns:a16="http://schemas.microsoft.com/office/drawing/2014/main" id="{EF6D1A64-4C39-4B0A-B68A-0AAF48D9B137}"/>
               </a:ext>
             </a:extLst>
           </p:cNvPr>
@@ -6094,7 +6182,7 @@
           <p:cNvPr id="3" name="">
             <a:extLst xmlns:a="http://schemas.openxmlformats.org/drawingml/2006/main">
               <a:ext uri="{FF2B5EF4-FFF2-40B4-BE49-F238E27FC236}">
-                <a16:creationId xmlns:a16="http://schemas.microsoft.com/office/drawing/2014/main" id="{17F00AB5-FEB6-43CB-A6E4-59D9465B2A54}"/>
+                <a16:creationId xmlns:a16="http://schemas.microsoft.com/office/drawing/2014/main" id="{593825A4-3AB0-4EEF-AA58-BB92105EE376}"/>
               </a:ext>
             </a:extLst>
           </p:cNvPr>
@@ -6144,7 +6232,7 @@
           <p:cNvPr id="4" name="">
             <a:extLst xmlns:a="http://schemas.openxmlformats.org/drawingml/2006/main">
               <a:ext uri="{FF2B5EF4-FFF2-40B4-BE49-F238E27FC236}">
-                <a16:creationId xmlns:a16="http://schemas.microsoft.com/office/drawing/2014/main" id="{2A8C8907-9126-413A-A16A-26E3D4FF7BEB}"/>
+                <a16:creationId xmlns:a16="http://schemas.microsoft.com/office/drawing/2014/main" id="{1BBC420E-FF8E-4876-8492-A6708D23154A}"/>
               </a:ext>
             </a:extLst>
           </p:cNvPr>
@@ -6175,7 +6263,7 @@
           <p:cNvPr id="5" name="">
             <a:extLst xmlns:a="http://schemas.openxmlformats.org/drawingml/2006/main">
               <a:ext uri="{FF2B5EF4-FFF2-40B4-BE49-F238E27FC236}">
-                <a16:creationId xmlns:a16="http://schemas.microsoft.com/office/drawing/2014/main" id="{1E4EE2AC-BAB9-4793-ADB0-015F0A3FC461}"/>
+                <a16:creationId xmlns:a16="http://schemas.microsoft.com/office/drawing/2014/main" id="{27FA1FBA-9C22-4FC3-9ACE-8B376D5781EC}"/>
               </a:ext>
             </a:extLst>
           </p:cNvPr>
@@ -6231,7 +6319,7 @@
           <p:cNvPr id="6" name="">
             <a:extLst xmlns:a="http://schemas.openxmlformats.org/drawingml/2006/main">
               <a:ext uri="{FF2B5EF4-FFF2-40B4-BE49-F238E27FC236}">
-                <a16:creationId xmlns:a16="http://schemas.microsoft.com/office/drawing/2014/main" id="{070D38C6-0502-4630-872F-7992902479C1}"/>
+                <a16:creationId xmlns:a16="http://schemas.microsoft.com/office/drawing/2014/main" id="{51B6210E-3D2C-4A74-802C-5B0EBFA9B410}"/>
               </a:ext>
             </a:extLst>
           </p:cNvPr>
@@ -6271,7 +6359,7 @@
                   <a:srgbClr val="52615B"/>
                 </a:solidFill>
               </a:rPr>
-              <a:t>sellableOnlineQuantityがRetailer在庫に反映されます。</a:t>
+              <a:t>Supplierのオンライン販売可能在庫がRetailer在庫に反映されます。</a:t>
             </a:r>
           </a:p>
         </p:txBody>
@@ -6281,7 +6369,7 @@
           <p:cNvPr id="7" name="">
             <a:extLst xmlns:a="http://schemas.openxmlformats.org/drawingml/2006/main">
               <a:ext uri="{FF2B5EF4-FFF2-40B4-BE49-F238E27FC236}">
-                <a16:creationId xmlns:a16="http://schemas.microsoft.com/office/drawing/2014/main" id="{57E003DC-BA2E-4F46-A1E5-E0D16B36C8A3}"/>
+                <a16:creationId xmlns:a16="http://schemas.microsoft.com/office/drawing/2014/main" id="{D6C21B1C-6DA9-4A7C-BF74-98449225A46F}"/>
               </a:ext>
             </a:extLst>
           </p:cNvPr>
@@ -6331,7 +6419,7 @@
           <p:cNvPr id="8" name="">
             <a:extLst xmlns:a="http://schemas.openxmlformats.org/drawingml/2006/main">
               <a:ext uri="{FF2B5EF4-FFF2-40B4-BE49-F238E27FC236}">
-                <a16:creationId xmlns:a16="http://schemas.microsoft.com/office/drawing/2014/main" id="{A7E3D5F7-E234-4441-9087-A0C633BEF45E}"/>
+                <a16:creationId xmlns:a16="http://schemas.microsoft.com/office/drawing/2014/main" id="{D32444D7-95F7-44CC-A1A1-1976570F4347}"/>
               </a:ext>
             </a:extLst>
           </p:cNvPr>
@@ -6387,7 +6475,7 @@
           <p:cNvPr id="9" name="">
             <a:extLst xmlns:a="http://schemas.openxmlformats.org/drawingml/2006/main">
               <a:ext uri="{FF2B5EF4-FFF2-40B4-BE49-F238E27FC236}">
-                <a16:creationId xmlns:a16="http://schemas.microsoft.com/office/drawing/2014/main" id="{C4DC84F2-E2E4-4AA3-85C4-E88D265C2CC6}"/>
+                <a16:creationId xmlns:a16="http://schemas.microsoft.com/office/drawing/2014/main" id="{D595F452-6E64-4558-8BDF-C2163CEA28EF}"/>
               </a:ext>
             </a:extLst>
           </p:cNvPr>
@@ -6437,7 +6525,7 @@
           <p:cNvPr id="10" name="">
             <a:extLst xmlns:a="http://schemas.openxmlformats.org/drawingml/2006/main">
               <a:ext uri="{FF2B5EF4-FFF2-40B4-BE49-F238E27FC236}">
-                <a16:creationId xmlns:a16="http://schemas.microsoft.com/office/drawing/2014/main" id="{2243B668-C88E-4C19-8A8E-CEF225065F12}"/>
+                <a16:creationId xmlns:a16="http://schemas.microsoft.com/office/drawing/2014/main" id="{C198D912-CAA6-4805-853D-8E9CE0DFE6FE}"/>
               </a:ext>
             </a:extLst>
           </p:cNvPr>
@@ -6487,7 +6575,7 @@
           <p:cNvPr id="11" name="">
             <a:extLst xmlns:a="http://schemas.openxmlformats.org/drawingml/2006/main">
               <a:ext uri="{FF2B5EF4-FFF2-40B4-BE49-F238E27FC236}">
-                <a16:creationId xmlns:a16="http://schemas.microsoft.com/office/drawing/2014/main" id="{892D59DF-FE30-4891-80C9-2EEA03E7D955}"/>
+                <a16:creationId xmlns:a16="http://schemas.microsoft.com/office/drawing/2014/main" id="{2A8438AB-9087-4EB0-A118-7EF0C2310755}"/>
               </a:ext>
             </a:extLst>
           </p:cNvPr>
@@ -6543,7 +6631,7 @@
           <p:cNvPr id="12" name="">
             <a:extLst xmlns:a="http://schemas.openxmlformats.org/drawingml/2006/main">
               <a:ext uri="{FF2B5EF4-FFF2-40B4-BE49-F238E27FC236}">
-                <a16:creationId xmlns:a16="http://schemas.microsoft.com/office/drawing/2014/main" id="{B8881738-9534-4C74-81AE-F1E11A6607CB}"/>
+                <a16:creationId xmlns:a16="http://schemas.microsoft.com/office/drawing/2014/main" id="{B3F3E32D-C7F6-4E84-B1DE-3E0F5C0725A0}"/>
               </a:ext>
             </a:extLst>
           </p:cNvPr>
@@ -6593,7 +6681,7 @@
           <p:cNvPr id="13" name="">
             <a:extLst xmlns:a="http://schemas.openxmlformats.org/drawingml/2006/main">
               <a:ext uri="{FF2B5EF4-FFF2-40B4-BE49-F238E27FC236}">
-                <a16:creationId xmlns:a16="http://schemas.microsoft.com/office/drawing/2014/main" id="{F500D7FA-4986-45B0-A492-37E11E9E2C9F}"/>
+                <a16:creationId xmlns:a16="http://schemas.microsoft.com/office/drawing/2014/main" id="{109506AC-C379-429B-ABF9-BBE613AA442D}"/>
               </a:ext>
             </a:extLst>
           </p:cNvPr>
@@ -6643,7 +6731,7 @@
           <p:cNvPr id="14" name="">
             <a:extLst xmlns:a="http://schemas.openxmlformats.org/drawingml/2006/main">
               <a:ext uri="{FF2B5EF4-FFF2-40B4-BE49-F238E27FC236}">
-                <a16:creationId xmlns:a16="http://schemas.microsoft.com/office/drawing/2014/main" id="{8064A4ED-8DE1-4494-845F-195A396BA5D0}"/>
+                <a16:creationId xmlns:a16="http://schemas.microsoft.com/office/drawing/2014/main" id="{7B4F2A17-3EDD-4ECB-B6C8-97355B4E2B8E}"/>
               </a:ext>
             </a:extLst>
           </p:cNvPr>
@@ -6699,7 +6787,7 @@
           <p:cNvPr id="15" name="">
             <a:extLst xmlns:a="http://schemas.openxmlformats.org/drawingml/2006/main">
               <a:ext uri="{FF2B5EF4-FFF2-40B4-BE49-F238E27FC236}">
-                <a16:creationId xmlns:a16="http://schemas.microsoft.com/office/drawing/2014/main" id="{6225CC0C-E854-4ABF-9840-55E9298C8E13}"/>
+                <a16:creationId xmlns:a16="http://schemas.microsoft.com/office/drawing/2014/main" id="{9AB2183F-A4D4-47B5-A005-4CC3EAA08672}"/>
               </a:ext>
             </a:extLst>
           </p:cNvPr>
@@ -6749,7 +6837,7 @@
           <p:cNvPr id="16" name="">
             <a:extLst xmlns:a="http://schemas.openxmlformats.org/drawingml/2006/main">
               <a:ext uri="{FF2B5EF4-FFF2-40B4-BE49-F238E27FC236}">
-                <a16:creationId xmlns:a16="http://schemas.microsoft.com/office/drawing/2014/main" id="{6164A20D-96AA-4212-98BF-45A36AF519E7}"/>
+                <a16:creationId xmlns:a16="http://schemas.microsoft.com/office/drawing/2014/main" id="{FD89A7BC-FFB6-4B2A-91A6-E6FA9A1D72C7}"/>
               </a:ext>
             </a:extLst>
           </p:cNvPr>
@@ -6799,7 +6887,7 @@
           <p:cNvPr id="17" name="">
             <a:extLst xmlns:a="http://schemas.openxmlformats.org/drawingml/2006/main">
               <a:ext uri="{FF2B5EF4-FFF2-40B4-BE49-F238E27FC236}">
-                <a16:creationId xmlns:a16="http://schemas.microsoft.com/office/drawing/2014/main" id="{13534F6A-1411-49C2-A29E-19F3EE15453F}"/>
+                <a16:creationId xmlns:a16="http://schemas.microsoft.com/office/drawing/2014/main" id="{A38DACB7-6E2B-4590-A19C-41F1FCB26F47}"/>
               </a:ext>
             </a:extLst>
           </p:cNvPr>
@@ -6855,7 +6943,7 @@
           <p:cNvPr id="18" name="">
             <a:extLst xmlns:a="http://schemas.openxmlformats.org/drawingml/2006/main">
               <a:ext uri="{FF2B5EF4-FFF2-40B4-BE49-F238E27FC236}">
-                <a16:creationId xmlns:a16="http://schemas.microsoft.com/office/drawing/2014/main" id="{E67D24B5-07F1-42A0-8E39-0A792F2F2E0D}"/>
+                <a16:creationId xmlns:a16="http://schemas.microsoft.com/office/drawing/2014/main" id="{B9C1FA17-EC8A-43FF-A80F-4583C5FC915C}"/>
               </a:ext>
             </a:extLst>
           </p:cNvPr>
@@ -6905,7 +6993,7 @@
           <p:cNvPr id="19" name="">
             <a:extLst xmlns:a="http://schemas.openxmlformats.org/drawingml/2006/main">
               <a:ext uri="{FF2B5EF4-FFF2-40B4-BE49-F238E27FC236}">
-                <a16:creationId xmlns:a16="http://schemas.microsoft.com/office/drawing/2014/main" id="{AA3BD802-2E6D-4BDD-842B-387C3903381C}"/>
+                <a16:creationId xmlns:a16="http://schemas.microsoft.com/office/drawing/2014/main" id="{734C2424-2C28-4146-8284-454FF106A5FE}"/>
               </a:ext>
             </a:extLst>
           </p:cNvPr>
@@ -6955,7 +7043,7 @@
           <p:cNvPr id="20" name="">
             <a:extLst xmlns:a="http://schemas.openxmlformats.org/drawingml/2006/main">
               <a:ext uri="{FF2B5EF4-FFF2-40B4-BE49-F238E27FC236}">
-                <a16:creationId xmlns:a16="http://schemas.microsoft.com/office/drawing/2014/main" id="{4D638231-58D2-435C-AA57-DF3E5AFE88FC}"/>
+                <a16:creationId xmlns:a16="http://schemas.microsoft.com/office/drawing/2014/main" id="{DD39B50A-9E56-4E7A-BBFA-A5A19B14128A}"/>
               </a:ext>
             </a:extLst>
           </p:cNvPr>
@@ -7005,7 +7093,7 @@
           <p:cNvPr id="21" name="">
             <a:extLst xmlns:a="http://schemas.openxmlformats.org/drawingml/2006/main">
               <a:ext uri="{FF2B5EF4-FFF2-40B4-BE49-F238E27FC236}">
-                <a16:creationId xmlns:a16="http://schemas.microsoft.com/office/drawing/2014/main" id="{BEEBB644-D08A-48DD-B3D6-CF19A96EAFEC}"/>
+                <a16:creationId xmlns:a16="http://schemas.microsoft.com/office/drawing/2014/main" id="{911207E0-2F26-4F94-A72E-B958F1BF0593}"/>
               </a:ext>
             </a:extLst>
           </p:cNvPr>
@@ -7055,7 +7143,7 @@
           <p:cNvPr id="22" name="">
             <a:extLst xmlns:a="http://schemas.openxmlformats.org/drawingml/2006/main">
               <a:ext uri="{FF2B5EF4-FFF2-40B4-BE49-F238E27FC236}">
-                <a16:creationId xmlns:a16="http://schemas.microsoft.com/office/drawing/2014/main" id="{34BB5694-9853-4171-A533-97E399B126F8}"/>
+                <a16:creationId xmlns:a16="http://schemas.microsoft.com/office/drawing/2014/main" id="{142A47E0-7BFD-4A51-807C-689148883D50}"/>
               </a:ext>
             </a:extLst>
           </p:cNvPr>
@@ -7086,7 +7174,7 @@
           <p:cNvPr id="23" name="">
             <a:extLst xmlns:a="http://schemas.openxmlformats.org/drawingml/2006/main">
               <a:ext uri="{FF2B5EF4-FFF2-40B4-BE49-F238E27FC236}">
-                <a16:creationId xmlns:a16="http://schemas.microsoft.com/office/drawing/2014/main" id="{029E987B-4BBE-48AC-B52E-901317297E62}"/>
+                <a16:creationId xmlns:a16="http://schemas.microsoft.com/office/drawing/2014/main" id="{A9AC2285-A4AE-4364-9B7A-E85CBF07ABC4}"/>
               </a:ext>
             </a:extLst>
           </p:cNvPr>
@@ -7098,7 +7186,7 @@
         <p:spPr>
           <a:xfrm xmlns:a="http://schemas.openxmlformats.org/drawingml/2006/main">
             <a:off x="609600" y="6419850"/>
-            <a:ext cx="7810500" cy="209550"/>
+            <a:ext cx="4000500" cy="209550"/>
           </a:xfrm>
           <a:prstGeom xmlns:a="http://schemas.openxmlformats.org/drawingml/2006/main" prst="rect">
             <a:avLst/>
@@ -7126,7 +7214,7 @@
                   <a:srgbClr val="52615B"/>
                 </a:solidFill>
               </a:rPr>
-              <a:t>非公式資料 | Source: products/shopify-collective/architecture.md</a:t>
+              <a:t>Shopify Collective</a:t>
             </a:r>
           </a:p>
         </p:txBody>
@@ -7136,7 +7224,7 @@
           <p:cNvPr id="24" name="">
             <a:extLst xmlns:a="http://schemas.openxmlformats.org/drawingml/2006/main">
               <a:ext uri="{FF2B5EF4-FFF2-40B4-BE49-F238E27FC236}">
-                <a16:creationId xmlns:a16="http://schemas.microsoft.com/office/drawing/2014/main" id="{6407E740-2FD1-4BD1-996F-94D22140F5FB}"/>
+                <a16:creationId xmlns:a16="http://schemas.microsoft.com/office/drawing/2014/main" id="{8BE76787-F2DA-42ED-AC99-30A72533B7F7}"/>
               </a:ext>
             </a:extLst>
           </p:cNvPr>
@@ -7184,7 +7272,7 @@
     </p:spTree>
     <p:extLst>
       <p:ext uri="{BB962C8B-B14F-4D97-AF65-F5344CB8AC3E}">
-        <p14:creationId xmlns:p14="http://schemas.microsoft.com/office/powerpoint/2010/main" val="160251260"/>
+        <p14:creationId xmlns:p14="http://schemas.microsoft.com/office/powerpoint/2010/main" val="1541908250"/>
       </p:ext>
     </p:extLst>
   </p:cSld>
@@ -7215,7 +7303,7 @@
           <p:cNvPr id="1" name="">
             <a:extLst xmlns:a="http://schemas.openxmlformats.org/drawingml/2006/main">
               <a:ext uri="{FF2B5EF4-FFF2-40B4-BE49-F238E27FC236}">
-                <a16:creationId xmlns:a16="http://schemas.microsoft.com/office/drawing/2014/main" id="{D7DAF1E0-2956-4126-A29A-C19DBFD9C30F}"/>
+                <a16:creationId xmlns:a16="http://schemas.microsoft.com/office/drawing/2014/main" id="{E9E4FC8B-8FC1-40A7-B317-2B66BC076613}"/>
               </a:ext>
             </a:extLst>
           </p:cNvPr>
@@ -7265,7 +7353,7 @@
           <p:cNvPr id="2" name="">
             <a:extLst xmlns:a="http://schemas.openxmlformats.org/drawingml/2006/main">
               <a:ext uri="{FF2B5EF4-FFF2-40B4-BE49-F238E27FC236}">
-                <a16:creationId xmlns:a16="http://schemas.microsoft.com/office/drawing/2014/main" id="{E01767B1-F5DB-4ABF-B60F-9E249A7AED9C}"/>
+                <a16:creationId xmlns:a16="http://schemas.microsoft.com/office/drawing/2014/main" id="{83FB97F5-8D67-4B02-8382-2B5F2DB14DE4}"/>
               </a:ext>
             </a:extLst>
           </p:cNvPr>
@@ -7315,7 +7403,7 @@
           <p:cNvPr id="3" name="">
             <a:extLst xmlns:a="http://schemas.openxmlformats.org/drawingml/2006/main">
               <a:ext uri="{FF2B5EF4-FFF2-40B4-BE49-F238E27FC236}">
-                <a16:creationId xmlns:a16="http://schemas.microsoft.com/office/drawing/2014/main" id="{BF69AD8B-D546-49C2-A447-E16A06516E3F}"/>
+                <a16:creationId xmlns:a16="http://schemas.microsoft.com/office/drawing/2014/main" id="{0F6E96CF-816C-409D-8211-8E1243DD7C28}"/>
               </a:ext>
             </a:extLst>
           </p:cNvPr>
@@ -7365,7 +7453,7 @@
           <p:cNvPr id="4" name="">
             <a:extLst xmlns:a="http://schemas.openxmlformats.org/drawingml/2006/main">
               <a:ext uri="{FF2B5EF4-FFF2-40B4-BE49-F238E27FC236}">
-                <a16:creationId xmlns:a16="http://schemas.microsoft.com/office/drawing/2014/main" id="{BF231FCD-4E3F-4F57-9224-0A8888EBB65D}"/>
+                <a16:creationId xmlns:a16="http://schemas.microsoft.com/office/drawing/2014/main" id="{C6989CA8-90D0-4D2F-B543-D65E8E3B9FDC}"/>
               </a:ext>
             </a:extLst>
           </p:cNvPr>
@@ -7396,7 +7484,7 @@
           <p:cNvPr id="5" name="">
             <a:extLst xmlns:a="http://schemas.openxmlformats.org/drawingml/2006/main">
               <a:ext uri="{FF2B5EF4-FFF2-40B4-BE49-F238E27FC236}">
-                <a16:creationId xmlns:a16="http://schemas.microsoft.com/office/drawing/2014/main" id="{B6F71C65-885D-4EFF-A441-1239ABBFEDC3}"/>
+                <a16:creationId xmlns:a16="http://schemas.microsoft.com/office/drawing/2014/main" id="{D3C6CF29-5715-48E7-944E-27823A2444FD}"/>
               </a:ext>
             </a:extLst>
           </p:cNvPr>
@@ -7452,7 +7540,7 @@
           <p:cNvPr id="6" name="">
             <a:extLst xmlns:a="http://schemas.openxmlformats.org/drawingml/2006/main">
               <a:ext uri="{FF2B5EF4-FFF2-40B4-BE49-F238E27FC236}">
-                <a16:creationId xmlns:a16="http://schemas.microsoft.com/office/drawing/2014/main" id="{DD213612-F6A6-4AFC-A9BE-58182B1B8BB0}"/>
+                <a16:creationId xmlns:a16="http://schemas.microsoft.com/office/drawing/2014/main" id="{555C1A62-C162-4767-B945-E6E31D2E7634}"/>
               </a:ext>
             </a:extLst>
           </p:cNvPr>
@@ -7502,7 +7590,7 @@
           <p:cNvPr id="7" name="">
             <a:extLst xmlns:a="http://schemas.openxmlformats.org/drawingml/2006/main">
               <a:ext uri="{FF2B5EF4-FFF2-40B4-BE49-F238E27FC236}">
-                <a16:creationId xmlns:a16="http://schemas.microsoft.com/office/drawing/2014/main" id="{0F9A5C0F-37D9-40F4-9FB9-AF60E6420FA9}"/>
+                <a16:creationId xmlns:a16="http://schemas.microsoft.com/office/drawing/2014/main" id="{9541C945-2619-4EFB-A84B-5529BE649BFE}"/>
               </a:ext>
             </a:extLst>
           </p:cNvPr>
@@ -7558,7 +7646,7 @@
           <p:cNvPr id="8" name="">
             <a:extLst xmlns:a="http://schemas.openxmlformats.org/drawingml/2006/main">
               <a:ext uri="{FF2B5EF4-FFF2-40B4-BE49-F238E27FC236}">
-                <a16:creationId xmlns:a16="http://schemas.microsoft.com/office/drawing/2014/main" id="{3A997E92-D782-4F6A-B209-10983F18FB4C}"/>
+                <a16:creationId xmlns:a16="http://schemas.microsoft.com/office/drawing/2014/main" id="{73054670-C0EE-427D-AB6A-DDE4CCE00FE5}"/>
               </a:ext>
             </a:extLst>
           </p:cNvPr>
@@ -7608,7 +7696,7 @@
           <p:cNvPr id="9" name="">
             <a:extLst xmlns:a="http://schemas.openxmlformats.org/drawingml/2006/main">
               <a:ext uri="{FF2B5EF4-FFF2-40B4-BE49-F238E27FC236}">
-                <a16:creationId xmlns:a16="http://schemas.microsoft.com/office/drawing/2014/main" id="{4E237F24-3661-460E-B8E2-EC0D60DA8871}"/>
+                <a16:creationId xmlns:a16="http://schemas.microsoft.com/office/drawing/2014/main" id="{0DEDBE15-DF82-4332-998D-FE33B7969D09}"/>
               </a:ext>
             </a:extLst>
           </p:cNvPr>
@@ -7658,7 +7746,7 @@
           <p:cNvPr id="10" name="">
             <a:extLst xmlns:a="http://schemas.openxmlformats.org/drawingml/2006/main">
               <a:ext uri="{FF2B5EF4-FFF2-40B4-BE49-F238E27FC236}">
-                <a16:creationId xmlns:a16="http://schemas.microsoft.com/office/drawing/2014/main" id="{03F0F6F3-748C-44C9-B5DF-0504DA1D1F88}"/>
+                <a16:creationId xmlns:a16="http://schemas.microsoft.com/office/drawing/2014/main" id="{6BDB6344-CCC7-4180-926F-673112E2FE71}"/>
               </a:ext>
             </a:extLst>
           </p:cNvPr>
@@ -7708,7 +7796,7 @@
           <p:cNvPr id="11" name="">
             <a:extLst xmlns:a="http://schemas.openxmlformats.org/drawingml/2006/main">
               <a:ext uri="{FF2B5EF4-FFF2-40B4-BE49-F238E27FC236}">
-                <a16:creationId xmlns:a16="http://schemas.microsoft.com/office/drawing/2014/main" id="{470F6100-955B-44CB-9532-77878D93560C}"/>
+                <a16:creationId xmlns:a16="http://schemas.microsoft.com/office/drawing/2014/main" id="{1F57A6B5-56DB-4E98-8C43-0CB9A7A6237D}"/>
               </a:ext>
             </a:extLst>
           </p:cNvPr>
@@ -7739,7 +7827,7 @@
           <p:cNvPr id="12" name="">
             <a:extLst xmlns:a="http://schemas.openxmlformats.org/drawingml/2006/main">
               <a:ext uri="{FF2B5EF4-FFF2-40B4-BE49-F238E27FC236}">
-                <a16:creationId xmlns:a16="http://schemas.microsoft.com/office/drawing/2014/main" id="{350DECDB-7E85-43F6-B87C-F74AF94837D9}"/>
+                <a16:creationId xmlns:a16="http://schemas.microsoft.com/office/drawing/2014/main" id="{7908BB18-65CF-4BF8-832F-4174DBB3F204}"/>
               </a:ext>
             </a:extLst>
           </p:cNvPr>
@@ -7751,7 +7839,7 @@
         <p:spPr>
           <a:xfrm xmlns:a="http://schemas.openxmlformats.org/drawingml/2006/main">
             <a:off x="609600" y="6419850"/>
-            <a:ext cx="7810500" cy="209550"/>
+            <a:ext cx="4000500" cy="209550"/>
           </a:xfrm>
           <a:prstGeom xmlns:a="http://schemas.openxmlformats.org/drawingml/2006/main" prst="rect">
             <a:avLst/>
@@ -7779,7 +7867,7 @@
                   <a:srgbClr val="52615B"/>
                 </a:solidFill>
               </a:rPr>
-              <a:t>非公式資料 | Source: products/shopify-collective/architecture.md</a:t>
+              <a:t>Shopify Collective</a:t>
             </a:r>
           </a:p>
         </p:txBody>
@@ -7789,7 +7877,7 @@
           <p:cNvPr id="13" name="">
             <a:extLst xmlns:a="http://schemas.openxmlformats.org/drawingml/2006/main">
               <a:ext uri="{FF2B5EF4-FFF2-40B4-BE49-F238E27FC236}">
-                <a16:creationId xmlns:a16="http://schemas.microsoft.com/office/drawing/2014/main" id="{8701543C-FAFB-4C36-B1F4-28F524CFD086}"/>
+                <a16:creationId xmlns:a16="http://schemas.microsoft.com/office/drawing/2014/main" id="{4879C037-7EF7-4207-9473-79F11097AFD7}"/>
               </a:ext>
             </a:extLst>
           </p:cNvPr>
@@ -7837,7 +7925,7 @@
     </p:spTree>
     <p:extLst>
       <p:ext uri="{BB962C8B-B14F-4D97-AF65-F5344CB8AC3E}">
-        <p14:creationId xmlns:p14="http://schemas.microsoft.com/office/powerpoint/2010/main" val="1242203064"/>
+        <p14:creationId xmlns:p14="http://schemas.microsoft.com/office/powerpoint/2010/main" val="1326227645"/>
       </p:ext>
     </p:extLst>
   </p:cSld>
@@ -7868,7 +7956,7 @@
           <p:cNvPr id="1" name="">
             <a:extLst xmlns:a="http://schemas.openxmlformats.org/drawingml/2006/main">
               <a:ext uri="{FF2B5EF4-FFF2-40B4-BE49-F238E27FC236}">
-                <a16:creationId xmlns:a16="http://schemas.microsoft.com/office/drawing/2014/main" id="{46F0C07D-5C9B-45F3-9792-7A3640E29E5D}"/>
+                <a16:creationId xmlns:a16="http://schemas.microsoft.com/office/drawing/2014/main" id="{40692E3D-E51A-47A8-A6D4-89EAA55D903A}"/>
               </a:ext>
             </a:extLst>
           </p:cNvPr>
@@ -7918,7 +8006,7 @@
           <p:cNvPr id="2" name="">
             <a:extLst xmlns:a="http://schemas.openxmlformats.org/drawingml/2006/main">
               <a:ext uri="{FF2B5EF4-FFF2-40B4-BE49-F238E27FC236}">
-                <a16:creationId xmlns:a16="http://schemas.microsoft.com/office/drawing/2014/main" id="{2A57E4EC-C1B7-4896-B4B6-DE0228D5BC77}"/>
+                <a16:creationId xmlns:a16="http://schemas.microsoft.com/office/drawing/2014/main" id="{59E7D877-FF09-4E56-ACCC-DE4F3180EB4F}"/>
               </a:ext>
             </a:extLst>
           </p:cNvPr>
@@ -7968,7 +8056,7 @@
           <p:cNvPr id="3" name="">
             <a:extLst xmlns:a="http://schemas.openxmlformats.org/drawingml/2006/main">
               <a:ext uri="{FF2B5EF4-FFF2-40B4-BE49-F238E27FC236}">
-                <a16:creationId xmlns:a16="http://schemas.microsoft.com/office/drawing/2014/main" id="{654ECCD5-A1BD-443D-84D7-35EA8071FD48}"/>
+                <a16:creationId xmlns:a16="http://schemas.microsoft.com/office/drawing/2014/main" id="{E3BEAFAE-D295-45C5-85A8-F2D9DDCC82D2}"/>
               </a:ext>
             </a:extLst>
           </p:cNvPr>
@@ -8018,7 +8106,7 @@
           <p:cNvPr id="4" name="">
             <a:extLst xmlns:a="http://schemas.openxmlformats.org/drawingml/2006/main">
               <a:ext uri="{FF2B5EF4-FFF2-40B4-BE49-F238E27FC236}">
-                <a16:creationId xmlns:a16="http://schemas.microsoft.com/office/drawing/2014/main" id="{3F68EA41-D9B4-4559-AAEC-092B7284B56F}"/>
+                <a16:creationId xmlns:a16="http://schemas.microsoft.com/office/drawing/2014/main" id="{B7EDA6A2-990E-4857-9D7E-0517D84BD165}"/>
               </a:ext>
             </a:extLst>
           </p:cNvPr>
@@ -8049,7 +8137,7 @@
           <p:cNvPr id="5" name="">
             <a:extLst xmlns:a="http://schemas.openxmlformats.org/drawingml/2006/main">
               <a:ext uri="{FF2B5EF4-FFF2-40B4-BE49-F238E27FC236}">
-                <a16:creationId xmlns:a16="http://schemas.microsoft.com/office/drawing/2014/main" id="{391D296F-00DC-4199-8A00-9FCC25E94162}"/>
+                <a16:creationId xmlns:a16="http://schemas.microsoft.com/office/drawing/2014/main" id="{63A63EA9-80A2-459A-84C7-520CB1CEFEBA}"/>
               </a:ext>
             </a:extLst>
           </p:cNvPr>
@@ -8105,7 +8193,7 @@
           <p:cNvPr id="6" name="">
             <a:extLst xmlns:a="http://schemas.openxmlformats.org/drawingml/2006/main">
               <a:ext uri="{FF2B5EF4-FFF2-40B4-BE49-F238E27FC236}">
-                <a16:creationId xmlns:a16="http://schemas.microsoft.com/office/drawing/2014/main" id="{443160AB-C56C-4DF3-82F8-F2BF72DB324E}"/>
+                <a16:creationId xmlns:a16="http://schemas.microsoft.com/office/drawing/2014/main" id="{1A1852A6-B5A5-42ED-8441-05C540A51904}"/>
               </a:ext>
             </a:extLst>
           </p:cNvPr>
@@ -8155,7 +8243,7 @@
           <p:cNvPr id="7" name="">
             <a:extLst xmlns:a="http://schemas.openxmlformats.org/drawingml/2006/main">
               <a:ext uri="{FF2B5EF4-FFF2-40B4-BE49-F238E27FC236}">
-                <a16:creationId xmlns:a16="http://schemas.microsoft.com/office/drawing/2014/main" id="{5BA24EA2-DF49-47D7-AB11-ACE0F4CD3827}"/>
+                <a16:creationId xmlns:a16="http://schemas.microsoft.com/office/drawing/2014/main" id="{8B43393F-6596-4E2D-9E09-FD38BEFFF164}"/>
               </a:ext>
             </a:extLst>
           </p:cNvPr>
@@ -8211,7 +8299,7 @@
           <p:cNvPr id="8" name="">
             <a:extLst xmlns:a="http://schemas.openxmlformats.org/drawingml/2006/main">
               <a:ext uri="{FF2B5EF4-FFF2-40B4-BE49-F238E27FC236}">
-                <a16:creationId xmlns:a16="http://schemas.microsoft.com/office/drawing/2014/main" id="{C3DCA214-5DE2-4EA4-BCDE-13CD8490576D}"/>
+                <a16:creationId xmlns:a16="http://schemas.microsoft.com/office/drawing/2014/main" id="{07A618D1-0515-415A-ABC4-0C89DB9B844F}"/>
               </a:ext>
             </a:extLst>
           </p:cNvPr>
@@ -8261,7 +8349,7 @@
           <p:cNvPr id="9" name="">
             <a:extLst xmlns:a="http://schemas.openxmlformats.org/drawingml/2006/main">
               <a:ext uri="{FF2B5EF4-FFF2-40B4-BE49-F238E27FC236}">
-                <a16:creationId xmlns:a16="http://schemas.microsoft.com/office/drawing/2014/main" id="{B9C6E0E7-C098-445E-80F6-9FC6FBA18F8E}"/>
+                <a16:creationId xmlns:a16="http://schemas.microsoft.com/office/drawing/2014/main" id="{6DD5B83F-5DE8-48AB-8F43-C23614BB4BC6}"/>
               </a:ext>
             </a:extLst>
           </p:cNvPr>
@@ -8311,7 +8399,7 @@
           <p:cNvPr id="10" name="">
             <a:extLst xmlns:a="http://schemas.openxmlformats.org/drawingml/2006/main">
               <a:ext uri="{FF2B5EF4-FFF2-40B4-BE49-F238E27FC236}">
-                <a16:creationId xmlns:a16="http://schemas.microsoft.com/office/drawing/2014/main" id="{2E678878-B74C-48FE-9F37-230D317DFDB1}"/>
+                <a16:creationId xmlns:a16="http://schemas.microsoft.com/office/drawing/2014/main" id="{085E3C8A-F542-4AF3-ACEB-F70FEB36A780}"/>
               </a:ext>
             </a:extLst>
           </p:cNvPr>
@@ -8361,7 +8449,7 @@
           <p:cNvPr id="11" name="">
             <a:extLst xmlns:a="http://schemas.openxmlformats.org/drawingml/2006/main">
               <a:ext uri="{FF2B5EF4-FFF2-40B4-BE49-F238E27FC236}">
-                <a16:creationId xmlns:a16="http://schemas.microsoft.com/office/drawing/2014/main" id="{376514F9-DB97-44DF-B991-11953DC9E407}"/>
+                <a16:creationId xmlns:a16="http://schemas.microsoft.com/office/drawing/2014/main" id="{8A0A8486-B4CE-4279-8E83-32D159F9EFD6}"/>
               </a:ext>
             </a:extLst>
           </p:cNvPr>
@@ -8392,7 +8480,7 @@
           <p:cNvPr id="12" name="">
             <a:extLst xmlns:a="http://schemas.openxmlformats.org/drawingml/2006/main">
               <a:ext uri="{FF2B5EF4-FFF2-40B4-BE49-F238E27FC236}">
-                <a16:creationId xmlns:a16="http://schemas.microsoft.com/office/drawing/2014/main" id="{BDC07C88-6636-43B2-9765-27FC90799EFD}"/>
+                <a16:creationId xmlns:a16="http://schemas.microsoft.com/office/drawing/2014/main" id="{65715C54-AAE4-47D6-BE52-4BD088C92D1C}"/>
               </a:ext>
             </a:extLst>
           </p:cNvPr>
@@ -8404,7 +8492,7 @@
         <p:spPr>
           <a:xfrm xmlns:a="http://schemas.openxmlformats.org/drawingml/2006/main">
             <a:off x="609600" y="6419850"/>
-            <a:ext cx="7810500" cy="209550"/>
+            <a:ext cx="4000500" cy="209550"/>
           </a:xfrm>
           <a:prstGeom xmlns:a="http://schemas.openxmlformats.org/drawingml/2006/main" prst="rect">
             <a:avLst/>
@@ -8432,7 +8520,7 @@
                   <a:srgbClr val="52615B"/>
                 </a:solidFill>
               </a:rPr>
-              <a:t>非公式資料 | Source: products/shopify-collective/architecture.md</a:t>
+              <a:t>Shopify Collective</a:t>
             </a:r>
           </a:p>
         </p:txBody>
@@ -8442,7 +8530,7 @@
           <p:cNvPr id="13" name="">
             <a:extLst xmlns:a="http://schemas.openxmlformats.org/drawingml/2006/main">
               <a:ext uri="{FF2B5EF4-FFF2-40B4-BE49-F238E27FC236}">
-                <a16:creationId xmlns:a16="http://schemas.microsoft.com/office/drawing/2014/main" id="{102B8764-A5D5-459E-83B7-194CF784624F}"/>
+                <a16:creationId xmlns:a16="http://schemas.microsoft.com/office/drawing/2014/main" id="{36A89FDF-A974-442C-870B-630A837EC33D}"/>
               </a:ext>
             </a:extLst>
           </p:cNvPr>
@@ -8490,7 +8578,7 @@
     </p:spTree>
     <p:extLst>
       <p:ext uri="{BB962C8B-B14F-4D97-AF65-F5344CB8AC3E}">
-        <p14:creationId xmlns:p14="http://schemas.microsoft.com/office/powerpoint/2010/main" val="1001339887"/>
+        <p14:creationId xmlns:p14="http://schemas.microsoft.com/office/powerpoint/2010/main" val="507634709"/>
       </p:ext>
     </p:extLst>
   </p:cSld>
@@ -8521,7 +8609,7 @@
           <p:cNvPr id="1" name="">
             <a:extLst xmlns:a="http://schemas.openxmlformats.org/drawingml/2006/main">
               <a:ext uri="{FF2B5EF4-FFF2-40B4-BE49-F238E27FC236}">
-                <a16:creationId xmlns:a16="http://schemas.microsoft.com/office/drawing/2014/main" id="{BCAA4350-7768-4AE3-A9D0-BFF6DC13F21B}"/>
+                <a16:creationId xmlns:a16="http://schemas.microsoft.com/office/drawing/2014/main" id="{B66B898E-E930-4424-962E-EFB9B2C559E7}"/>
               </a:ext>
             </a:extLst>
           </p:cNvPr>
@@ -8571,7 +8659,7 @@
           <p:cNvPr id="2" name="">
             <a:extLst xmlns:a="http://schemas.openxmlformats.org/drawingml/2006/main">
               <a:ext uri="{FF2B5EF4-FFF2-40B4-BE49-F238E27FC236}">
-                <a16:creationId xmlns:a16="http://schemas.microsoft.com/office/drawing/2014/main" id="{984E1FA8-9190-40EB-A676-0EDD44E7177A}"/>
+                <a16:creationId xmlns:a16="http://schemas.microsoft.com/office/drawing/2014/main" id="{AFFD2BEC-8ED3-4B1E-A798-01FB3FE9909B}"/>
               </a:ext>
             </a:extLst>
           </p:cNvPr>
@@ -8621,7 +8709,7 @@
           <p:cNvPr id="3" name="">
             <a:extLst xmlns:a="http://schemas.openxmlformats.org/drawingml/2006/main">
               <a:ext uri="{FF2B5EF4-FFF2-40B4-BE49-F238E27FC236}">
-                <a16:creationId xmlns:a16="http://schemas.microsoft.com/office/drawing/2014/main" id="{3A3EEFBB-A571-4E88-9ECB-4D0397C3D0B1}"/>
+                <a16:creationId xmlns:a16="http://schemas.microsoft.com/office/drawing/2014/main" id="{4207FAEB-AC93-4A0D-9152-FF0EBBC91C19}"/>
               </a:ext>
             </a:extLst>
           </p:cNvPr>
@@ -8671,7 +8759,7 @@
           <p:cNvPr id="4" name="">
             <a:extLst xmlns:a="http://schemas.openxmlformats.org/drawingml/2006/main">
               <a:ext uri="{FF2B5EF4-FFF2-40B4-BE49-F238E27FC236}">
-                <a16:creationId xmlns:a16="http://schemas.microsoft.com/office/drawing/2014/main" id="{E0291D24-EEED-4A28-9B3A-7680896391CA}"/>
+                <a16:creationId xmlns:a16="http://schemas.microsoft.com/office/drawing/2014/main" id="{2E685656-8CB0-40D3-B583-CF6BE17EAD99}"/>
               </a:ext>
             </a:extLst>
           </p:cNvPr>
@@ -8702,7 +8790,7 @@
           <p:cNvPr id="5" name="">
             <a:extLst xmlns:a="http://schemas.openxmlformats.org/drawingml/2006/main">
               <a:ext uri="{FF2B5EF4-FFF2-40B4-BE49-F238E27FC236}">
-                <a16:creationId xmlns:a16="http://schemas.microsoft.com/office/drawing/2014/main" id="{B364B0B6-0628-4AAB-A513-9B95DB7AF546}"/>
+                <a16:creationId xmlns:a16="http://schemas.microsoft.com/office/drawing/2014/main" id="{0719BFBA-0FEA-4C7F-86FB-75573B73A24A}"/>
               </a:ext>
             </a:extLst>
           </p:cNvPr>
@@ -8758,7 +8846,7 @@
           <p:cNvPr id="6" name="">
             <a:extLst xmlns:a="http://schemas.openxmlformats.org/drawingml/2006/main">
               <a:ext uri="{FF2B5EF4-FFF2-40B4-BE49-F238E27FC236}">
-                <a16:creationId xmlns:a16="http://schemas.microsoft.com/office/drawing/2014/main" id="{EA7663C1-FB88-47FB-A28A-27E0B8121302}"/>
+                <a16:creationId xmlns:a16="http://schemas.microsoft.com/office/drawing/2014/main" id="{3C0EFDA7-4963-4DAD-9D6B-EBBE6E99258C}"/>
               </a:ext>
             </a:extLst>
           </p:cNvPr>
@@ -8808,7 +8896,7 @@
           <p:cNvPr id="7" name="">
             <a:extLst xmlns:a="http://schemas.openxmlformats.org/drawingml/2006/main">
               <a:ext uri="{FF2B5EF4-FFF2-40B4-BE49-F238E27FC236}">
-                <a16:creationId xmlns:a16="http://schemas.microsoft.com/office/drawing/2014/main" id="{E3DB5607-3121-4A32-B540-F97CFA49682B}"/>
+                <a16:creationId xmlns:a16="http://schemas.microsoft.com/office/drawing/2014/main" id="{C34F8AB8-80FC-432D-B9F0-F94D61106F35}"/>
               </a:ext>
             </a:extLst>
           </p:cNvPr>
@@ -8858,7 +8946,7 @@
           <p:cNvPr id="8" name="">
             <a:extLst xmlns:a="http://schemas.openxmlformats.org/drawingml/2006/main">
               <a:ext uri="{FF2B5EF4-FFF2-40B4-BE49-F238E27FC236}">
-                <a16:creationId xmlns:a16="http://schemas.microsoft.com/office/drawing/2014/main" id="{F583ECE2-B81D-40F7-9D5C-D0ACA27058B6}"/>
+                <a16:creationId xmlns:a16="http://schemas.microsoft.com/office/drawing/2014/main" id="{C4EDFEE7-BAFD-443B-9674-BC4745391841}"/>
               </a:ext>
             </a:extLst>
           </p:cNvPr>
@@ -8908,7 +8996,7 @@
           <p:cNvPr id="9" name="">
             <a:extLst xmlns:a="http://schemas.openxmlformats.org/drawingml/2006/main">
               <a:ext uri="{FF2B5EF4-FFF2-40B4-BE49-F238E27FC236}">
-                <a16:creationId xmlns:a16="http://schemas.microsoft.com/office/drawing/2014/main" id="{2F8A4C77-C437-42C5-9321-12BEA5B50986}"/>
+                <a16:creationId xmlns:a16="http://schemas.microsoft.com/office/drawing/2014/main" id="{8ABAC611-46E9-4D67-81E9-B0A6D1DE6253}"/>
               </a:ext>
             </a:extLst>
           </p:cNvPr>
@@ -8964,7 +9052,7 @@
           <p:cNvPr id="10" name="">
             <a:extLst xmlns:a="http://schemas.openxmlformats.org/drawingml/2006/main">
               <a:ext uri="{FF2B5EF4-FFF2-40B4-BE49-F238E27FC236}">
-                <a16:creationId xmlns:a16="http://schemas.microsoft.com/office/drawing/2014/main" id="{E66FBFAA-A952-4E84-8BE8-6B568E3F6638}"/>
+                <a16:creationId xmlns:a16="http://schemas.microsoft.com/office/drawing/2014/main" id="{1D404FA9-9E2F-4ABC-842E-7DB777603A61}"/>
               </a:ext>
             </a:extLst>
           </p:cNvPr>
@@ -9014,7 +9102,7 @@
           <p:cNvPr id="11" name="">
             <a:extLst xmlns:a="http://schemas.openxmlformats.org/drawingml/2006/main">
               <a:ext uri="{FF2B5EF4-FFF2-40B4-BE49-F238E27FC236}">
-                <a16:creationId xmlns:a16="http://schemas.microsoft.com/office/drawing/2014/main" id="{EEB137C1-3780-4328-B60A-D1839FC0AAB3}"/>
+                <a16:creationId xmlns:a16="http://schemas.microsoft.com/office/drawing/2014/main" id="{D62D701F-3238-443D-9FF1-E682BFA3D834}"/>
               </a:ext>
             </a:extLst>
           </p:cNvPr>
@@ -9064,7 +9152,7 @@
           <p:cNvPr id="12" name="">
             <a:extLst xmlns:a="http://schemas.openxmlformats.org/drawingml/2006/main">
               <a:ext uri="{FF2B5EF4-FFF2-40B4-BE49-F238E27FC236}">
-                <a16:creationId xmlns:a16="http://schemas.microsoft.com/office/drawing/2014/main" id="{3F35D541-3D8A-4026-A622-D970BE590728}"/>
+                <a16:creationId xmlns:a16="http://schemas.microsoft.com/office/drawing/2014/main" id="{07A27564-CBA3-4239-938C-8158FFE97CFE}"/>
               </a:ext>
             </a:extLst>
           </p:cNvPr>
@@ -9114,7 +9202,7 @@
           <p:cNvPr id="13" name="">
             <a:extLst xmlns:a="http://schemas.openxmlformats.org/drawingml/2006/main">
               <a:ext uri="{FF2B5EF4-FFF2-40B4-BE49-F238E27FC236}">
-                <a16:creationId xmlns:a16="http://schemas.microsoft.com/office/drawing/2014/main" id="{C8101B23-6BD6-43ED-9ACA-FA04B7884E1C}"/>
+                <a16:creationId xmlns:a16="http://schemas.microsoft.com/office/drawing/2014/main" id="{C72E88CA-1A25-483B-A066-7D957BEF6C2C}"/>
               </a:ext>
             </a:extLst>
           </p:cNvPr>
@@ -9170,7 +9258,7 @@
           <p:cNvPr id="14" name="">
             <a:extLst xmlns:a="http://schemas.openxmlformats.org/drawingml/2006/main">
               <a:ext uri="{FF2B5EF4-FFF2-40B4-BE49-F238E27FC236}">
-                <a16:creationId xmlns:a16="http://schemas.microsoft.com/office/drawing/2014/main" id="{6E4E2B40-4ABB-4B9C-839C-E0E79515889F}"/>
+                <a16:creationId xmlns:a16="http://schemas.microsoft.com/office/drawing/2014/main" id="{36CB69AC-E66C-490C-895F-B1A15DEFEF48}"/>
               </a:ext>
             </a:extLst>
           </p:cNvPr>
@@ -9220,7 +9308,7 @@
           <p:cNvPr id="15" name="">
             <a:extLst xmlns:a="http://schemas.openxmlformats.org/drawingml/2006/main">
               <a:ext uri="{FF2B5EF4-FFF2-40B4-BE49-F238E27FC236}">
-                <a16:creationId xmlns:a16="http://schemas.microsoft.com/office/drawing/2014/main" id="{C52379B5-5547-4813-B416-2762C252F311}"/>
+                <a16:creationId xmlns:a16="http://schemas.microsoft.com/office/drawing/2014/main" id="{2107DDB6-3DFB-45DD-83EC-2732B912A121}"/>
               </a:ext>
             </a:extLst>
           </p:cNvPr>
@@ -9270,7 +9358,7 @@
           <p:cNvPr id="16" name="">
             <a:extLst xmlns:a="http://schemas.openxmlformats.org/drawingml/2006/main">
               <a:ext uri="{FF2B5EF4-FFF2-40B4-BE49-F238E27FC236}">
-                <a16:creationId xmlns:a16="http://schemas.microsoft.com/office/drawing/2014/main" id="{BA6745A8-4999-4750-A2F6-54FA694FEDBF}"/>
+                <a16:creationId xmlns:a16="http://schemas.microsoft.com/office/drawing/2014/main" id="{F639A0E5-5B21-4CCF-9BFC-EB51701A4D20}"/>
               </a:ext>
             </a:extLst>
           </p:cNvPr>
@@ -9320,7 +9408,7 @@
           <p:cNvPr id="17" name="">
             <a:extLst xmlns:a="http://schemas.openxmlformats.org/drawingml/2006/main">
               <a:ext uri="{FF2B5EF4-FFF2-40B4-BE49-F238E27FC236}">
-                <a16:creationId xmlns:a16="http://schemas.microsoft.com/office/drawing/2014/main" id="{EC5B0289-605D-42BB-9783-0D5F79B5CDB6}"/>
+                <a16:creationId xmlns:a16="http://schemas.microsoft.com/office/drawing/2014/main" id="{619A0651-CDF1-44EF-A2DC-6D1EF7904A34}"/>
               </a:ext>
             </a:extLst>
           </p:cNvPr>
@@ -9376,7 +9464,7 @@
           <p:cNvPr id="18" name="">
             <a:extLst xmlns:a="http://schemas.openxmlformats.org/drawingml/2006/main">
               <a:ext uri="{FF2B5EF4-FFF2-40B4-BE49-F238E27FC236}">
-                <a16:creationId xmlns:a16="http://schemas.microsoft.com/office/drawing/2014/main" id="{6C439494-6453-4A60-9374-D6A2ADCE6E96}"/>
+                <a16:creationId xmlns:a16="http://schemas.microsoft.com/office/drawing/2014/main" id="{BA8DF578-55C2-4359-A8C6-59AD1D160AC1}"/>
               </a:ext>
             </a:extLst>
           </p:cNvPr>
@@ -9426,7 +9514,7 @@
           <p:cNvPr id="19" name="">
             <a:extLst xmlns:a="http://schemas.openxmlformats.org/drawingml/2006/main">
               <a:ext uri="{FF2B5EF4-FFF2-40B4-BE49-F238E27FC236}">
-                <a16:creationId xmlns:a16="http://schemas.microsoft.com/office/drawing/2014/main" id="{261F550B-AA56-4FC6-A9D0-35F5C5AD7A0D}"/>
+                <a16:creationId xmlns:a16="http://schemas.microsoft.com/office/drawing/2014/main" id="{410903D1-EDBC-4D06-968B-FEAC19458D98}"/>
               </a:ext>
             </a:extLst>
           </p:cNvPr>
@@ -9476,7 +9564,7 @@
           <p:cNvPr id="20" name="">
             <a:extLst xmlns:a="http://schemas.openxmlformats.org/drawingml/2006/main">
               <a:ext uri="{FF2B5EF4-FFF2-40B4-BE49-F238E27FC236}">
-                <a16:creationId xmlns:a16="http://schemas.microsoft.com/office/drawing/2014/main" id="{FD41D7C3-D0F1-443F-A826-CE92EC11070E}"/>
+                <a16:creationId xmlns:a16="http://schemas.microsoft.com/office/drawing/2014/main" id="{B9F9D4F6-9481-46E3-8C40-E6305117DAE5}"/>
               </a:ext>
             </a:extLst>
           </p:cNvPr>
@@ -9526,7 +9614,7 @@
           <p:cNvPr id="21" name="">
             <a:extLst xmlns:a="http://schemas.openxmlformats.org/drawingml/2006/main">
               <a:ext uri="{FF2B5EF4-FFF2-40B4-BE49-F238E27FC236}">
-                <a16:creationId xmlns:a16="http://schemas.microsoft.com/office/drawing/2014/main" id="{348D82B0-D30D-4592-B3F7-0A683FD7BBA0}"/>
+                <a16:creationId xmlns:a16="http://schemas.microsoft.com/office/drawing/2014/main" id="{AA47D1AC-26A0-4C50-9A63-2FBCA995C228}"/>
               </a:ext>
             </a:extLst>
           </p:cNvPr>
@@ -9582,7 +9670,7 @@
           <p:cNvPr id="22" name="">
             <a:extLst xmlns:a="http://schemas.openxmlformats.org/drawingml/2006/main">
               <a:ext uri="{FF2B5EF4-FFF2-40B4-BE49-F238E27FC236}">
-                <a16:creationId xmlns:a16="http://schemas.microsoft.com/office/drawing/2014/main" id="{2B2CCA14-7E7D-4101-BAD1-8F350B4D3B0A}"/>
+                <a16:creationId xmlns:a16="http://schemas.microsoft.com/office/drawing/2014/main" id="{D650E7C6-DD9A-4CDD-B2CF-1283FF247780}"/>
               </a:ext>
             </a:extLst>
           </p:cNvPr>
@@ -9632,7 +9720,7 @@
           <p:cNvPr id="23" name="">
             <a:extLst xmlns:a="http://schemas.openxmlformats.org/drawingml/2006/main">
               <a:ext uri="{FF2B5EF4-FFF2-40B4-BE49-F238E27FC236}">
-                <a16:creationId xmlns:a16="http://schemas.microsoft.com/office/drawing/2014/main" id="{75E85410-C84C-4CCD-A59D-4D36DA9D1021}"/>
+                <a16:creationId xmlns:a16="http://schemas.microsoft.com/office/drawing/2014/main" id="{A5C1EC7B-FF8F-469D-9B24-AFF294C03639}"/>
               </a:ext>
             </a:extLst>
           </p:cNvPr>
@@ -9682,7 +9770,7 @@
           <p:cNvPr id="24" name="">
             <a:extLst xmlns:a="http://schemas.openxmlformats.org/drawingml/2006/main">
               <a:ext uri="{FF2B5EF4-FFF2-40B4-BE49-F238E27FC236}">
-                <a16:creationId xmlns:a16="http://schemas.microsoft.com/office/drawing/2014/main" id="{AA057C64-A857-496B-A8EF-81175049D687}"/>
+                <a16:creationId xmlns:a16="http://schemas.microsoft.com/office/drawing/2014/main" id="{F6DD93AF-5D6F-4B2A-969F-EB6D84DEBC53}"/>
               </a:ext>
             </a:extLst>
           </p:cNvPr>
@@ -9713,7 +9801,7 @@
           <p:cNvPr id="25" name="">
             <a:extLst xmlns:a="http://schemas.openxmlformats.org/drawingml/2006/main">
               <a:ext uri="{FF2B5EF4-FFF2-40B4-BE49-F238E27FC236}">
-                <a16:creationId xmlns:a16="http://schemas.microsoft.com/office/drawing/2014/main" id="{542C7FBE-6B28-4C29-A54C-270FFFE5D082}"/>
+                <a16:creationId xmlns:a16="http://schemas.microsoft.com/office/drawing/2014/main" id="{92DDE993-0A98-460A-9C5D-96D8D72527A7}"/>
               </a:ext>
             </a:extLst>
           </p:cNvPr>
@@ -9725,7 +9813,7 @@
         <p:spPr>
           <a:xfrm xmlns:a="http://schemas.openxmlformats.org/drawingml/2006/main">
             <a:off x="609600" y="6419850"/>
-            <a:ext cx="7810500" cy="209550"/>
+            <a:ext cx="4000500" cy="209550"/>
           </a:xfrm>
           <a:prstGeom xmlns:a="http://schemas.openxmlformats.org/drawingml/2006/main" prst="rect">
             <a:avLst/>
@@ -9753,7 +9841,7 @@
                   <a:srgbClr val="52615B"/>
                 </a:solidFill>
               </a:rPr>
-              <a:t>非公式資料 | Source: products/shopify-collective/architecture.md</a:t>
+              <a:t>Shopify Collective</a:t>
             </a:r>
           </a:p>
         </p:txBody>
@@ -9763,7 +9851,7 @@
           <p:cNvPr id="26" name="">
             <a:extLst xmlns:a="http://schemas.openxmlformats.org/drawingml/2006/main">
               <a:ext uri="{FF2B5EF4-FFF2-40B4-BE49-F238E27FC236}">
-                <a16:creationId xmlns:a16="http://schemas.microsoft.com/office/drawing/2014/main" id="{B5728668-174C-4DA3-A449-10591BAB85E0}"/>
+                <a16:creationId xmlns:a16="http://schemas.microsoft.com/office/drawing/2014/main" id="{5632C503-5F92-4654-A5B3-AB968E1BFA96}"/>
               </a:ext>
             </a:extLst>
           </p:cNvPr>
@@ -9811,7 +9899,7 @@
     </p:spTree>
     <p:extLst>
       <p:ext uri="{BB962C8B-B14F-4D97-AF65-F5344CB8AC3E}">
-        <p14:creationId xmlns:p14="http://schemas.microsoft.com/office/powerpoint/2010/main" val="378678734"/>
+        <p14:creationId xmlns:p14="http://schemas.microsoft.com/office/powerpoint/2010/main" val="2049739093"/>
       </p:ext>
     </p:extLst>
   </p:cSld>
@@ -9842,7 +9930,7 @@
           <p:cNvPr id="1" name="">
             <a:extLst xmlns:a="http://schemas.openxmlformats.org/drawingml/2006/main">
               <a:ext uri="{FF2B5EF4-FFF2-40B4-BE49-F238E27FC236}">
-                <a16:creationId xmlns:a16="http://schemas.microsoft.com/office/drawing/2014/main" id="{EB2B872A-DC51-46C5-B829-B67CA61056A4}"/>
+                <a16:creationId xmlns:a16="http://schemas.microsoft.com/office/drawing/2014/main" id="{95D93093-2EFE-4020-AE17-5FCFA36717A0}"/>
               </a:ext>
             </a:extLst>
           </p:cNvPr>
@@ -9892,7 +9980,7 @@
           <p:cNvPr id="2" name="">
             <a:extLst xmlns:a="http://schemas.openxmlformats.org/drawingml/2006/main">
               <a:ext uri="{FF2B5EF4-FFF2-40B4-BE49-F238E27FC236}">
-                <a16:creationId xmlns:a16="http://schemas.microsoft.com/office/drawing/2014/main" id="{12D93C33-D887-4688-AA6A-03C03B90CF1B}"/>
+                <a16:creationId xmlns:a16="http://schemas.microsoft.com/office/drawing/2014/main" id="{CD8771BB-5457-49C4-93D0-2A3B8B22A95E}"/>
               </a:ext>
             </a:extLst>
           </p:cNvPr>
@@ -9942,7 +10030,7 @@
           <p:cNvPr id="3" name="">
             <a:extLst xmlns:a="http://schemas.openxmlformats.org/drawingml/2006/main">
               <a:ext uri="{FF2B5EF4-FFF2-40B4-BE49-F238E27FC236}">
-                <a16:creationId xmlns:a16="http://schemas.microsoft.com/office/drawing/2014/main" id="{6083A1BF-254C-4343-BD58-62959D3F4651}"/>
+                <a16:creationId xmlns:a16="http://schemas.microsoft.com/office/drawing/2014/main" id="{699CFC64-BD2C-4F85-BE43-3C1A3161D967}"/>
               </a:ext>
             </a:extLst>
           </p:cNvPr>
@@ -9992,7 +10080,7 @@
           <p:cNvPr id="4" name="">
             <a:extLst xmlns:a="http://schemas.openxmlformats.org/drawingml/2006/main">
               <a:ext uri="{FF2B5EF4-FFF2-40B4-BE49-F238E27FC236}">
-                <a16:creationId xmlns:a16="http://schemas.microsoft.com/office/drawing/2014/main" id="{294275B2-1EDB-48DA-80A6-AD72E534FF7F}"/>
+                <a16:creationId xmlns:a16="http://schemas.microsoft.com/office/drawing/2014/main" id="{BD43482F-ED8D-4642-B05D-8EA123A18CE2}"/>
               </a:ext>
             </a:extLst>
           </p:cNvPr>
@@ -10023,7 +10111,7 @@
           <p:cNvPr id="5" name="">
             <a:extLst xmlns:a="http://schemas.openxmlformats.org/drawingml/2006/main">
               <a:ext uri="{FF2B5EF4-FFF2-40B4-BE49-F238E27FC236}">
-                <a16:creationId xmlns:a16="http://schemas.microsoft.com/office/drawing/2014/main" id="{13AFA6B6-F25E-4BC8-A076-BBE78E4F2B83}"/>
+                <a16:creationId xmlns:a16="http://schemas.microsoft.com/office/drawing/2014/main" id="{E099A51C-EB67-443E-82A2-C960CCD2C9F0}"/>
               </a:ext>
             </a:extLst>
           </p:cNvPr>
@@ -10079,7 +10167,7 @@
           <p:cNvPr id="6" name="">
             <a:extLst xmlns:a="http://schemas.openxmlformats.org/drawingml/2006/main">
               <a:ext uri="{FF2B5EF4-FFF2-40B4-BE49-F238E27FC236}">
-                <a16:creationId xmlns:a16="http://schemas.microsoft.com/office/drawing/2014/main" id="{C6F467D5-DC1E-42F0-BE64-390B1F8524EC}"/>
+                <a16:creationId xmlns:a16="http://schemas.microsoft.com/office/drawing/2014/main" id="{5B341291-C045-4BE5-B905-8FB379173CC9}"/>
               </a:ext>
             </a:extLst>
           </p:cNvPr>
@@ -10129,7 +10217,7 @@
           <p:cNvPr id="7" name="">
             <a:extLst xmlns:a="http://schemas.openxmlformats.org/drawingml/2006/main">
               <a:ext uri="{FF2B5EF4-FFF2-40B4-BE49-F238E27FC236}">
-                <a16:creationId xmlns:a16="http://schemas.microsoft.com/office/drawing/2014/main" id="{8A04B423-5326-4D75-8AA6-F228BB3CD958}"/>
+                <a16:creationId xmlns:a16="http://schemas.microsoft.com/office/drawing/2014/main" id="{177E9351-C4F4-489F-B252-F8B15629F472}"/>
               </a:ext>
             </a:extLst>
           </p:cNvPr>
@@ -10179,7 +10267,7 @@
           <p:cNvPr id="8" name="">
             <a:extLst xmlns:a="http://schemas.openxmlformats.org/drawingml/2006/main">
               <a:ext uri="{FF2B5EF4-FFF2-40B4-BE49-F238E27FC236}">
-                <a16:creationId xmlns:a16="http://schemas.microsoft.com/office/drawing/2014/main" id="{F7917486-1333-454A-AEE3-0C3F21811588}"/>
+                <a16:creationId xmlns:a16="http://schemas.microsoft.com/office/drawing/2014/main" id="{2CAF2738-F500-4B67-ACCF-A474402268EF}"/>
               </a:ext>
             </a:extLst>
           </p:cNvPr>
@@ -10229,7 +10317,7 @@
           <p:cNvPr id="9" name="">
             <a:extLst xmlns:a="http://schemas.openxmlformats.org/drawingml/2006/main">
               <a:ext uri="{FF2B5EF4-FFF2-40B4-BE49-F238E27FC236}">
-                <a16:creationId xmlns:a16="http://schemas.microsoft.com/office/drawing/2014/main" id="{D0A6F388-8878-4CB8-9FD6-710C3773BAB7}"/>
+                <a16:creationId xmlns:a16="http://schemas.microsoft.com/office/drawing/2014/main" id="{5A2858A0-029D-47C3-B353-439B7335018D}"/>
               </a:ext>
             </a:extLst>
           </p:cNvPr>
@@ -10285,7 +10373,7 @@
           <p:cNvPr id="10" name="">
             <a:extLst xmlns:a="http://schemas.openxmlformats.org/drawingml/2006/main">
               <a:ext uri="{FF2B5EF4-FFF2-40B4-BE49-F238E27FC236}">
-                <a16:creationId xmlns:a16="http://schemas.microsoft.com/office/drawing/2014/main" id="{C729C3A9-9392-4C2D-A340-AFE5B8278F94}"/>
+                <a16:creationId xmlns:a16="http://schemas.microsoft.com/office/drawing/2014/main" id="{41A31A82-2A03-4C5F-8D6A-A0C5D708FB12}"/>
               </a:ext>
             </a:extLst>
           </p:cNvPr>
@@ -10335,7 +10423,7 @@
           <p:cNvPr id="11" name="">
             <a:extLst xmlns:a="http://schemas.openxmlformats.org/drawingml/2006/main">
               <a:ext uri="{FF2B5EF4-FFF2-40B4-BE49-F238E27FC236}">
-                <a16:creationId xmlns:a16="http://schemas.microsoft.com/office/drawing/2014/main" id="{83947D67-6607-491B-81EE-E9FE4BBD0870}"/>
+                <a16:creationId xmlns:a16="http://schemas.microsoft.com/office/drawing/2014/main" id="{30CFBAB9-4C8A-48CB-97A4-8F42DE6DE266}"/>
               </a:ext>
             </a:extLst>
           </p:cNvPr>
@@ -10385,7 +10473,7 @@
           <p:cNvPr id="12" name="">
             <a:extLst xmlns:a="http://schemas.openxmlformats.org/drawingml/2006/main">
               <a:ext uri="{FF2B5EF4-FFF2-40B4-BE49-F238E27FC236}">
-                <a16:creationId xmlns:a16="http://schemas.microsoft.com/office/drawing/2014/main" id="{478073F3-E34D-4C67-98A7-7856BDA16728}"/>
+                <a16:creationId xmlns:a16="http://schemas.microsoft.com/office/drawing/2014/main" id="{63B2A919-F905-4687-AC08-686943EC6B80}"/>
               </a:ext>
             </a:extLst>
           </p:cNvPr>
@@ -10435,7 +10523,7 @@
           <p:cNvPr id="13" name="">
             <a:extLst xmlns:a="http://schemas.openxmlformats.org/drawingml/2006/main">
               <a:ext uri="{FF2B5EF4-FFF2-40B4-BE49-F238E27FC236}">
-                <a16:creationId xmlns:a16="http://schemas.microsoft.com/office/drawing/2014/main" id="{E2969A91-21FA-4FB5-B1C9-628B5715E663}"/>
+                <a16:creationId xmlns:a16="http://schemas.microsoft.com/office/drawing/2014/main" id="{B0FBC1FF-1EA0-4BB9-8FF0-7D131D1EB81D}"/>
               </a:ext>
             </a:extLst>
           </p:cNvPr>
@@ -10491,7 +10579,7 @@
           <p:cNvPr id="14" name="">
             <a:extLst xmlns:a="http://schemas.openxmlformats.org/drawingml/2006/main">
               <a:ext uri="{FF2B5EF4-FFF2-40B4-BE49-F238E27FC236}">
-                <a16:creationId xmlns:a16="http://schemas.microsoft.com/office/drawing/2014/main" id="{9A7EDAAE-BBAC-4076-BD23-7AEA86409B72}"/>
+                <a16:creationId xmlns:a16="http://schemas.microsoft.com/office/drawing/2014/main" id="{39A4ABD6-9283-4784-BCA0-22061999BF85}"/>
               </a:ext>
             </a:extLst>
           </p:cNvPr>
@@ -10541,7 +10629,7 @@
           <p:cNvPr id="15" name="">
             <a:extLst xmlns:a="http://schemas.openxmlformats.org/drawingml/2006/main">
               <a:ext uri="{FF2B5EF4-FFF2-40B4-BE49-F238E27FC236}">
-                <a16:creationId xmlns:a16="http://schemas.microsoft.com/office/drawing/2014/main" id="{863E248A-3F7C-4DE2-B3F0-509D3390D0AC}"/>
+                <a16:creationId xmlns:a16="http://schemas.microsoft.com/office/drawing/2014/main" id="{3051B781-7228-475A-8CB7-F6775392275A}"/>
               </a:ext>
             </a:extLst>
           </p:cNvPr>
@@ -10581,7 +10669,7 @@
                   <a:srgbClr val="52615B"/>
                 </a:solidFill>
               </a:rPr>
-              <a:t>shopifyPaymentsAccount adjustmentsをassociated orderで確認できます。</a:t>
+              <a:t>関連注文のShopify Payments残高調整として確認できます。</a:t>
             </a:r>
           </a:p>
         </p:txBody>
@@ -10591,7 +10679,7 @@
           <p:cNvPr id="16" name="">
             <a:extLst xmlns:a="http://schemas.openxmlformats.org/drawingml/2006/main">
               <a:ext uri="{FF2B5EF4-FFF2-40B4-BE49-F238E27FC236}">
-                <a16:creationId xmlns:a16="http://schemas.microsoft.com/office/drawing/2014/main" id="{A0D538BE-DD14-4FAE-B599-04DB33019BDC}"/>
+                <a16:creationId xmlns:a16="http://schemas.microsoft.com/office/drawing/2014/main" id="{DEE8B329-C221-4BE2-8603-1AF5AAC8EA73}"/>
               </a:ext>
             </a:extLst>
           </p:cNvPr>
@@ -10641,7 +10729,7 @@
           <p:cNvPr id="17" name="">
             <a:extLst xmlns:a="http://schemas.openxmlformats.org/drawingml/2006/main">
               <a:ext uri="{FF2B5EF4-FFF2-40B4-BE49-F238E27FC236}">
-                <a16:creationId xmlns:a16="http://schemas.microsoft.com/office/drawing/2014/main" id="{46DD1761-6A59-44BA-BA95-38C1F0D6F0A1}"/>
+                <a16:creationId xmlns:a16="http://schemas.microsoft.com/office/drawing/2014/main" id="{15C002D7-118F-41A5-B375-5A8AF1763859}"/>
               </a:ext>
             </a:extLst>
           </p:cNvPr>
@@ -10697,7 +10785,7 @@
           <p:cNvPr id="18" name="">
             <a:extLst xmlns:a="http://schemas.openxmlformats.org/drawingml/2006/main">
               <a:ext uri="{FF2B5EF4-FFF2-40B4-BE49-F238E27FC236}">
-                <a16:creationId xmlns:a16="http://schemas.microsoft.com/office/drawing/2014/main" id="{C1CEE0A4-E825-4E59-B732-037BEDAE982C}"/>
+                <a16:creationId xmlns:a16="http://schemas.microsoft.com/office/drawing/2014/main" id="{142C0679-9F56-4E20-9C87-4E9E049B712B}"/>
               </a:ext>
             </a:extLst>
           </p:cNvPr>
@@ -10747,7 +10835,7 @@
           <p:cNvPr id="19" name="">
             <a:extLst xmlns:a="http://schemas.openxmlformats.org/drawingml/2006/main">
               <a:ext uri="{FF2B5EF4-FFF2-40B4-BE49-F238E27FC236}">
-                <a16:creationId xmlns:a16="http://schemas.microsoft.com/office/drawing/2014/main" id="{37A5D5A5-8D19-4B66-B931-1EBF4EC69AB3}"/>
+                <a16:creationId xmlns:a16="http://schemas.microsoft.com/office/drawing/2014/main" id="{768548D4-D821-48DA-8461-83941AA78095}"/>
               </a:ext>
             </a:extLst>
           </p:cNvPr>
@@ -10797,7 +10885,7 @@
           <p:cNvPr id="20" name="">
             <a:extLst xmlns:a="http://schemas.openxmlformats.org/drawingml/2006/main">
               <a:ext uri="{FF2B5EF4-FFF2-40B4-BE49-F238E27FC236}">
-                <a16:creationId xmlns:a16="http://schemas.microsoft.com/office/drawing/2014/main" id="{4B67C5BA-4456-496E-83D7-6ABA50D3096A}"/>
+                <a16:creationId xmlns:a16="http://schemas.microsoft.com/office/drawing/2014/main" id="{3575F1F8-096F-4D32-9924-1D42EB8271A8}"/>
               </a:ext>
             </a:extLst>
           </p:cNvPr>
@@ -10828,7 +10916,7 @@
           <p:cNvPr id="21" name="">
             <a:extLst xmlns:a="http://schemas.openxmlformats.org/drawingml/2006/main">
               <a:ext uri="{FF2B5EF4-FFF2-40B4-BE49-F238E27FC236}">
-                <a16:creationId xmlns:a16="http://schemas.microsoft.com/office/drawing/2014/main" id="{1C3C96A7-5B26-4B32-A50A-EFDA1AF3E7C7}"/>
+                <a16:creationId xmlns:a16="http://schemas.microsoft.com/office/drawing/2014/main" id="{3BBCD8FC-7BE5-42BC-8A68-675B05C0B16B}"/>
               </a:ext>
             </a:extLst>
           </p:cNvPr>
@@ -10840,7 +10928,7 @@
         <p:spPr>
           <a:xfrm xmlns:a="http://schemas.openxmlformats.org/drawingml/2006/main">
             <a:off x="609600" y="6419850"/>
-            <a:ext cx="7810500" cy="209550"/>
+            <a:ext cx="4000500" cy="209550"/>
           </a:xfrm>
           <a:prstGeom xmlns:a="http://schemas.openxmlformats.org/drawingml/2006/main" prst="rect">
             <a:avLst/>
@@ -10868,7 +10956,7 @@
                   <a:srgbClr val="52615B"/>
                 </a:solidFill>
               </a:rPr>
-              <a:t>非公式資料 | Source: products/shopify-collective/architecture.md</a:t>
+              <a:t>Shopify Collective</a:t>
             </a:r>
           </a:p>
         </p:txBody>
@@ -10878,7 +10966,7 @@
           <p:cNvPr id="22" name="">
             <a:extLst xmlns:a="http://schemas.openxmlformats.org/drawingml/2006/main">
               <a:ext uri="{FF2B5EF4-FFF2-40B4-BE49-F238E27FC236}">
-                <a16:creationId xmlns:a16="http://schemas.microsoft.com/office/drawing/2014/main" id="{C85D6847-C216-4ECB-A63A-F0A35E465601}"/>
+                <a16:creationId xmlns:a16="http://schemas.microsoft.com/office/drawing/2014/main" id="{886E38F5-680D-4845-932B-A58F0C6E6AC9}"/>
               </a:ext>
             </a:extLst>
           </p:cNvPr>
@@ -10926,7 +11014,7 @@
     </p:spTree>
     <p:extLst>
       <p:ext uri="{BB962C8B-B14F-4D97-AF65-F5344CB8AC3E}">
-        <p14:creationId xmlns:p14="http://schemas.microsoft.com/office/powerpoint/2010/main" val="1607058917"/>
+        <p14:creationId xmlns:p14="http://schemas.microsoft.com/office/powerpoint/2010/main" val="2011813926"/>
       </p:ext>
     </p:extLst>
   </p:cSld>
@@ -10957,7 +11045,7 @@
           <p:cNvPr id="1" name="">
             <a:extLst xmlns:a="http://schemas.openxmlformats.org/drawingml/2006/main">
               <a:ext uri="{FF2B5EF4-FFF2-40B4-BE49-F238E27FC236}">
-                <a16:creationId xmlns:a16="http://schemas.microsoft.com/office/drawing/2014/main" id="{524659B9-3093-4C6A-83AD-6AA97FADD2CF}"/>
+                <a16:creationId xmlns:a16="http://schemas.microsoft.com/office/drawing/2014/main" id="{2799BA31-2B2B-459A-B2B7-54489FB00BAE}"/>
               </a:ext>
             </a:extLst>
           </p:cNvPr>
@@ -11007,7 +11095,7 @@
           <p:cNvPr id="2" name="">
             <a:extLst xmlns:a="http://schemas.openxmlformats.org/drawingml/2006/main">
               <a:ext uri="{FF2B5EF4-FFF2-40B4-BE49-F238E27FC236}">
-                <a16:creationId xmlns:a16="http://schemas.microsoft.com/office/drawing/2014/main" id="{E849FAA5-92EB-4B32-A181-F2748A296A43}"/>
+                <a16:creationId xmlns:a16="http://schemas.microsoft.com/office/drawing/2014/main" id="{422795C9-42F3-4075-823B-F30A1D54D6D0}"/>
               </a:ext>
             </a:extLst>
           </p:cNvPr>
@@ -11057,7 +11145,7 @@
           <p:cNvPr id="3" name="">
             <a:extLst xmlns:a="http://schemas.openxmlformats.org/drawingml/2006/main">
               <a:ext uri="{FF2B5EF4-FFF2-40B4-BE49-F238E27FC236}">
-                <a16:creationId xmlns:a16="http://schemas.microsoft.com/office/drawing/2014/main" id="{DF687EF4-232F-469D-9CA9-5FAA54C89983}"/>
+                <a16:creationId xmlns:a16="http://schemas.microsoft.com/office/drawing/2014/main" id="{21FE6A08-6652-4A83-9BB3-CE84CEAF8994}"/>
               </a:ext>
             </a:extLst>
           </p:cNvPr>
@@ -11107,7 +11195,7 @@
           <p:cNvPr id="4" name="">
             <a:extLst xmlns:a="http://schemas.openxmlformats.org/drawingml/2006/main">
               <a:ext uri="{FF2B5EF4-FFF2-40B4-BE49-F238E27FC236}">
-                <a16:creationId xmlns:a16="http://schemas.microsoft.com/office/drawing/2014/main" id="{57C27284-5E5E-47E6-86CF-8928A42FB7E1}"/>
+                <a16:creationId xmlns:a16="http://schemas.microsoft.com/office/drawing/2014/main" id="{4F0ADF1C-C5C2-4C48-9BF7-182575C9BF25}"/>
               </a:ext>
             </a:extLst>
           </p:cNvPr>
@@ -11138,7 +11226,7 @@
           <p:cNvPr id="5" name="">
             <a:extLst xmlns:a="http://schemas.openxmlformats.org/drawingml/2006/main">
               <a:ext uri="{FF2B5EF4-FFF2-40B4-BE49-F238E27FC236}">
-                <a16:creationId xmlns:a16="http://schemas.microsoft.com/office/drawing/2014/main" id="{050FB0B9-38AC-4E84-BC44-06E6C31EF60A}"/>
+                <a16:creationId xmlns:a16="http://schemas.microsoft.com/office/drawing/2014/main" id="{C5975839-D571-407D-AFCD-D4A29579C299}"/>
               </a:ext>
             </a:extLst>
           </p:cNvPr>
@@ -11194,7 +11282,7 @@
           <p:cNvPr id="6" name="">
             <a:extLst xmlns:a="http://schemas.openxmlformats.org/drawingml/2006/main">
               <a:ext uri="{FF2B5EF4-FFF2-40B4-BE49-F238E27FC236}">
-                <a16:creationId xmlns:a16="http://schemas.microsoft.com/office/drawing/2014/main" id="{65F011AF-AA27-4011-B9C3-B73D12D36726}"/>
+                <a16:creationId xmlns:a16="http://schemas.microsoft.com/office/drawing/2014/main" id="{52E8846C-632F-411A-AB44-5FAA6786AB48}"/>
               </a:ext>
             </a:extLst>
           </p:cNvPr>
@@ -11250,7 +11338,7 @@
           <p:cNvPr id="7" name="">
             <a:extLst xmlns:a="http://schemas.openxmlformats.org/drawingml/2006/main">
               <a:ext uri="{FF2B5EF4-FFF2-40B4-BE49-F238E27FC236}">
-                <a16:creationId xmlns:a16="http://schemas.microsoft.com/office/drawing/2014/main" id="{BAF86780-59BD-4C25-9BAF-291B254C46F4}"/>
+                <a16:creationId xmlns:a16="http://schemas.microsoft.com/office/drawing/2014/main" id="{310187EB-91DA-432F-8781-2AE424D3AA74}"/>
               </a:ext>
             </a:extLst>
           </p:cNvPr>
@@ -11306,7 +11394,7 @@
           <p:cNvPr id="8" name="">
             <a:extLst xmlns:a="http://schemas.openxmlformats.org/drawingml/2006/main">
               <a:ext uri="{FF2B5EF4-FFF2-40B4-BE49-F238E27FC236}">
-                <a16:creationId xmlns:a16="http://schemas.microsoft.com/office/drawing/2014/main" id="{4DFA6773-24AA-4F0F-AA0E-F37CFA3BD0B8}"/>
+                <a16:creationId xmlns:a16="http://schemas.microsoft.com/office/drawing/2014/main" id="{2AA3A6A1-AB43-45F5-A50E-85880B9F1334}"/>
               </a:ext>
             </a:extLst>
           </p:cNvPr>
@@ -11362,7 +11450,7 @@
           <p:cNvPr id="9" name="">
             <a:extLst xmlns:a="http://schemas.openxmlformats.org/drawingml/2006/main">
               <a:ext uri="{FF2B5EF4-FFF2-40B4-BE49-F238E27FC236}">
-                <a16:creationId xmlns:a16="http://schemas.microsoft.com/office/drawing/2014/main" id="{576599E9-AAB5-4A6B-AB05-EEBDADA61ED2}"/>
+                <a16:creationId xmlns:a16="http://schemas.microsoft.com/office/drawing/2014/main" id="{8F1B3AD7-05DA-4DE9-BC79-4E632B8C2AD1}"/>
               </a:ext>
             </a:extLst>
           </p:cNvPr>
@@ -11418,7 +11506,7 @@
           <p:cNvPr id="10" name="">
             <a:extLst xmlns:a="http://schemas.openxmlformats.org/drawingml/2006/main">
               <a:ext uri="{FF2B5EF4-FFF2-40B4-BE49-F238E27FC236}">
-                <a16:creationId xmlns:a16="http://schemas.microsoft.com/office/drawing/2014/main" id="{7DDCC231-0D98-48A0-A36F-C33EFBE4C620}"/>
+                <a16:creationId xmlns:a16="http://schemas.microsoft.com/office/drawing/2014/main" id="{5392CBEB-71A0-471B-80BD-852356387772}"/>
               </a:ext>
             </a:extLst>
           </p:cNvPr>
@@ -11474,7 +11562,7 @@
           <p:cNvPr id="11" name="">
             <a:extLst xmlns:a="http://schemas.openxmlformats.org/drawingml/2006/main">
               <a:ext uri="{FF2B5EF4-FFF2-40B4-BE49-F238E27FC236}">
-                <a16:creationId xmlns:a16="http://schemas.microsoft.com/office/drawing/2014/main" id="{CD01306A-B1A8-476C-A8C5-9094C6D3B43C}"/>
+                <a16:creationId xmlns:a16="http://schemas.microsoft.com/office/drawing/2014/main" id="{77A6885A-99EF-4267-A15C-C41915A26CBB}"/>
               </a:ext>
             </a:extLst>
           </p:cNvPr>
@@ -11530,7 +11618,7 @@
           <p:cNvPr id="12" name="">
             <a:extLst xmlns:a="http://schemas.openxmlformats.org/drawingml/2006/main">
               <a:ext uri="{FF2B5EF4-FFF2-40B4-BE49-F238E27FC236}">
-                <a16:creationId xmlns:a16="http://schemas.microsoft.com/office/drawing/2014/main" id="{8B7213DC-7A48-49B7-A46B-F07146F0A4EC}"/>
+                <a16:creationId xmlns:a16="http://schemas.microsoft.com/office/drawing/2014/main" id="{DFA211A6-266E-41AE-85D5-3F9A876384E4}"/>
               </a:ext>
             </a:extLst>
           </p:cNvPr>
@@ -11586,7 +11674,7 @@
           <p:cNvPr id="13" name="">
             <a:extLst xmlns:a="http://schemas.openxmlformats.org/drawingml/2006/main">
               <a:ext uri="{FF2B5EF4-FFF2-40B4-BE49-F238E27FC236}">
-                <a16:creationId xmlns:a16="http://schemas.microsoft.com/office/drawing/2014/main" id="{96C23BA0-F773-471C-BDF7-55B5EF84333F}"/>
+                <a16:creationId xmlns:a16="http://schemas.microsoft.com/office/drawing/2014/main" id="{B5991326-793E-4587-A8BB-AA6A05345651}"/>
               </a:ext>
             </a:extLst>
           </p:cNvPr>
@@ -11642,7 +11730,7 @@
           <p:cNvPr id="14" name="">
             <a:extLst xmlns:a="http://schemas.openxmlformats.org/drawingml/2006/main">
               <a:ext uri="{FF2B5EF4-FFF2-40B4-BE49-F238E27FC236}">
-                <a16:creationId xmlns:a16="http://schemas.microsoft.com/office/drawing/2014/main" id="{035365D5-FF2A-447B-9A44-209BF9B3BE60}"/>
+                <a16:creationId xmlns:a16="http://schemas.microsoft.com/office/drawing/2014/main" id="{13123844-7907-4DAA-A703-94BC1C80121B}"/>
               </a:ext>
             </a:extLst>
           </p:cNvPr>
@@ -11698,7 +11786,7 @@
           <p:cNvPr id="15" name="">
             <a:extLst xmlns:a="http://schemas.openxmlformats.org/drawingml/2006/main">
               <a:ext uri="{FF2B5EF4-FFF2-40B4-BE49-F238E27FC236}">
-                <a16:creationId xmlns:a16="http://schemas.microsoft.com/office/drawing/2014/main" id="{471168EE-8807-4209-B3CD-7B9E76BD6047}"/>
+                <a16:creationId xmlns:a16="http://schemas.microsoft.com/office/drawing/2014/main" id="{66B0969F-0156-49F4-B5C0-480392971FE9}"/>
               </a:ext>
             </a:extLst>
           </p:cNvPr>
@@ -11754,7 +11842,7 @@
           <p:cNvPr id="16" name="">
             <a:extLst xmlns:a="http://schemas.openxmlformats.org/drawingml/2006/main">
               <a:ext uri="{FF2B5EF4-FFF2-40B4-BE49-F238E27FC236}">
-                <a16:creationId xmlns:a16="http://schemas.microsoft.com/office/drawing/2014/main" id="{B7DD2847-ACA9-4741-83D5-352E8A68D154}"/>
+                <a16:creationId xmlns:a16="http://schemas.microsoft.com/office/drawing/2014/main" id="{35E07CDF-A4BB-4B47-91C9-2C66EA8F9465}"/>
               </a:ext>
             </a:extLst>
           </p:cNvPr>
@@ -11810,7 +11898,7 @@
           <p:cNvPr id="17" name="">
             <a:extLst xmlns:a="http://schemas.openxmlformats.org/drawingml/2006/main">
               <a:ext uri="{FF2B5EF4-FFF2-40B4-BE49-F238E27FC236}">
-                <a16:creationId xmlns:a16="http://schemas.microsoft.com/office/drawing/2014/main" id="{2E0435DA-4E40-4153-B31D-A6BDBDC7E8F2}"/>
+                <a16:creationId xmlns:a16="http://schemas.microsoft.com/office/drawing/2014/main" id="{C6AD98B9-8914-4E40-A347-A2FB280A71FB}"/>
               </a:ext>
             </a:extLst>
           </p:cNvPr>
@@ -11866,7 +11954,7 @@
           <p:cNvPr id="18" name="">
             <a:extLst xmlns:a="http://schemas.openxmlformats.org/drawingml/2006/main">
               <a:ext uri="{FF2B5EF4-FFF2-40B4-BE49-F238E27FC236}">
-                <a16:creationId xmlns:a16="http://schemas.microsoft.com/office/drawing/2014/main" id="{2A26676E-7922-48D3-9D65-17818D3D3773}"/>
+                <a16:creationId xmlns:a16="http://schemas.microsoft.com/office/drawing/2014/main" id="{8C009E9E-194C-4538-B488-78418C898C7F}"/>
               </a:ext>
             </a:extLst>
           </p:cNvPr>
@@ -11922,7 +12010,7 @@
           <p:cNvPr id="19" name="">
             <a:extLst xmlns:a="http://schemas.openxmlformats.org/drawingml/2006/main">
               <a:ext uri="{FF2B5EF4-FFF2-40B4-BE49-F238E27FC236}">
-                <a16:creationId xmlns:a16="http://schemas.microsoft.com/office/drawing/2014/main" id="{DACA32EC-83F3-40CE-962B-9C7CD91099F3}"/>
+                <a16:creationId xmlns:a16="http://schemas.microsoft.com/office/drawing/2014/main" id="{3812896F-8672-4FF8-B505-80134B332828}"/>
               </a:ext>
             </a:extLst>
           </p:cNvPr>
@@ -11978,7 +12066,7 @@
           <p:cNvPr id="20" name="">
             <a:extLst xmlns:a="http://schemas.openxmlformats.org/drawingml/2006/main">
               <a:ext uri="{FF2B5EF4-FFF2-40B4-BE49-F238E27FC236}">
-                <a16:creationId xmlns:a16="http://schemas.microsoft.com/office/drawing/2014/main" id="{9C2C0E31-6438-4297-ADCE-068316DF658D}"/>
+                <a16:creationId xmlns:a16="http://schemas.microsoft.com/office/drawing/2014/main" id="{98676116-08C6-4872-8F0A-D9284F0CBB07}"/>
               </a:ext>
             </a:extLst>
           </p:cNvPr>
@@ -12034,7 +12122,7 @@
           <p:cNvPr id="21" name="">
             <a:extLst xmlns:a="http://schemas.openxmlformats.org/drawingml/2006/main">
               <a:ext uri="{FF2B5EF4-FFF2-40B4-BE49-F238E27FC236}">
-                <a16:creationId xmlns:a16="http://schemas.microsoft.com/office/drawing/2014/main" id="{258F13C9-E636-4985-946D-3AD91C359CB8}"/>
+                <a16:creationId xmlns:a16="http://schemas.microsoft.com/office/drawing/2014/main" id="{0907EC87-F523-4BFF-A5F7-8B5AC5F69A32}"/>
               </a:ext>
             </a:extLst>
           </p:cNvPr>
@@ -12090,7 +12178,7 @@
           <p:cNvPr id="22" name="">
             <a:extLst xmlns:a="http://schemas.openxmlformats.org/drawingml/2006/main">
               <a:ext uri="{FF2B5EF4-FFF2-40B4-BE49-F238E27FC236}">
-                <a16:creationId xmlns:a16="http://schemas.microsoft.com/office/drawing/2014/main" id="{F20A46BC-3C4F-4827-AB78-9EAC36BAF5F0}"/>
+                <a16:creationId xmlns:a16="http://schemas.microsoft.com/office/drawing/2014/main" id="{F09C1E5E-2A39-45F9-B044-F9DFF399C657}"/>
               </a:ext>
             </a:extLst>
           </p:cNvPr>
@@ -12146,7 +12234,7 @@
           <p:cNvPr id="23" name="">
             <a:extLst xmlns:a="http://schemas.openxmlformats.org/drawingml/2006/main">
               <a:ext uri="{FF2B5EF4-FFF2-40B4-BE49-F238E27FC236}">
-                <a16:creationId xmlns:a16="http://schemas.microsoft.com/office/drawing/2014/main" id="{EED827C1-AAFB-4012-9722-1FB4F7D0B3D1}"/>
+                <a16:creationId xmlns:a16="http://schemas.microsoft.com/office/drawing/2014/main" id="{2288D955-2D17-4C17-B678-2B878FE3F534}"/>
               </a:ext>
             </a:extLst>
           </p:cNvPr>
@@ -12202,7 +12290,7 @@
           <p:cNvPr id="24" name="">
             <a:extLst xmlns:a="http://schemas.openxmlformats.org/drawingml/2006/main">
               <a:ext uri="{FF2B5EF4-FFF2-40B4-BE49-F238E27FC236}">
-                <a16:creationId xmlns:a16="http://schemas.microsoft.com/office/drawing/2014/main" id="{2D365EEC-3A66-4C8F-8AD7-C5F0F77194F4}"/>
+                <a16:creationId xmlns:a16="http://schemas.microsoft.com/office/drawing/2014/main" id="{73C652DB-783E-491B-BE10-9A71DD6DBE07}"/>
               </a:ext>
             </a:extLst>
           </p:cNvPr>
@@ -12258,7 +12346,7 @@
           <p:cNvPr id="25" name="">
             <a:extLst xmlns:a="http://schemas.openxmlformats.org/drawingml/2006/main">
               <a:ext uri="{FF2B5EF4-FFF2-40B4-BE49-F238E27FC236}">
-                <a16:creationId xmlns:a16="http://schemas.microsoft.com/office/drawing/2014/main" id="{586FE867-6A14-4AE6-903E-90C238D86EF7}"/>
+                <a16:creationId xmlns:a16="http://schemas.microsoft.com/office/drawing/2014/main" id="{5641C61D-7ECB-406A-BC70-E0A9E63393EC}"/>
               </a:ext>
             </a:extLst>
           </p:cNvPr>
@@ -12289,7 +12377,7 @@
           <p:cNvPr id="26" name="">
             <a:extLst xmlns:a="http://schemas.openxmlformats.org/drawingml/2006/main">
               <a:ext uri="{FF2B5EF4-FFF2-40B4-BE49-F238E27FC236}">
-                <a16:creationId xmlns:a16="http://schemas.microsoft.com/office/drawing/2014/main" id="{AE6B8145-CBF5-496C-BECC-46584B838D0D}"/>
+                <a16:creationId xmlns:a16="http://schemas.microsoft.com/office/drawing/2014/main" id="{E1CBE960-F87D-48A3-9C63-E4991FF90246}"/>
               </a:ext>
             </a:extLst>
           </p:cNvPr>
@@ -12301,7 +12389,7 @@
         <p:spPr>
           <a:xfrm xmlns:a="http://schemas.openxmlformats.org/drawingml/2006/main">
             <a:off x="609600" y="6419850"/>
-            <a:ext cx="7810500" cy="209550"/>
+            <a:ext cx="4000500" cy="209550"/>
           </a:xfrm>
           <a:prstGeom xmlns:a="http://schemas.openxmlformats.org/drawingml/2006/main" prst="rect">
             <a:avLst/>
@@ -12329,7 +12417,7 @@
                   <a:srgbClr val="52615B"/>
                 </a:solidFill>
               </a:rPr>
-              <a:t>非公式資料 | Source: products/shopify-collective/architecture.md</a:t>
+              <a:t>Shopify Collective</a:t>
             </a:r>
           </a:p>
         </p:txBody>
@@ -12339,7 +12427,7 @@
           <p:cNvPr id="27" name="">
             <a:extLst xmlns:a="http://schemas.openxmlformats.org/drawingml/2006/main">
               <a:ext uri="{FF2B5EF4-FFF2-40B4-BE49-F238E27FC236}">
-                <a16:creationId xmlns:a16="http://schemas.microsoft.com/office/drawing/2014/main" id="{032DD55E-220D-4172-881F-35052CC3CDF2}"/>
+                <a16:creationId xmlns:a16="http://schemas.microsoft.com/office/drawing/2014/main" id="{BC5ACA6F-4A20-4C72-B66E-69B3317D0E83}"/>
               </a:ext>
             </a:extLst>
           </p:cNvPr>
@@ -12387,7 +12475,7 @@
     </p:spTree>
     <p:extLst>
       <p:ext uri="{BB962C8B-B14F-4D97-AF65-F5344CB8AC3E}">
-        <p14:creationId xmlns:p14="http://schemas.microsoft.com/office/powerpoint/2010/main" val="1618753617"/>
+        <p14:creationId xmlns:p14="http://schemas.microsoft.com/office/powerpoint/2010/main" val="329313596"/>
       </p:ext>
     </p:extLst>
   </p:cSld>

</xml_diff>

<commit_message>
Clarify Collective FAQ pricing impacts
</commit_message>
<xml_diff>
--- a/products/shopify-collective/ja/shopify-collective-architecture-ja.pptx
+++ b/products/shopify-collective/ja/shopify-collective-architecture-ja.pptx
@@ -2,24 +2,24 @@
 <file path=ppt/presentation.xml><?xml version="1.0" encoding="utf-8"?>
 <p:presentation xmlns:p="http://schemas.openxmlformats.org/presentationml/2006/main">
   <p:sldMasterIdLst>
-    <p:sldMasterId xmlns:r="http://schemas.openxmlformats.org/officeDocument/2006/relationships" id="2147483648" r:id="R73d086a09ab04d46"/>
+    <p:sldMasterId xmlns:r="http://schemas.openxmlformats.org/officeDocument/2006/relationships" id="2147483648" r:id="R9a11dca9401d446b"/>
   </p:sldMasterIdLst>
   <p:notesMasterIdLst>
-    <p:notesMasterId xmlns:r="http://schemas.openxmlformats.org/officeDocument/2006/relationships" r:id="R93ce4e7273de4d47"/>
+    <p:notesMasterId xmlns:r="http://schemas.openxmlformats.org/officeDocument/2006/relationships" r:id="Rdb5c5b333fa74ade"/>
   </p:notesMasterIdLst>
   <p:sldIdLst>
-    <p:sldId xmlns:r="http://schemas.openxmlformats.org/officeDocument/2006/relationships" id="256" r:id="Ra5a39a4742794849"/>
-    <p:sldId xmlns:r="http://schemas.openxmlformats.org/officeDocument/2006/relationships" id="257" r:id="R7f96d65e13e34f73"/>
-    <p:sldId xmlns:r="http://schemas.openxmlformats.org/officeDocument/2006/relationships" id="258" r:id="R66d54c435312446a"/>
-    <p:sldId xmlns:r="http://schemas.openxmlformats.org/officeDocument/2006/relationships" id="259" r:id="Ra2aef9ec914a4cf7"/>
-    <p:sldId xmlns:r="http://schemas.openxmlformats.org/officeDocument/2006/relationships" id="260" r:id="Re186dc9ff8f845d9"/>
-    <p:sldId xmlns:r="http://schemas.openxmlformats.org/officeDocument/2006/relationships" id="261" r:id="R0a14561e7ce645a1"/>
-    <p:sldId xmlns:r="http://schemas.openxmlformats.org/officeDocument/2006/relationships" id="262" r:id="R19ecf0cb06f442a0"/>
-    <p:sldId xmlns:r="http://schemas.openxmlformats.org/officeDocument/2006/relationships" id="263" r:id="Rbb8f6a84729f4a35"/>
-    <p:sldId xmlns:r="http://schemas.openxmlformats.org/officeDocument/2006/relationships" id="264" r:id="R1b3ce2954d544d13"/>
-    <p:sldId xmlns:r="http://schemas.openxmlformats.org/officeDocument/2006/relationships" id="265" r:id="R11290b4a9ba14486"/>
-    <p:sldId xmlns:r="http://schemas.openxmlformats.org/officeDocument/2006/relationships" id="266" r:id="Ra6670f9ed0d947ac"/>
-    <p:sldId xmlns:r="http://schemas.openxmlformats.org/officeDocument/2006/relationships" id="267" r:id="Rd53c910913524aa4"/>
+    <p:sldId xmlns:r="http://schemas.openxmlformats.org/officeDocument/2006/relationships" id="256" r:id="R742ffcec8d634141"/>
+    <p:sldId xmlns:r="http://schemas.openxmlformats.org/officeDocument/2006/relationships" id="257" r:id="R6aa0c02744bf4c0b"/>
+    <p:sldId xmlns:r="http://schemas.openxmlformats.org/officeDocument/2006/relationships" id="258" r:id="Rd8ba5242070b4ac8"/>
+    <p:sldId xmlns:r="http://schemas.openxmlformats.org/officeDocument/2006/relationships" id="259" r:id="Rcb6f4fa5780f4e00"/>
+    <p:sldId xmlns:r="http://schemas.openxmlformats.org/officeDocument/2006/relationships" id="260" r:id="Rf15d51d84d7b49af"/>
+    <p:sldId xmlns:r="http://schemas.openxmlformats.org/officeDocument/2006/relationships" id="261" r:id="R6487ab354e4e42d2"/>
+    <p:sldId xmlns:r="http://schemas.openxmlformats.org/officeDocument/2006/relationships" id="262" r:id="R63c677cd32dd4eb7"/>
+    <p:sldId xmlns:r="http://schemas.openxmlformats.org/officeDocument/2006/relationships" id="263" r:id="R78f47c28116a4b4e"/>
+    <p:sldId xmlns:r="http://schemas.openxmlformats.org/officeDocument/2006/relationships" id="264" r:id="R4682896d21e64504"/>
+    <p:sldId xmlns:r="http://schemas.openxmlformats.org/officeDocument/2006/relationships" id="265" r:id="R8dc2093c40594b59"/>
+    <p:sldId xmlns:r="http://schemas.openxmlformats.org/officeDocument/2006/relationships" id="266" r:id="Rce6f0b4d13414ddd"/>
+    <p:sldId xmlns:r="http://schemas.openxmlformats.org/officeDocument/2006/relationships" id="267" r:id="Rd591167dc94e4778"/>
   </p:sldIdLst>
   <p:sldSz cx="12192000" cy="6858000"/>
   <p:notesSz cx="6858000" cy="9144000"/>
@@ -1338,7 +1338,7 @@
   </p:cSld>
   <p:clrMap bg1="lt1" tx1="dk1" bg2="lt2" tx2="dk2" accent1="accent1" accent2="accent2" accent3="accent3" accent4="accent4" accent5="accent5" accent6="accent6" hlink="hlink" folHlink="folHlink"/>
   <p:sldLayoutIdLst>
-    <p:sldLayoutId xmlns:r="http://schemas.openxmlformats.org/officeDocument/2006/relationships" id="2147483649" r:id="R3479a5c2836542a9"/>
+    <p:sldLayoutId xmlns:r="http://schemas.openxmlformats.org/officeDocument/2006/relationships" id="2147483649" r:id="Rce6013e132db439b"/>
   </p:sldLayoutIdLst>
   <p:txStyles>
     <p:titleStyle>
@@ -1889,7 +1889,7 @@
           <p:cNvPr id="1" name="">
             <a:extLst xmlns:a="http://schemas.openxmlformats.org/drawingml/2006/main">
               <a:ext uri="{FF2B5EF4-FFF2-40B4-BE49-F238E27FC236}">
-                <a16:creationId xmlns:a16="http://schemas.microsoft.com/office/drawing/2014/main" id="{4A742F2A-78E3-4526-873D-B897CB1E4636}"/>
+                <a16:creationId xmlns:a16="http://schemas.microsoft.com/office/drawing/2014/main" id="{E0BAE137-6795-4A55-9753-8A622D189081}"/>
               </a:ext>
             </a:extLst>
           </p:cNvPr>
@@ -1939,7 +1939,7 @@
           <p:cNvPr id="2" name="">
             <a:extLst xmlns:a="http://schemas.openxmlformats.org/drawingml/2006/main">
               <a:ext uri="{FF2B5EF4-FFF2-40B4-BE49-F238E27FC236}">
-                <a16:creationId xmlns:a16="http://schemas.microsoft.com/office/drawing/2014/main" id="{C774FDA6-4250-4C19-A256-44D8BA8BAFB3}"/>
+                <a16:creationId xmlns:a16="http://schemas.microsoft.com/office/drawing/2014/main" id="{A1DB5AAA-DEE7-4540-A30C-699D4B0FB4DB}"/>
               </a:ext>
             </a:extLst>
           </p:cNvPr>
@@ -2006,7 +2006,7 @@
           <p:cNvPr id="3" name="">
             <a:extLst xmlns:a="http://schemas.openxmlformats.org/drawingml/2006/main">
               <a:ext uri="{FF2B5EF4-FFF2-40B4-BE49-F238E27FC236}">
-                <a16:creationId xmlns:a16="http://schemas.microsoft.com/office/drawing/2014/main" id="{897A7AC0-A185-4FB3-84C9-D74E178236D9}"/>
+                <a16:creationId xmlns:a16="http://schemas.microsoft.com/office/drawing/2014/main" id="{8BA2045F-EC16-4596-BEC1-CDC8CF3C63BB}"/>
               </a:ext>
             </a:extLst>
           </p:cNvPr>
@@ -2046,7 +2046,7 @@
                   <a:srgbClr val="FFFFFF"/>
                 </a:solidFill>
               </a:rPr>
-              <a:t>商品同期、注文、支払い、返品までのRetailer/Supplierフロー</a:t>
+              <a:t>商品同期、注文、支払い、返品までの小売業者・サプライヤーフロー</a:t>
             </a:r>
           </a:p>
         </p:txBody>
@@ -2056,7 +2056,7 @@
           <p:cNvPr id="4" name="">
             <a:extLst xmlns:a="http://schemas.openxmlformats.org/drawingml/2006/main">
               <a:ext uri="{FF2B5EF4-FFF2-40B4-BE49-F238E27FC236}">
-                <a16:creationId xmlns:a16="http://schemas.microsoft.com/office/drawing/2014/main" id="{C0808776-78C4-420F-A496-A7788C114750}"/>
+                <a16:creationId xmlns:a16="http://schemas.microsoft.com/office/drawing/2014/main" id="{D13A72FC-1D21-42DF-9F35-3F5C0BE498C6}"/>
               </a:ext>
             </a:extLst>
           </p:cNvPr>
@@ -2104,7 +2104,7 @@
     </p:spTree>
     <p:extLst>
       <p:ext uri="{BB962C8B-B14F-4D97-AF65-F5344CB8AC3E}">
-        <p14:creationId xmlns:p14="http://schemas.microsoft.com/office/powerpoint/2010/main" val="310741541"/>
+        <p14:creationId xmlns:p14="http://schemas.microsoft.com/office/powerpoint/2010/main" val="976303914"/>
       </p:ext>
     </p:extLst>
   </p:cSld>
@@ -2135,7 +2135,7 @@
           <p:cNvPr id="1" name="">
             <a:extLst xmlns:a="http://schemas.openxmlformats.org/drawingml/2006/main">
               <a:ext uri="{FF2B5EF4-FFF2-40B4-BE49-F238E27FC236}">
-                <a16:creationId xmlns:a16="http://schemas.microsoft.com/office/drawing/2014/main" id="{C8D6423B-73C3-45B4-B00B-288034C0FB8D}"/>
+                <a16:creationId xmlns:a16="http://schemas.microsoft.com/office/drawing/2014/main" id="{179918F5-C91D-4329-A586-1D032E429BBC}"/>
               </a:ext>
             </a:extLst>
           </p:cNvPr>
@@ -2185,7 +2185,7 @@
           <p:cNvPr id="2" name="">
             <a:extLst xmlns:a="http://schemas.openxmlformats.org/drawingml/2006/main">
               <a:ext uri="{FF2B5EF4-FFF2-40B4-BE49-F238E27FC236}">
-                <a16:creationId xmlns:a16="http://schemas.microsoft.com/office/drawing/2014/main" id="{CF315CF5-D872-46F8-86C9-37173A0BC7DE}"/>
+                <a16:creationId xmlns:a16="http://schemas.microsoft.com/office/drawing/2014/main" id="{485AD5E1-E856-4DD9-8D51-D7196844C4BB}"/>
               </a:ext>
             </a:extLst>
           </p:cNvPr>
@@ -2235,7 +2235,7 @@
           <p:cNvPr id="3" name="">
             <a:extLst xmlns:a="http://schemas.openxmlformats.org/drawingml/2006/main">
               <a:ext uri="{FF2B5EF4-FFF2-40B4-BE49-F238E27FC236}">
-                <a16:creationId xmlns:a16="http://schemas.microsoft.com/office/drawing/2014/main" id="{31FC53A7-E69D-41E8-ABA8-E57DC170C4BA}"/>
+                <a16:creationId xmlns:a16="http://schemas.microsoft.com/office/drawing/2014/main" id="{31B1EE1A-B714-4EEC-910B-C4607234E726}"/>
               </a:ext>
             </a:extLst>
           </p:cNvPr>
@@ -2285,7 +2285,7 @@
           <p:cNvPr id="4" name="">
             <a:extLst xmlns:a="http://schemas.openxmlformats.org/drawingml/2006/main">
               <a:ext uri="{FF2B5EF4-FFF2-40B4-BE49-F238E27FC236}">
-                <a16:creationId xmlns:a16="http://schemas.microsoft.com/office/drawing/2014/main" id="{7406EE18-36C4-4DCD-B868-DEDFC388DD3A}"/>
+                <a16:creationId xmlns:a16="http://schemas.microsoft.com/office/drawing/2014/main" id="{9E4ACC48-B6CC-4E43-B881-407751A74436}"/>
               </a:ext>
             </a:extLst>
           </p:cNvPr>
@@ -2316,7 +2316,7 @@
           <p:cNvPr id="5" name="">
             <a:extLst xmlns:a="http://schemas.openxmlformats.org/drawingml/2006/main">
               <a:ext uri="{FF2B5EF4-FFF2-40B4-BE49-F238E27FC236}">
-                <a16:creationId xmlns:a16="http://schemas.microsoft.com/office/drawing/2014/main" id="{5782B355-2896-4808-ADDC-3030B8192BC6}"/>
+                <a16:creationId xmlns:a16="http://schemas.microsoft.com/office/drawing/2014/main" id="{8363AA1D-7797-4A86-B674-35D3012AB22B}"/>
               </a:ext>
             </a:extLst>
           </p:cNvPr>
@@ -2356,7 +2356,7 @@
                   <a:srgbClr val="004C3F"/>
                 </a:solidFill>
               </a:rPr>
-              <a:t>Supplier注文はいつ作成?</a:t>
+              <a:t>サプライヤー注文はいつ作成?</a:t>
             </a:r>
           </a:p>
         </p:txBody>
@@ -2366,7 +2366,7 @@
           <p:cNvPr id="6" name="">
             <a:extLst xmlns:a="http://schemas.openxmlformats.org/drawingml/2006/main">
               <a:ext uri="{FF2B5EF4-FFF2-40B4-BE49-F238E27FC236}">
-                <a16:creationId xmlns:a16="http://schemas.microsoft.com/office/drawing/2014/main" id="{90E8D006-B844-4412-937D-DB10641244C6}"/>
+                <a16:creationId xmlns:a16="http://schemas.microsoft.com/office/drawing/2014/main" id="{BE53E702-397C-4795-A6E0-CCF4CC905860}"/>
               </a:ext>
             </a:extLst>
           </p:cNvPr>
@@ -2406,7 +2406,7 @@
                   <a:srgbClr val="52615B"/>
                 </a:solidFill>
               </a:rPr>
-              <a:t>Retailer注文の支払い後、不正チェックを通過し、保留でなければ作成されます。ERP/OMS/WMS同期は注文作成・更新Webhookを使います。</a:t>
+              <a:t>小売業者注文の支払い後、不正チェックを通過し、保留でなければ作成されます。ERP/OMS/WMS同期は注文作成・更新Webhookを使います。</a:t>
             </a:r>
           </a:p>
         </p:txBody>
@@ -2416,7 +2416,7 @@
           <p:cNvPr id="7" name="">
             <a:extLst xmlns:a="http://schemas.openxmlformats.org/drawingml/2006/main">
               <a:ext uri="{FF2B5EF4-FFF2-40B4-BE49-F238E27FC236}">
-                <a16:creationId xmlns:a16="http://schemas.microsoft.com/office/drawing/2014/main" id="{71E06DC9-4323-4D54-B12A-F1C6C7B6220B}"/>
+                <a16:creationId xmlns:a16="http://schemas.microsoft.com/office/drawing/2014/main" id="{6C2CD884-67FD-4D53-AD7A-FA374161DE94}"/>
               </a:ext>
             </a:extLst>
           </p:cNvPr>
@@ -2456,7 +2456,7 @@
                   <a:srgbClr val="004C3F"/>
                 </a:solidFill>
               </a:rPr>
-              <a:t>Supplier金額の決まり方は?</a:t>
+              <a:t>サプライヤー金額の決まり方は?</a:t>
             </a:r>
           </a:p>
         </p:txBody>
@@ -2466,7 +2466,7 @@
           <p:cNvPr id="8" name="">
             <a:extLst xmlns:a="http://schemas.openxmlformats.org/drawingml/2006/main">
               <a:ext uri="{FF2B5EF4-FFF2-40B4-BE49-F238E27FC236}">
-                <a16:creationId xmlns:a16="http://schemas.microsoft.com/office/drawing/2014/main" id="{F01CA8AE-AAC9-4B43-BD6D-FAD4D99C3AB3}"/>
+                <a16:creationId xmlns:a16="http://schemas.microsoft.com/office/drawing/2014/main" id="{F1CE0FC3-4982-44B5-AA82-E41F6C5FB906}"/>
               </a:ext>
             </a:extLst>
           </p:cNvPr>
@@ -2506,7 +2506,7 @@
                   <a:srgbClr val="52615B"/>
                 </a:solidFill>
               </a:rPr>
-              <a:t>Cost price、supplier shipping、税、調整で決まり、顧客checkout総額そのものではありません。会計連携では注文Webhookとpayment adjustmentを併用します。</a:t>
+              <a:t>金額は商品原価、サプライヤー送料、税、調整で決まり、顧客checkout総額ではありません。会計連携は注文Webhookとpayment adjustmentを併用します。</a:t>
             </a:r>
           </a:p>
         </p:txBody>
@@ -2516,7 +2516,7 @@
           <p:cNvPr id="9" name="">
             <a:extLst xmlns:a="http://schemas.openxmlformats.org/drawingml/2006/main">
               <a:ext uri="{FF2B5EF4-FFF2-40B4-BE49-F238E27FC236}">
-                <a16:creationId xmlns:a16="http://schemas.microsoft.com/office/drawing/2014/main" id="{85C7D499-D0C6-4F47-8712-8887F53B4BD6}"/>
+                <a16:creationId xmlns:a16="http://schemas.microsoft.com/office/drawing/2014/main" id="{605E7568-2889-4B3F-8446-73310480EC86}"/>
               </a:ext>
             </a:extLst>
           </p:cNvPr>
@@ -2566,7 +2566,7 @@
           <p:cNvPr id="10" name="">
             <a:extLst xmlns:a="http://schemas.openxmlformats.org/drawingml/2006/main">
               <a:ext uri="{FF2B5EF4-FFF2-40B4-BE49-F238E27FC236}">
-                <a16:creationId xmlns:a16="http://schemas.microsoft.com/office/drawing/2014/main" id="{8EA71738-372B-46A7-ACEC-F7C67F302254}"/>
+                <a16:creationId xmlns:a16="http://schemas.microsoft.com/office/drawing/2014/main" id="{CA753E90-B523-4A3C-8FE2-A590CEA46F69}"/>
               </a:ext>
             </a:extLst>
           </p:cNvPr>
@@ -2616,7 +2616,7 @@
           <p:cNvPr id="11" name="">
             <a:extLst xmlns:a="http://schemas.openxmlformats.org/drawingml/2006/main">
               <a:ext uri="{FF2B5EF4-FFF2-40B4-BE49-F238E27FC236}">
-                <a16:creationId xmlns:a16="http://schemas.microsoft.com/office/drawing/2014/main" id="{DD91387A-4378-4DF2-B99F-A31213F89E2E}"/>
+                <a16:creationId xmlns:a16="http://schemas.microsoft.com/office/drawing/2014/main" id="{9DAA82F7-3ACF-4197-A144-7A1F8F32C864}"/>
               </a:ext>
             </a:extLst>
           </p:cNvPr>
@@ -2656,7 +2656,7 @@
                   <a:srgbClr val="004C3F"/>
                 </a:solidFill>
               </a:rPr>
-              <a:t>Retailer discount時は?</a:t>
+              <a:t>小売業者discount/安値販売時は?</a:t>
             </a:r>
           </a:p>
         </p:txBody>
@@ -2666,7 +2666,7 @@
           <p:cNvPr id="12" name="">
             <a:extLst xmlns:a="http://schemas.openxmlformats.org/drawingml/2006/main">
               <a:ext uri="{FF2B5EF4-FFF2-40B4-BE49-F238E27FC236}">
-                <a16:creationId xmlns:a16="http://schemas.microsoft.com/office/drawing/2014/main" id="{AF9469AB-FBE8-4891-A742-D127829C63B3}"/>
+                <a16:creationId xmlns:a16="http://schemas.microsoft.com/office/drawing/2014/main" id="{6D1BE968-5B4B-4DF9-8D4E-3DBF140B9F42}"/>
               </a:ext>
             </a:extLst>
           </p:cNvPr>
@@ -2706,7 +2706,7 @@
                   <a:srgbClr val="52615B"/>
                 </a:solidFill>
               </a:rPr>
-              <a:t>顧客支払額が下がりRetailer利益が減ります。Supplier cost priceは変わりません。</a:t>
+              <a:t>顧客支払額が下がり、小売業者利益は低下またはマイナスになります。サプライヤーcost priceと注文金額は変わりません。</a:t>
             </a:r>
           </a:p>
         </p:txBody>
@@ -2716,7 +2716,7 @@
           <p:cNvPr id="13" name="">
             <a:extLst xmlns:a="http://schemas.openxmlformats.org/drawingml/2006/main">
               <a:ext uri="{FF2B5EF4-FFF2-40B4-BE49-F238E27FC236}">
-                <a16:creationId xmlns:a16="http://schemas.microsoft.com/office/drawing/2014/main" id="{9A4FA5AF-9087-4CBB-8CD3-B0AF59155B89}"/>
+                <a16:creationId xmlns:a16="http://schemas.microsoft.com/office/drawing/2014/main" id="{4D486C91-04D8-42CF-B81B-D760A4D42143}"/>
               </a:ext>
             </a:extLst>
           </p:cNvPr>
@@ -2747,7 +2747,7 @@
           <p:cNvPr id="14" name="">
             <a:extLst xmlns:a="http://schemas.openxmlformats.org/drawingml/2006/main">
               <a:ext uri="{FF2B5EF4-FFF2-40B4-BE49-F238E27FC236}">
-                <a16:creationId xmlns:a16="http://schemas.microsoft.com/office/drawing/2014/main" id="{C42F95AF-F11C-41C4-8D74-25FD9E6FF87D}"/>
+                <a16:creationId xmlns:a16="http://schemas.microsoft.com/office/drawing/2014/main" id="{F96BD704-B3F3-4680-9132-4042634F97C3}"/>
               </a:ext>
             </a:extLst>
           </p:cNvPr>
@@ -2797,7 +2797,7 @@
           <p:cNvPr id="15" name="">
             <a:extLst xmlns:a="http://schemas.openxmlformats.org/drawingml/2006/main">
               <a:ext uri="{FF2B5EF4-FFF2-40B4-BE49-F238E27FC236}">
-                <a16:creationId xmlns:a16="http://schemas.microsoft.com/office/drawing/2014/main" id="{EA82981B-4A12-42F8-8435-0D2F53991D30}"/>
+                <a16:creationId xmlns:a16="http://schemas.microsoft.com/office/drawing/2014/main" id="{DF471174-C21F-4EA3-8A91-8CF923DA7832}"/>
               </a:ext>
             </a:extLst>
           </p:cNvPr>
@@ -2845,7 +2845,7 @@
     </p:spTree>
     <p:extLst>
       <p:ext uri="{BB962C8B-B14F-4D97-AF65-F5344CB8AC3E}">
-        <p14:creationId xmlns:p14="http://schemas.microsoft.com/office/powerpoint/2010/main" val="538913160"/>
+        <p14:creationId xmlns:p14="http://schemas.microsoft.com/office/powerpoint/2010/main" val="138308817"/>
       </p:ext>
     </p:extLst>
   </p:cSld>
@@ -2876,7 +2876,7 @@
           <p:cNvPr id="1" name="">
             <a:extLst xmlns:a="http://schemas.openxmlformats.org/drawingml/2006/main">
               <a:ext uri="{FF2B5EF4-FFF2-40B4-BE49-F238E27FC236}">
-                <a16:creationId xmlns:a16="http://schemas.microsoft.com/office/drawing/2014/main" id="{CF056323-C9DC-473C-9A23-AF8FE37BB379}"/>
+                <a16:creationId xmlns:a16="http://schemas.microsoft.com/office/drawing/2014/main" id="{AF6D5618-36AF-45D5-9E91-77B5BA90D93B}"/>
               </a:ext>
             </a:extLst>
           </p:cNvPr>
@@ -2926,7 +2926,7 @@
           <p:cNvPr id="2" name="">
             <a:extLst xmlns:a="http://schemas.openxmlformats.org/drawingml/2006/main">
               <a:ext uri="{FF2B5EF4-FFF2-40B4-BE49-F238E27FC236}">
-                <a16:creationId xmlns:a16="http://schemas.microsoft.com/office/drawing/2014/main" id="{93C0C2EE-0D41-4735-AEA3-1AE0F40F5CD1}"/>
+                <a16:creationId xmlns:a16="http://schemas.microsoft.com/office/drawing/2014/main" id="{5285D27F-B660-4D67-BD9C-76E14278E94E}"/>
               </a:ext>
             </a:extLst>
           </p:cNvPr>
@@ -2976,7 +2976,7 @@
           <p:cNvPr id="3" name="">
             <a:extLst xmlns:a="http://schemas.openxmlformats.org/drawingml/2006/main">
               <a:ext uri="{FF2B5EF4-FFF2-40B4-BE49-F238E27FC236}">
-                <a16:creationId xmlns:a16="http://schemas.microsoft.com/office/drawing/2014/main" id="{83135368-1877-4A50-BA20-A88851674E02}"/>
+                <a16:creationId xmlns:a16="http://schemas.microsoft.com/office/drawing/2014/main" id="{EFF2683B-3AFE-4E95-8487-F1C3E55D816E}"/>
               </a:ext>
             </a:extLst>
           </p:cNvPr>
@@ -3016,7 +3016,7 @@
                   <a:srgbClr val="52615B"/>
                 </a:solidFill>
               </a:rPr>
-              <a:t>CollectiveはSupplierからRetailerへの同期を担い、外部システムは接続先ストアのWebhookを購読します。</a:t>
+              <a:t>Collectiveはサプライヤーから小売業者への同期を担い、外部システムは接続先ストアのWebhookを購読します。</a:t>
             </a:r>
           </a:p>
         </p:txBody>
@@ -3026,7 +3026,7 @@
           <p:cNvPr id="4" name="">
             <a:extLst xmlns:a="http://schemas.openxmlformats.org/drawingml/2006/main">
               <a:ext uri="{FF2B5EF4-FFF2-40B4-BE49-F238E27FC236}">
-                <a16:creationId xmlns:a16="http://schemas.microsoft.com/office/drawing/2014/main" id="{F1EAF632-3F05-41EC-A31C-BB440C1F7367}"/>
+                <a16:creationId xmlns:a16="http://schemas.microsoft.com/office/drawing/2014/main" id="{36140C57-8DF8-47A4-A4DC-AE137EAC6EFD}"/>
               </a:ext>
             </a:extLst>
           </p:cNvPr>
@@ -3057,7 +3057,7 @@
           <p:cNvPr id="5" name="">
             <a:extLst xmlns:a="http://schemas.openxmlformats.org/drawingml/2006/main">
               <a:ext uri="{FF2B5EF4-FFF2-40B4-BE49-F238E27FC236}">
-                <a16:creationId xmlns:a16="http://schemas.microsoft.com/office/drawing/2014/main" id="{E5268091-9090-4307-ACBB-ADB3A188A410}"/>
+                <a16:creationId xmlns:a16="http://schemas.microsoft.com/office/drawing/2014/main" id="{A1DBF76F-0D39-41ED-8CA1-107DDDDFA536}"/>
               </a:ext>
             </a:extLst>
           </p:cNvPr>
@@ -3107,7 +3107,7 @@
           <p:cNvPr id="6" name="">
             <a:extLst xmlns:a="http://schemas.openxmlformats.org/drawingml/2006/main">
               <a:ext uri="{FF2B5EF4-FFF2-40B4-BE49-F238E27FC236}">
-                <a16:creationId xmlns:a16="http://schemas.microsoft.com/office/drawing/2014/main" id="{6AF22B77-A7D1-4183-8E07-566686B8A92D}"/>
+                <a16:creationId xmlns:a16="http://schemas.microsoft.com/office/drawing/2014/main" id="{1D55856A-B383-4C5D-B208-4759FAAB98E5}"/>
               </a:ext>
             </a:extLst>
           </p:cNvPr>
@@ -3147,7 +3147,7 @@
                   <a:srgbClr val="52615B"/>
                 </a:solidFill>
               </a:rPr>
-              <a:t>Supplierのオンライン販売可能在庫がRetailer在庫に反映されます。Retailer側の外部ミラーは商品作成・更新・削除Webhookを使います。</a:t>
+              <a:t>サプライヤーのオンライン販売可能在庫が小売業者在庫に反映されます。小売業者側の外部ミラーは商品作成・更新・削除Webhookを使います。</a:t>
             </a:r>
           </a:p>
         </p:txBody>
@@ -3157,7 +3157,7 @@
           <p:cNvPr id="7" name="">
             <a:extLst xmlns:a="http://schemas.openxmlformats.org/drawingml/2006/main">
               <a:ext uri="{FF2B5EF4-FFF2-40B4-BE49-F238E27FC236}">
-                <a16:creationId xmlns:a16="http://schemas.microsoft.com/office/drawing/2014/main" id="{18E6D18C-553A-44A9-B282-20D3A4DC6D0A}"/>
+                <a16:creationId xmlns:a16="http://schemas.microsoft.com/office/drawing/2014/main" id="{FF44B1EE-C7A0-4CE2-B4E5-DA0E65E3FFAB}"/>
               </a:ext>
             </a:extLst>
           </p:cNvPr>
@@ -3207,7 +3207,7 @@
           <p:cNvPr id="8" name="">
             <a:extLst xmlns:a="http://schemas.openxmlformats.org/drawingml/2006/main">
               <a:ext uri="{FF2B5EF4-FFF2-40B4-BE49-F238E27FC236}">
-                <a16:creationId xmlns:a16="http://schemas.microsoft.com/office/drawing/2014/main" id="{C5CA57EA-0546-4987-8336-EABCB9BF2AD0}"/>
+                <a16:creationId xmlns:a16="http://schemas.microsoft.com/office/drawing/2014/main" id="{D2F0CAB4-FF1C-4989-82D8-0FA2F9FD0833}"/>
               </a:ext>
             </a:extLst>
           </p:cNvPr>
@@ -3247,7 +3247,7 @@
                   <a:srgbClr val="52615B"/>
                 </a:solidFill>
               </a:rPr>
-              <a:t>一時的にはありえます。Shopify checkoutはSupplier在庫を確認しますが、手動注文は例外です。</a:t>
+              <a:t>一時的にはありえます。Shopify checkoutはサプライヤー在庫を確認しますが、手動注文は例外です。</a:t>
             </a:r>
           </a:p>
         </p:txBody>
@@ -3257,7 +3257,7 @@
           <p:cNvPr id="9" name="">
             <a:extLst xmlns:a="http://schemas.openxmlformats.org/drawingml/2006/main">
               <a:ext uri="{FF2B5EF4-FFF2-40B4-BE49-F238E27FC236}">
-                <a16:creationId xmlns:a16="http://schemas.microsoft.com/office/drawing/2014/main" id="{96682655-CF5A-4C1C-AC1F-C202DED9FEA4}"/>
+                <a16:creationId xmlns:a16="http://schemas.microsoft.com/office/drawing/2014/main" id="{6BAEFDB3-E680-4DFF-9F88-CAB051059C2F}"/>
               </a:ext>
             </a:extLst>
           </p:cNvPr>
@@ -3297,7 +3297,7 @@
                   <a:srgbClr val="004C3F"/>
                 </a:solidFill>
               </a:rPr>
-              <a:t>商品マスターはSupplier側必須?</a:t>
+              <a:t>商品マスターはサプライヤー側必須?</a:t>
             </a:r>
           </a:p>
         </p:txBody>
@@ -3307,7 +3307,7 @@
           <p:cNvPr id="10" name="">
             <a:extLst xmlns:a="http://schemas.openxmlformats.org/drawingml/2006/main">
               <a:ext uri="{FF2B5EF4-FFF2-40B4-BE49-F238E27FC236}">
-                <a16:creationId xmlns:a16="http://schemas.microsoft.com/office/drawing/2014/main" id="{B7320747-B6A2-4A0A-9727-B2040260E4E2}"/>
+                <a16:creationId xmlns:a16="http://schemas.microsoft.com/office/drawing/2014/main" id="{81C5C96C-AB22-40EB-9641-8F6C2198C040}"/>
               </a:ext>
             </a:extLst>
           </p:cNvPr>
@@ -3347,7 +3347,7 @@
                   <a:srgbClr val="52615B"/>
                 </a:solidFill>
               </a:rPr>
-              <a:t>Collectiveで共有する商品はSupplierのShopifyストアに存在し、Collectiveへ公開される必要があります。上流はERP/PIMでも構いません。</a:t>
+              <a:t>共有商品はサプライヤーのShopifyストアに存在し、Collective公開が必要です。上流はERP/PIMでも構いません。</a:t>
             </a:r>
           </a:p>
         </p:txBody>
@@ -3357,7 +3357,7 @@
           <p:cNvPr id="11" name="">
             <a:extLst xmlns:a="http://schemas.openxmlformats.org/drawingml/2006/main">
               <a:ext uri="{FF2B5EF4-FFF2-40B4-BE49-F238E27FC236}">
-                <a16:creationId xmlns:a16="http://schemas.microsoft.com/office/drawing/2014/main" id="{8D310D53-D564-4270-89C5-4B64CA24A09B}"/>
+                <a16:creationId xmlns:a16="http://schemas.microsoft.com/office/drawing/2014/main" id="{11734C91-0ACE-4C92-83E1-CE6DF68E2BD4}"/>
               </a:ext>
             </a:extLst>
           </p:cNvPr>
@@ -3397,7 +3397,7 @@
                   <a:srgbClr val="004C3F"/>
                 </a:solidFill>
               </a:rPr>
-              <a:t>Supplier変更時は?</a:t>
+              <a:t>サプライヤーがデータ/価格/在庫を変更したら?</a:t>
             </a:r>
           </a:p>
         </p:txBody>
@@ -3407,7 +3407,7 @@
           <p:cNvPr id="12" name="">
             <a:extLst xmlns:a="http://schemas.openxmlformats.org/drawingml/2006/main">
               <a:ext uri="{FF2B5EF4-FFF2-40B4-BE49-F238E27FC236}">
-                <a16:creationId xmlns:a16="http://schemas.microsoft.com/office/drawing/2014/main" id="{0F40BB7B-13F6-4E41-9D3A-2B36801DE1A7}"/>
+                <a16:creationId xmlns:a16="http://schemas.microsoft.com/office/drawing/2014/main" id="{D057A819-A2B0-4060-A2DA-22B945A374B8}"/>
               </a:ext>
             </a:extLst>
           </p:cNvPr>
@@ -3447,7 +3447,7 @@
                   <a:srgbClr val="52615B"/>
                 </a:solidFill>
               </a:rPr>
-              <a:t>在庫とcost priceは同期されます。その他の商品情報は設定次第です。Retailer側の外部連携は商品Webhookで追従します。</a:t>
+              <a:t>同期対象は小売業者データに反映。将来注文は新しい原価、送料、在庫を使い、支払い済み注文は調整がなければ注文時金額を維持します。</a:t>
             </a:r>
           </a:p>
         </p:txBody>
@@ -3457,7 +3457,7 @@
           <p:cNvPr id="13" name="">
             <a:extLst xmlns:a="http://schemas.openxmlformats.org/drawingml/2006/main">
               <a:ext uri="{FF2B5EF4-FFF2-40B4-BE49-F238E27FC236}">
-                <a16:creationId xmlns:a16="http://schemas.microsoft.com/office/drawing/2014/main" id="{C17744A7-B9E2-4719-BFF4-BF541D494FD1}"/>
+                <a16:creationId xmlns:a16="http://schemas.microsoft.com/office/drawing/2014/main" id="{9EED5BA5-8C88-4076-831F-B76A08052612}"/>
               </a:ext>
             </a:extLst>
           </p:cNvPr>
@@ -3488,7 +3488,7 @@
           <p:cNvPr id="14" name="">
             <a:extLst xmlns:a="http://schemas.openxmlformats.org/drawingml/2006/main">
               <a:ext uri="{FF2B5EF4-FFF2-40B4-BE49-F238E27FC236}">
-                <a16:creationId xmlns:a16="http://schemas.microsoft.com/office/drawing/2014/main" id="{8294CBD3-F0B2-4DF4-8B8C-A020A87930D7}"/>
+                <a16:creationId xmlns:a16="http://schemas.microsoft.com/office/drawing/2014/main" id="{AC544F8A-D67B-43E1-ACEC-584F7AA8C2E5}"/>
               </a:ext>
             </a:extLst>
           </p:cNvPr>
@@ -3538,7 +3538,7 @@
           <p:cNvPr id="15" name="">
             <a:extLst xmlns:a="http://schemas.openxmlformats.org/drawingml/2006/main">
               <a:ext uri="{FF2B5EF4-FFF2-40B4-BE49-F238E27FC236}">
-                <a16:creationId xmlns:a16="http://schemas.microsoft.com/office/drawing/2014/main" id="{E21DE1F1-6130-4423-8134-8A302338425E}"/>
+                <a16:creationId xmlns:a16="http://schemas.microsoft.com/office/drawing/2014/main" id="{B05BC63E-297C-403B-885F-773E504E5058}"/>
               </a:ext>
             </a:extLst>
           </p:cNvPr>
@@ -3586,7 +3586,7 @@
     </p:spTree>
     <p:extLst>
       <p:ext uri="{BB962C8B-B14F-4D97-AF65-F5344CB8AC3E}">
-        <p14:creationId xmlns:p14="http://schemas.microsoft.com/office/powerpoint/2010/main" val="1804768431"/>
+        <p14:creationId xmlns:p14="http://schemas.microsoft.com/office/powerpoint/2010/main" val="1294069808"/>
       </p:ext>
     </p:extLst>
   </p:cSld>
@@ -3617,7 +3617,7 @@
           <p:cNvPr id="1" name="">
             <a:extLst xmlns:a="http://schemas.openxmlformats.org/drawingml/2006/main">
               <a:ext uri="{FF2B5EF4-FFF2-40B4-BE49-F238E27FC236}">
-                <a16:creationId xmlns:a16="http://schemas.microsoft.com/office/drawing/2014/main" id="{48F3E185-9F68-4093-9AEB-DEC6F3C208F4}"/>
+                <a16:creationId xmlns:a16="http://schemas.microsoft.com/office/drawing/2014/main" id="{3E68B486-7EB3-460E-8B73-570CC275483E}"/>
               </a:ext>
             </a:extLst>
           </p:cNvPr>
@@ -3657,7 +3657,7 @@
                   <a:srgbClr val="004C3F"/>
                 </a:solidFill>
               </a:rPr>
-              <a:t>11 | FAQ: Retailer変更</a:t>
+              <a:t>11 | FAQ: 小売業者変更</a:t>
             </a:r>
           </a:p>
         </p:txBody>
@@ -3667,7 +3667,7 @@
           <p:cNvPr id="2" name="">
             <a:extLst xmlns:a="http://schemas.openxmlformats.org/drawingml/2006/main">
               <a:ext uri="{FF2B5EF4-FFF2-40B4-BE49-F238E27FC236}">
-                <a16:creationId xmlns:a16="http://schemas.microsoft.com/office/drawing/2014/main" id="{4EBF0DF5-EB9A-48A0-BFD2-EBA4BF9F0B43}"/>
+                <a16:creationId xmlns:a16="http://schemas.microsoft.com/office/drawing/2014/main" id="{E7CF06DE-1703-4A2F-9B41-6EEEE376AF15}"/>
               </a:ext>
             </a:extLst>
           </p:cNvPr>
@@ -3707,7 +3707,7 @@
                   <a:srgbClr val="101820"/>
                 </a:solidFill>
               </a:rPr>
-              <a:t>Retailer側の変更はSupplierマスターを更新しない</a:t>
+              <a:t>小売業者側の変更はサプライヤーデータや原価を更新しない</a:t>
             </a:r>
           </a:p>
         </p:txBody>
@@ -3717,7 +3717,7 @@
           <p:cNvPr id="3" name="">
             <a:extLst xmlns:a="http://schemas.openxmlformats.org/drawingml/2006/main">
               <a:ext uri="{FF2B5EF4-FFF2-40B4-BE49-F238E27FC236}">
-                <a16:creationId xmlns:a16="http://schemas.microsoft.com/office/drawing/2014/main" id="{B3119D9B-D16F-444C-B6F8-54C5818B7257}"/>
+                <a16:creationId xmlns:a16="http://schemas.microsoft.com/office/drawing/2014/main" id="{E5D6B58D-4ADE-4599-BB55-F30DBCE0426C}"/>
               </a:ext>
             </a:extLst>
           </p:cNvPr>
@@ -3757,7 +3757,7 @@
                   <a:srgbClr val="52615B"/>
                 </a:solidFill>
               </a:rPr>
-              <a:t>RetailerストアのWebhookはRetailer側イベントとして扱い、Supplierの元商品変更とは区別します。</a:t>
+              <a:t>小売業者ストアのWebhookは小売業者側イベントとして扱い、サプライヤーの元商品変更とは区別します。</a:t>
             </a:r>
           </a:p>
         </p:txBody>
@@ -3767,7 +3767,7 @@
           <p:cNvPr id="4" name="">
             <a:extLst xmlns:a="http://schemas.openxmlformats.org/drawingml/2006/main">
               <a:ext uri="{FF2B5EF4-FFF2-40B4-BE49-F238E27FC236}">
-                <a16:creationId xmlns:a16="http://schemas.microsoft.com/office/drawing/2014/main" id="{948615C6-E3F7-41B2-BC78-C308081928BE}"/>
+                <a16:creationId xmlns:a16="http://schemas.microsoft.com/office/drawing/2014/main" id="{F83AD47B-3541-4B98-BA93-1F046179725E}"/>
               </a:ext>
             </a:extLst>
           </p:cNvPr>
@@ -3798,7 +3798,7 @@
           <p:cNvPr id="5" name="">
             <a:extLst xmlns:a="http://schemas.openxmlformats.org/drawingml/2006/main">
               <a:ext uri="{FF2B5EF4-FFF2-40B4-BE49-F238E27FC236}">
-                <a16:creationId xmlns:a16="http://schemas.microsoft.com/office/drawing/2014/main" id="{34579E86-61BE-4960-A641-28A343D2380B}"/>
+                <a16:creationId xmlns:a16="http://schemas.microsoft.com/office/drawing/2014/main" id="{6D725A81-064E-48E9-8731-7FA1BD8B7C8D}"/>
               </a:ext>
             </a:extLst>
           </p:cNvPr>
@@ -3838,7 +3838,7 @@
                   <a:srgbClr val="004C3F"/>
                 </a:solidFill>
               </a:rPr>
-              <a:t>Retailerが商品を変更したら?</a:t>
+              <a:t>小売業者がデータ/価格/在庫を変更したら?</a:t>
             </a:r>
           </a:p>
         </p:txBody>
@@ -3848,7 +3848,7 @@
           <p:cNvPr id="6" name="">
             <a:extLst xmlns:a="http://schemas.openxmlformats.org/drawingml/2006/main">
               <a:ext uri="{FF2B5EF4-FFF2-40B4-BE49-F238E27FC236}">
-                <a16:creationId xmlns:a16="http://schemas.microsoft.com/office/drawing/2014/main" id="{0F77266C-43A4-471A-B93D-7771B40E8F0F}"/>
+                <a16:creationId xmlns:a16="http://schemas.microsoft.com/office/drawing/2014/main" id="{8BB76CF1-BB15-4670-BC48-F0BF9F90118D}"/>
               </a:ext>
             </a:extLst>
           </p:cNvPr>
@@ -3888,7 +3888,7 @@
                   <a:srgbClr val="52615B"/>
                 </a:solidFill>
               </a:rPr>
-              <a:t>Retailer編集はSupplierの元商品を更新しません。Supplier管理フィールドはSupplier側が管理します。</a:t>
+              <a:t>サプライヤー元データと原価は変わりません。サプライヤー注文金額は原価、送料、税、調整に基づきます。</a:t>
             </a:r>
           </a:p>
         </p:txBody>
@@ -3898,7 +3898,7 @@
           <p:cNvPr id="7" name="">
             <a:extLst xmlns:a="http://schemas.openxmlformats.org/drawingml/2006/main">
               <a:ext uri="{FF2B5EF4-FFF2-40B4-BE49-F238E27FC236}">
-                <a16:creationId xmlns:a16="http://schemas.microsoft.com/office/drawing/2014/main" id="{B86C2FE8-AC67-49DA-A959-05E03E77A450}"/>
+                <a16:creationId xmlns:a16="http://schemas.microsoft.com/office/drawing/2014/main" id="{881FB1FE-03F8-4BB1-95C6-DFA6C3AD42A1}"/>
               </a:ext>
             </a:extLst>
           </p:cNvPr>
@@ -3938,7 +3938,7 @@
                   <a:srgbClr val="004C3F"/>
                 </a:solidFill>
               </a:rPr>
-              <a:t>Retailerが価格を変更したら?</a:t>
+              <a:t>小売業者編集は上書きされる?</a:t>
             </a:r>
           </a:p>
         </p:txBody>
@@ -3948,7 +3948,7 @@
           <p:cNvPr id="8" name="">
             <a:extLst xmlns:a="http://schemas.openxmlformats.org/drawingml/2006/main">
               <a:ext uri="{FF2B5EF4-FFF2-40B4-BE49-F238E27FC236}">
-                <a16:creationId xmlns:a16="http://schemas.microsoft.com/office/drawing/2014/main" id="{3E74FC66-89E4-4980-AB1D-296C5E7301EC}"/>
+                <a16:creationId xmlns:a16="http://schemas.microsoft.com/office/drawing/2014/main" id="{4390A876-9F70-4C01-AB81-1A1802E04077}"/>
               </a:ext>
             </a:extLst>
           </p:cNvPr>
@@ -3988,7 +3988,7 @@
                   <a:srgbClr val="52615B"/>
                 </a:solidFill>
               </a:rPr>
-              <a:t>Retail price syncがOFFならRetailerがretail priceを管理できます。Supplier cost priceはSupplier管理です。</a:t>
+              <a:t>サプライヤー管理または同期対象フィールドは、サプライヤー更新で上書きされる場合があります。在庫はサプライヤー管理です。</a:t>
             </a:r>
           </a:p>
         </p:txBody>
@@ -3998,7 +3998,7 @@
           <p:cNvPr id="9" name="">
             <a:extLst xmlns:a="http://schemas.openxmlformats.org/drawingml/2006/main">
               <a:ext uri="{FF2B5EF4-FFF2-40B4-BE49-F238E27FC236}">
-                <a16:creationId xmlns:a16="http://schemas.microsoft.com/office/drawing/2014/main" id="{51407CFE-5032-423F-8B94-9A8F9CEE8F21}"/>
+                <a16:creationId xmlns:a16="http://schemas.microsoft.com/office/drawing/2014/main" id="{1D648741-A1BF-4502-9E36-5662617B8419}"/>
               </a:ext>
             </a:extLst>
           </p:cNvPr>
@@ -4038,7 +4038,7 @@
                   <a:srgbClr val="004C3F"/>
                 </a:solidFill>
               </a:rPr>
-              <a:t>Retailerが在庫を変更したら?</a:t>
+              <a:t>小売業者が購入者価格を変更したら?</a:t>
             </a:r>
           </a:p>
         </p:txBody>
@@ -4048,7 +4048,7 @@
           <p:cNvPr id="10" name="">
             <a:extLst xmlns:a="http://schemas.openxmlformats.org/drawingml/2006/main">
               <a:ext uri="{FF2B5EF4-FFF2-40B4-BE49-F238E27FC236}">
-                <a16:creationId xmlns:a16="http://schemas.microsoft.com/office/drawing/2014/main" id="{F38E8436-272F-4467-8078-B2866108F9FE}"/>
+                <a16:creationId xmlns:a16="http://schemas.microsoft.com/office/drawing/2014/main" id="{DFB20007-5507-413E-8A8A-005B8676F50B}"/>
               </a:ext>
             </a:extLst>
           </p:cNvPr>
@@ -4088,7 +4088,7 @@
                   <a:srgbClr val="52615B"/>
                 </a:solidFill>
               </a:rPr>
-              <a:t>インポートされたCollective在庫はSupplier管理で、Retailer adminでは読み取り専用です。</a:t>
+              <a:t>顧客請求額と小売業者利益は変わりますが、サプライヤー原価と注文金額はサプライヤー側条件のままです。</a:t>
             </a:r>
           </a:p>
         </p:txBody>
@@ -4098,7 +4098,7 @@
           <p:cNvPr id="11" name="">
             <a:extLst xmlns:a="http://schemas.openxmlformats.org/drawingml/2006/main">
               <a:ext uri="{FF2B5EF4-FFF2-40B4-BE49-F238E27FC236}">
-                <a16:creationId xmlns:a16="http://schemas.microsoft.com/office/drawing/2014/main" id="{8FD73F45-19FD-425E-9408-AFAC0F655134}"/>
+                <a16:creationId xmlns:a16="http://schemas.microsoft.com/office/drawing/2014/main" id="{83751C8D-9282-42DB-96B4-56C7CE77B89E}"/>
               </a:ext>
             </a:extLst>
           </p:cNvPr>
@@ -4148,7 +4148,7 @@
           <p:cNvPr id="12" name="">
             <a:extLst xmlns:a="http://schemas.openxmlformats.org/drawingml/2006/main">
               <a:ext uri="{FF2B5EF4-FFF2-40B4-BE49-F238E27FC236}">
-                <a16:creationId xmlns:a16="http://schemas.microsoft.com/office/drawing/2014/main" id="{687B81F8-DEE0-4743-ABE2-9A990651484A}"/>
+                <a16:creationId xmlns:a16="http://schemas.microsoft.com/office/drawing/2014/main" id="{570F21FE-7D91-4FD1-9242-0A921CAA82DA}"/>
               </a:ext>
             </a:extLst>
           </p:cNvPr>
@@ -4198,7 +4198,7 @@
           <p:cNvPr id="13" name="">
             <a:extLst xmlns:a="http://schemas.openxmlformats.org/drawingml/2006/main">
               <a:ext uri="{FF2B5EF4-FFF2-40B4-BE49-F238E27FC236}">
-                <a16:creationId xmlns:a16="http://schemas.microsoft.com/office/drawing/2014/main" id="{E7EEFBDD-D79A-4C93-B72E-820041B5D6F1}"/>
+                <a16:creationId xmlns:a16="http://schemas.microsoft.com/office/drawing/2014/main" id="{AD41CC92-9351-4E6A-B134-FF4466112B9A}"/>
               </a:ext>
             </a:extLst>
           </p:cNvPr>
@@ -4229,7 +4229,7 @@
           <p:cNvPr id="14" name="">
             <a:extLst xmlns:a="http://schemas.openxmlformats.org/drawingml/2006/main">
               <a:ext uri="{FF2B5EF4-FFF2-40B4-BE49-F238E27FC236}">
-                <a16:creationId xmlns:a16="http://schemas.microsoft.com/office/drawing/2014/main" id="{1564EFFD-0F92-4592-A067-62AA5CE3CCE2}"/>
+                <a16:creationId xmlns:a16="http://schemas.microsoft.com/office/drawing/2014/main" id="{855154EC-7810-45E4-B423-62DCDFBB3476}"/>
               </a:ext>
             </a:extLst>
           </p:cNvPr>
@@ -4279,7 +4279,7 @@
           <p:cNvPr id="15" name="">
             <a:extLst xmlns:a="http://schemas.openxmlformats.org/drawingml/2006/main">
               <a:ext uri="{FF2B5EF4-FFF2-40B4-BE49-F238E27FC236}">
-                <a16:creationId xmlns:a16="http://schemas.microsoft.com/office/drawing/2014/main" id="{78B31163-8B5A-4A92-88E4-6DB0C90BD7BA}"/>
+                <a16:creationId xmlns:a16="http://schemas.microsoft.com/office/drawing/2014/main" id="{6B87B591-A884-4362-A7FD-5345A19D1361}"/>
               </a:ext>
             </a:extLst>
           </p:cNvPr>
@@ -4327,7 +4327,7 @@
     </p:spTree>
     <p:extLst>
       <p:ext uri="{BB962C8B-B14F-4D97-AF65-F5344CB8AC3E}">
-        <p14:creationId xmlns:p14="http://schemas.microsoft.com/office/powerpoint/2010/main" val="1498199076"/>
+        <p14:creationId xmlns:p14="http://schemas.microsoft.com/office/powerpoint/2010/main" val="1337921556"/>
       </p:ext>
     </p:extLst>
   </p:cSld>
@@ -4358,7 +4358,7 @@
           <p:cNvPr id="1" name="">
             <a:extLst xmlns:a="http://schemas.openxmlformats.org/drawingml/2006/main">
               <a:ext uri="{FF2B5EF4-FFF2-40B4-BE49-F238E27FC236}">
-                <a16:creationId xmlns:a16="http://schemas.microsoft.com/office/drawing/2014/main" id="{A4D334EB-2126-4053-BB06-EC0DD219131D}"/>
+                <a16:creationId xmlns:a16="http://schemas.microsoft.com/office/drawing/2014/main" id="{8A554E9C-5810-4BBB-AE49-B37CD146D466}"/>
               </a:ext>
             </a:extLst>
           </p:cNvPr>
@@ -4408,7 +4408,7 @@
           <p:cNvPr id="2" name="">
             <a:extLst xmlns:a="http://schemas.openxmlformats.org/drawingml/2006/main">
               <a:ext uri="{FF2B5EF4-FFF2-40B4-BE49-F238E27FC236}">
-                <a16:creationId xmlns:a16="http://schemas.microsoft.com/office/drawing/2014/main" id="{010372C0-563E-4F8F-B829-77E720D78C83}"/>
+                <a16:creationId xmlns:a16="http://schemas.microsoft.com/office/drawing/2014/main" id="{CB6B4A93-611B-41E0-8B61-16F76217AE2B}"/>
               </a:ext>
             </a:extLst>
           </p:cNvPr>
@@ -4458,7 +4458,7 @@
           <p:cNvPr id="3" name="">
             <a:extLst xmlns:a="http://schemas.openxmlformats.org/drawingml/2006/main">
               <a:ext uri="{FF2B5EF4-FFF2-40B4-BE49-F238E27FC236}">
-                <a16:creationId xmlns:a16="http://schemas.microsoft.com/office/drawing/2014/main" id="{30FB4C1E-EA7C-4CF9-8657-0ED7B9F5BB75}"/>
+                <a16:creationId xmlns:a16="http://schemas.microsoft.com/office/drawing/2014/main" id="{75F49DE5-403A-4DD6-ADDC-CC14CE5E7D39}"/>
               </a:ext>
             </a:extLst>
           </p:cNvPr>
@@ -4498,7 +4498,7 @@
                   <a:srgbClr val="52615B"/>
                 </a:solidFill>
               </a:rPr>
-              <a:t>Supplierの商品、Retailerの販売、Collectiveの同期・注文ルーティングを分けて見ると理解しやすくなります。</a:t>
+              <a:t>サプライヤーの商品、小売業者の販売、Collectiveの同期・注文ルーティングを分けて見ると理解しやすくなります。</a:t>
             </a:r>
           </a:p>
         </p:txBody>
@@ -4508,7 +4508,7 @@
           <p:cNvPr id="4" name="">
             <a:extLst xmlns:a="http://schemas.openxmlformats.org/drawingml/2006/main">
               <a:ext uri="{FF2B5EF4-FFF2-40B4-BE49-F238E27FC236}">
-                <a16:creationId xmlns:a16="http://schemas.microsoft.com/office/drawing/2014/main" id="{F81FAE79-7C3B-4C60-973A-06FB629A2279}"/>
+                <a16:creationId xmlns:a16="http://schemas.microsoft.com/office/drawing/2014/main" id="{A5596D98-367C-4CEA-AA8D-0B8DF22E3B9D}"/>
               </a:ext>
             </a:extLst>
           </p:cNvPr>
@@ -4539,7 +4539,7 @@
           <p:cNvPr id="5" name="">
             <a:extLst xmlns:a="http://schemas.openxmlformats.org/drawingml/2006/main">
               <a:ext uri="{FF2B5EF4-FFF2-40B4-BE49-F238E27FC236}">
-                <a16:creationId xmlns:a16="http://schemas.microsoft.com/office/drawing/2014/main" id="{10B16318-07A2-4E07-93E2-BEDAF31273B2}"/>
+                <a16:creationId xmlns:a16="http://schemas.microsoft.com/office/drawing/2014/main" id="{867ADEAD-C368-4335-B5A1-EB61E1C17536}"/>
               </a:ext>
             </a:extLst>
           </p:cNvPr>
@@ -4585,7 +4585,7 @@
                   <a:srgbClr val="101820"/>
                 </a:solidFill>
               </a:rPr>
-              <a:t>Supplier</a:t>
+              <a:t>サプライヤー</a:t>
             </a:r>
           </a:p>
         </p:txBody>
@@ -4595,7 +4595,7 @@
           <p:cNvPr id="6" name="">
             <a:extLst xmlns:a="http://schemas.openxmlformats.org/drawingml/2006/main">
               <a:ext uri="{FF2B5EF4-FFF2-40B4-BE49-F238E27FC236}">
-                <a16:creationId xmlns:a16="http://schemas.microsoft.com/office/drawing/2014/main" id="{41D18A2F-D0F7-4206-8B90-8AA19DE4490C}"/>
+                <a16:creationId xmlns:a16="http://schemas.microsoft.com/office/drawing/2014/main" id="{4001761F-345E-4844-85BF-EBF7A531ACB2}"/>
               </a:ext>
             </a:extLst>
           </p:cNvPr>
@@ -4635,7 +4635,7 @@
                   <a:srgbClr val="52615B"/>
                 </a:solidFill>
               </a:rPr>
-              <a:t>商品を所有し、price list、cost price、supplier shippingを設定し、顧客へ直接フルフィルメントします。</a:t>
+              <a:t>商品を所有し、price list、cost price、サプライヤー送料を設定し、顧客へ直接フルフィルメントします。</a:t>
             </a:r>
           </a:p>
         </p:txBody>
@@ -4645,7 +4645,7 @@
           <p:cNvPr id="7" name="">
             <a:extLst xmlns:a="http://schemas.openxmlformats.org/drawingml/2006/main">
               <a:ext uri="{FF2B5EF4-FFF2-40B4-BE49-F238E27FC236}">
-                <a16:creationId xmlns:a16="http://schemas.microsoft.com/office/drawing/2014/main" id="{18BCE863-5928-4C91-99C5-B1F350B22DFC}"/>
+                <a16:creationId xmlns:a16="http://schemas.microsoft.com/office/drawing/2014/main" id="{F452D62C-EE4B-4FCA-AB04-20EB95121512}"/>
               </a:ext>
             </a:extLst>
           </p:cNvPr>
@@ -4701,7 +4701,7 @@
           <p:cNvPr id="8" name="">
             <a:extLst xmlns:a="http://schemas.openxmlformats.org/drawingml/2006/main">
               <a:ext uri="{FF2B5EF4-FFF2-40B4-BE49-F238E27FC236}">
-                <a16:creationId xmlns:a16="http://schemas.microsoft.com/office/drawing/2014/main" id="{AA3B1A33-83FE-49E5-BDB6-CFAB171793DD}"/>
+                <a16:creationId xmlns:a16="http://schemas.microsoft.com/office/drawing/2014/main" id="{C6CF6B14-A269-4E4C-9A6F-EEB4265A82FA}"/>
               </a:ext>
             </a:extLst>
           </p:cNvPr>
@@ -4751,7 +4751,7 @@
           <p:cNvPr id="9" name="">
             <a:extLst xmlns:a="http://schemas.openxmlformats.org/drawingml/2006/main">
               <a:ext uri="{FF2B5EF4-FFF2-40B4-BE49-F238E27FC236}">
-                <a16:creationId xmlns:a16="http://schemas.microsoft.com/office/drawing/2014/main" id="{27BBBE99-DA75-4A7C-BBEC-7B878E99A58D}"/>
+                <a16:creationId xmlns:a16="http://schemas.microsoft.com/office/drawing/2014/main" id="{6EF141F6-5091-4A3B-9559-98DB5439EB1A}"/>
               </a:ext>
             </a:extLst>
           </p:cNvPr>
@@ -4797,7 +4797,7 @@
                   <a:srgbClr val="101820"/>
                 </a:solidFill>
               </a:rPr>
-              <a:t>Retailer</a:t>
+              <a:t>小売業者</a:t>
             </a:r>
           </a:p>
         </p:txBody>
@@ -4807,7 +4807,7 @@
           <p:cNvPr id="10" name="">
             <a:extLst xmlns:a="http://schemas.openxmlformats.org/drawingml/2006/main">
               <a:ext uri="{FF2B5EF4-FFF2-40B4-BE49-F238E27FC236}">
-                <a16:creationId xmlns:a16="http://schemas.microsoft.com/office/drawing/2014/main" id="{D4A1926E-54B6-439A-B2E5-5CFEC22067E8}"/>
+                <a16:creationId xmlns:a16="http://schemas.microsoft.com/office/drawing/2014/main" id="{5CA1C6ED-0207-4C94-8C98-3E3CE31F03E2}"/>
               </a:ext>
             </a:extLst>
           </p:cNvPr>
@@ -4857,7 +4857,7 @@
           <p:cNvPr id="11" name="">
             <a:extLst xmlns:a="http://schemas.openxmlformats.org/drawingml/2006/main">
               <a:ext uri="{FF2B5EF4-FFF2-40B4-BE49-F238E27FC236}">
-                <a16:creationId xmlns:a16="http://schemas.microsoft.com/office/drawing/2014/main" id="{6FC357B0-FEB1-4AFB-AE72-7D953E2BEBB2}"/>
+                <a16:creationId xmlns:a16="http://schemas.microsoft.com/office/drawing/2014/main" id="{4199E92A-1621-41F3-8501-AC191386A2AC}"/>
               </a:ext>
             </a:extLst>
           </p:cNvPr>
@@ -4888,7 +4888,7 @@
           <p:cNvPr id="12" name="">
             <a:extLst xmlns:a="http://schemas.openxmlformats.org/drawingml/2006/main">
               <a:ext uri="{FF2B5EF4-FFF2-40B4-BE49-F238E27FC236}">
-                <a16:creationId xmlns:a16="http://schemas.microsoft.com/office/drawing/2014/main" id="{D9D1A3DD-C1BE-4161-83D6-8FEBEC2E6502}"/>
+                <a16:creationId xmlns:a16="http://schemas.microsoft.com/office/drawing/2014/main" id="{B94F52E7-5272-4AEB-A36F-B234B05EC866}"/>
               </a:ext>
             </a:extLst>
           </p:cNvPr>
@@ -4938,7 +4938,7 @@
           <p:cNvPr id="13" name="">
             <a:extLst xmlns:a="http://schemas.openxmlformats.org/drawingml/2006/main">
               <a:ext uri="{FF2B5EF4-FFF2-40B4-BE49-F238E27FC236}">
-                <a16:creationId xmlns:a16="http://schemas.microsoft.com/office/drawing/2014/main" id="{510F510E-BD20-421A-9E49-A6BC04F7C985}"/>
+                <a16:creationId xmlns:a16="http://schemas.microsoft.com/office/drawing/2014/main" id="{E4077A7E-ABEC-4930-AF77-2D2DB1C05361}"/>
               </a:ext>
             </a:extLst>
           </p:cNvPr>
@@ -4986,7 +4986,7 @@
     </p:spTree>
     <p:extLst>
       <p:ext uri="{BB962C8B-B14F-4D97-AF65-F5344CB8AC3E}">
-        <p14:creationId xmlns:p14="http://schemas.microsoft.com/office/powerpoint/2010/main" val="1175628177"/>
+        <p14:creationId xmlns:p14="http://schemas.microsoft.com/office/powerpoint/2010/main" val="1518777431"/>
       </p:ext>
     </p:extLst>
   </p:cSld>
@@ -5017,7 +5017,7 @@
           <p:cNvPr id="1" name="">
             <a:extLst xmlns:a="http://schemas.openxmlformats.org/drawingml/2006/main">
               <a:ext uri="{FF2B5EF4-FFF2-40B4-BE49-F238E27FC236}">
-                <a16:creationId xmlns:a16="http://schemas.microsoft.com/office/drawing/2014/main" id="{BBBFD532-534E-4B9D-9BE1-E70A48F30478}"/>
+                <a16:creationId xmlns:a16="http://schemas.microsoft.com/office/drawing/2014/main" id="{57BFF626-9AB2-4452-9A3F-5D5A35878015}"/>
               </a:ext>
             </a:extLst>
           </p:cNvPr>
@@ -5067,7 +5067,7 @@
           <p:cNvPr id="2" name="">
             <a:extLst xmlns:a="http://schemas.openxmlformats.org/drawingml/2006/main">
               <a:ext uri="{FF2B5EF4-FFF2-40B4-BE49-F238E27FC236}">
-                <a16:creationId xmlns:a16="http://schemas.microsoft.com/office/drawing/2014/main" id="{8037E3EA-FDE8-450C-9F89-5B94C6992D6E}"/>
+                <a16:creationId xmlns:a16="http://schemas.microsoft.com/office/drawing/2014/main" id="{2870BF5D-9968-482C-8AE1-B2AA10ACA952}"/>
               </a:ext>
             </a:extLst>
           </p:cNvPr>
@@ -5107,7 +5107,7 @@
                   <a:srgbClr val="101820"/>
                 </a:solidFill>
               </a:rPr>
-              <a:t>商品共有はSupplierのprice listから始まる</a:t>
+              <a:t>商品共有はサプライヤーのprice listから始まる</a:t>
             </a:r>
           </a:p>
         </p:txBody>
@@ -5117,7 +5117,7 @@
           <p:cNvPr id="3" name="">
             <a:extLst xmlns:a="http://schemas.openxmlformats.org/drawingml/2006/main">
               <a:ext uri="{FF2B5EF4-FFF2-40B4-BE49-F238E27FC236}">
-                <a16:creationId xmlns:a16="http://schemas.microsoft.com/office/drawing/2014/main" id="{7146DE3B-8951-443E-9EBD-127259AAE83C}"/>
+                <a16:creationId xmlns:a16="http://schemas.microsoft.com/office/drawing/2014/main" id="{BD6A1098-9FC9-4D87-A42B-E8E216E268F8}"/>
               </a:ext>
             </a:extLst>
           </p:cNvPr>
@@ -5157,7 +5157,7 @@
                   <a:srgbClr val="52615B"/>
                 </a:solidFill>
               </a:rPr>
-              <a:t>商品はSupplierのShopifyストアに存在し、ACTIVEで、Collective Supplierチャネルに公開され、price listに含まれる必要があります。</a:t>
+              <a:t>商品はサプライヤーのShopifyストアに存在し、ACTIVEで、Collective Supplierチャネルに公開され、price listに含まれる必要があります。</a:t>
             </a:r>
           </a:p>
         </p:txBody>
@@ -5167,7 +5167,7 @@
           <p:cNvPr id="4" name="">
             <a:extLst xmlns:a="http://schemas.openxmlformats.org/drawingml/2006/main">
               <a:ext uri="{FF2B5EF4-FFF2-40B4-BE49-F238E27FC236}">
-                <a16:creationId xmlns:a16="http://schemas.microsoft.com/office/drawing/2014/main" id="{15C512C5-AE53-4128-BC1C-A4321B70B1FF}"/>
+                <a16:creationId xmlns:a16="http://schemas.microsoft.com/office/drawing/2014/main" id="{71D6341B-EC7F-42E4-A61B-E9B789E60FA2}"/>
               </a:ext>
             </a:extLst>
           </p:cNvPr>
@@ -5198,7 +5198,7 @@
           <p:cNvPr id="5" name="">
             <a:extLst xmlns:a="http://schemas.openxmlformats.org/drawingml/2006/main">
               <a:ext uri="{FF2B5EF4-FFF2-40B4-BE49-F238E27FC236}">
-                <a16:creationId xmlns:a16="http://schemas.microsoft.com/office/drawing/2014/main" id="{83F53AE4-B8D9-497C-9DB4-2DD7CF25C76F}"/>
+                <a16:creationId xmlns:a16="http://schemas.microsoft.com/office/drawing/2014/main" id="{05B97A29-1E16-46FC-862F-DA52852ADC68}"/>
               </a:ext>
             </a:extLst>
           </p:cNvPr>
@@ -5254,7 +5254,7 @@
           <p:cNvPr id="6" name="">
             <a:extLst xmlns:a="http://schemas.openxmlformats.org/drawingml/2006/main">
               <a:ext uri="{FF2B5EF4-FFF2-40B4-BE49-F238E27FC236}">
-                <a16:creationId xmlns:a16="http://schemas.microsoft.com/office/drawing/2014/main" id="{74604EEC-7F50-41E2-A260-F49F56D489DE}"/>
+                <a16:creationId xmlns:a16="http://schemas.microsoft.com/office/drawing/2014/main" id="{77C45FC7-681F-4CF8-B98C-D84C3D28E4F6}"/>
               </a:ext>
             </a:extLst>
           </p:cNvPr>
@@ -5304,7 +5304,7 @@
           <p:cNvPr id="7" name="">
             <a:extLst xmlns:a="http://schemas.openxmlformats.org/drawingml/2006/main">
               <a:ext uri="{FF2B5EF4-FFF2-40B4-BE49-F238E27FC236}">
-                <a16:creationId xmlns:a16="http://schemas.microsoft.com/office/drawing/2014/main" id="{850B62AE-EEC2-4755-AF76-9ED78F46AC78}"/>
+                <a16:creationId xmlns:a16="http://schemas.microsoft.com/office/drawing/2014/main" id="{C199EC69-9B45-47F4-95DD-846BD20BC219}"/>
               </a:ext>
             </a:extLst>
           </p:cNvPr>
@@ -5354,7 +5354,7 @@
           <p:cNvPr id="8" name="">
             <a:extLst xmlns:a="http://schemas.openxmlformats.org/drawingml/2006/main">
               <a:ext uri="{FF2B5EF4-FFF2-40B4-BE49-F238E27FC236}">
-                <a16:creationId xmlns:a16="http://schemas.microsoft.com/office/drawing/2014/main" id="{B8FBC3B8-93BA-429D-BAF0-84BD52EEDC19}"/>
+                <a16:creationId xmlns:a16="http://schemas.microsoft.com/office/drawing/2014/main" id="{30E5631E-9673-475B-B6FD-06B229D439C5}"/>
               </a:ext>
             </a:extLst>
           </p:cNvPr>
@@ -5410,7 +5410,7 @@
           <p:cNvPr id="9" name="">
             <a:extLst xmlns:a="http://schemas.openxmlformats.org/drawingml/2006/main">
               <a:ext uri="{FF2B5EF4-FFF2-40B4-BE49-F238E27FC236}">
-                <a16:creationId xmlns:a16="http://schemas.microsoft.com/office/drawing/2014/main" id="{51403B28-8528-40BD-8F7B-96199571E472}"/>
+                <a16:creationId xmlns:a16="http://schemas.microsoft.com/office/drawing/2014/main" id="{FBCF4FAF-8ED8-4AA6-AAF9-69C33E60FF18}"/>
               </a:ext>
             </a:extLst>
           </p:cNvPr>
@@ -5460,7 +5460,7 @@
           <p:cNvPr id="10" name="">
             <a:extLst xmlns:a="http://schemas.openxmlformats.org/drawingml/2006/main">
               <a:ext uri="{FF2B5EF4-FFF2-40B4-BE49-F238E27FC236}">
-                <a16:creationId xmlns:a16="http://schemas.microsoft.com/office/drawing/2014/main" id="{7B08F3C6-2A27-4352-9C63-82D10A504844}"/>
+                <a16:creationId xmlns:a16="http://schemas.microsoft.com/office/drawing/2014/main" id="{8FFD5F06-8D36-4286-B2D9-044A93D06063}"/>
               </a:ext>
             </a:extLst>
           </p:cNvPr>
@@ -5510,7 +5510,7 @@
           <p:cNvPr id="11" name="">
             <a:extLst xmlns:a="http://schemas.openxmlformats.org/drawingml/2006/main">
               <a:ext uri="{FF2B5EF4-FFF2-40B4-BE49-F238E27FC236}">
-                <a16:creationId xmlns:a16="http://schemas.microsoft.com/office/drawing/2014/main" id="{02159132-44D8-4032-B961-B4B732ADD79A}"/>
+                <a16:creationId xmlns:a16="http://schemas.microsoft.com/office/drawing/2014/main" id="{F15C0B61-FFE4-4344-9BBD-EFED982E0834}"/>
               </a:ext>
             </a:extLst>
           </p:cNvPr>
@@ -5566,7 +5566,7 @@
           <p:cNvPr id="12" name="">
             <a:extLst xmlns:a="http://schemas.openxmlformats.org/drawingml/2006/main">
               <a:ext uri="{FF2B5EF4-FFF2-40B4-BE49-F238E27FC236}">
-                <a16:creationId xmlns:a16="http://schemas.microsoft.com/office/drawing/2014/main" id="{F0281841-EB0C-4B9A-BDA0-54B42855D939}"/>
+                <a16:creationId xmlns:a16="http://schemas.microsoft.com/office/drawing/2014/main" id="{98AED2D5-B08F-4A3F-9C53-CB85512A59E2}"/>
               </a:ext>
             </a:extLst>
           </p:cNvPr>
@@ -5616,7 +5616,7 @@
           <p:cNvPr id="13" name="">
             <a:extLst xmlns:a="http://schemas.openxmlformats.org/drawingml/2006/main">
               <a:ext uri="{FF2B5EF4-FFF2-40B4-BE49-F238E27FC236}">
-                <a16:creationId xmlns:a16="http://schemas.microsoft.com/office/drawing/2014/main" id="{CEE0AA85-13E4-4169-9524-65FAC388B2DE}"/>
+                <a16:creationId xmlns:a16="http://schemas.microsoft.com/office/drawing/2014/main" id="{1CD0A1B6-EA74-4AD8-BDE7-8450BD70ED2A}"/>
               </a:ext>
             </a:extLst>
           </p:cNvPr>
@@ -5666,7 +5666,7 @@
           <p:cNvPr id="14" name="">
             <a:extLst xmlns:a="http://schemas.openxmlformats.org/drawingml/2006/main">
               <a:ext uri="{FF2B5EF4-FFF2-40B4-BE49-F238E27FC236}">
-                <a16:creationId xmlns:a16="http://schemas.microsoft.com/office/drawing/2014/main" id="{605B9A65-A5EA-45ED-B91B-4036D664F80B}"/>
+                <a16:creationId xmlns:a16="http://schemas.microsoft.com/office/drawing/2014/main" id="{7EE9F7A9-8F2A-4D42-AD19-67256D7ADD97}"/>
               </a:ext>
             </a:extLst>
           </p:cNvPr>
@@ -5712,7 +5712,7 @@
                   <a:srgbClr val="004C3F"/>
                 </a:solidFill>
               </a:rPr>
-              <a:t>Retailerがimport</a:t>
+              <a:t>小売業者がimport</a:t>
             </a:r>
           </a:p>
         </p:txBody>
@@ -5722,7 +5722,7 @@
           <p:cNvPr id="15" name="">
             <a:extLst xmlns:a="http://schemas.openxmlformats.org/drawingml/2006/main">
               <a:ext uri="{FF2B5EF4-FFF2-40B4-BE49-F238E27FC236}">
-                <a16:creationId xmlns:a16="http://schemas.microsoft.com/office/drawing/2014/main" id="{CAC49E68-6FD4-4B50-9F83-DE8E7FF1796E}"/>
+                <a16:creationId xmlns:a16="http://schemas.microsoft.com/office/drawing/2014/main" id="{651079B7-A346-479E-9EC3-1976BA5B63F9}"/>
               </a:ext>
             </a:extLst>
           </p:cNvPr>
@@ -5762,7 +5762,7 @@
                   <a:srgbClr val="52615B"/>
                 </a:solidFill>
               </a:rPr>
-              <a:t>Collectiveタグ付き商品がRetailerストアに作成されます。</a:t>
+              <a:t>Collectiveタグ付き商品が小売業者ストアに作成されます。</a:t>
             </a:r>
           </a:p>
         </p:txBody>
@@ -5772,7 +5772,7 @@
           <p:cNvPr id="16" name="">
             <a:extLst xmlns:a="http://schemas.openxmlformats.org/drawingml/2006/main">
               <a:ext uri="{FF2B5EF4-FFF2-40B4-BE49-F238E27FC236}">
-                <a16:creationId xmlns:a16="http://schemas.microsoft.com/office/drawing/2014/main" id="{220D2A95-A0CC-4F6C-A27D-F15CDE9A67EC}"/>
+                <a16:creationId xmlns:a16="http://schemas.microsoft.com/office/drawing/2014/main" id="{FB1DF0F7-E39F-4C4A-B3EE-6BD0E4DEF76D}"/>
               </a:ext>
             </a:extLst>
           </p:cNvPr>
@@ -5822,7 +5822,7 @@
           <p:cNvPr id="17" name="">
             <a:extLst xmlns:a="http://schemas.openxmlformats.org/drawingml/2006/main">
               <a:ext uri="{FF2B5EF4-FFF2-40B4-BE49-F238E27FC236}">
-                <a16:creationId xmlns:a16="http://schemas.microsoft.com/office/drawing/2014/main" id="{9FC2A99B-D0EB-4360-9B9C-B2279FA7DCCF}"/>
+                <a16:creationId xmlns:a16="http://schemas.microsoft.com/office/drawing/2014/main" id="{9D9DC44D-C420-40C7-9680-E21F4B86E77A}"/>
               </a:ext>
             </a:extLst>
           </p:cNvPr>
@@ -5872,7 +5872,7 @@
           <p:cNvPr id="18" name="">
             <a:extLst xmlns:a="http://schemas.openxmlformats.org/drawingml/2006/main">
               <a:ext uri="{FF2B5EF4-FFF2-40B4-BE49-F238E27FC236}">
-                <a16:creationId xmlns:a16="http://schemas.microsoft.com/office/drawing/2014/main" id="{99B19D55-0742-4EB6-A92F-9F0E92F3DAA4}"/>
+                <a16:creationId xmlns:a16="http://schemas.microsoft.com/office/drawing/2014/main" id="{525D93E4-FD10-4CBF-8A64-208CF5810721}"/>
               </a:ext>
             </a:extLst>
           </p:cNvPr>
@@ -5922,7 +5922,7 @@
           <p:cNvPr id="19" name="">
             <a:extLst xmlns:a="http://schemas.openxmlformats.org/drawingml/2006/main">
               <a:ext uri="{FF2B5EF4-FFF2-40B4-BE49-F238E27FC236}">
-                <a16:creationId xmlns:a16="http://schemas.microsoft.com/office/drawing/2014/main" id="{9254AB28-29E9-49C7-8229-03DA510B2EB3}"/>
+                <a16:creationId xmlns:a16="http://schemas.microsoft.com/office/drawing/2014/main" id="{F450E530-7A21-4A33-9289-2A9C35106270}"/>
               </a:ext>
             </a:extLst>
           </p:cNvPr>
@@ -5953,7 +5953,7 @@
           <p:cNvPr id="20" name="">
             <a:extLst xmlns:a="http://schemas.openxmlformats.org/drawingml/2006/main">
               <a:ext uri="{FF2B5EF4-FFF2-40B4-BE49-F238E27FC236}">
-                <a16:creationId xmlns:a16="http://schemas.microsoft.com/office/drawing/2014/main" id="{04D06A5B-D947-4F33-B571-C2E291A9B0A2}"/>
+                <a16:creationId xmlns:a16="http://schemas.microsoft.com/office/drawing/2014/main" id="{861F4D13-7354-423D-94F0-9864AEC9C699}"/>
               </a:ext>
             </a:extLst>
           </p:cNvPr>
@@ -6003,7 +6003,7 @@
           <p:cNvPr id="21" name="">
             <a:extLst xmlns:a="http://schemas.openxmlformats.org/drawingml/2006/main">
               <a:ext uri="{FF2B5EF4-FFF2-40B4-BE49-F238E27FC236}">
-                <a16:creationId xmlns:a16="http://schemas.microsoft.com/office/drawing/2014/main" id="{C223A6D6-B20C-483D-AC5F-91042EBB93C1}"/>
+                <a16:creationId xmlns:a16="http://schemas.microsoft.com/office/drawing/2014/main" id="{D0F46B1B-914D-4C2F-8FA3-7511BA1BA24B}"/>
               </a:ext>
             </a:extLst>
           </p:cNvPr>
@@ -6051,7 +6051,7 @@
     </p:spTree>
     <p:extLst>
       <p:ext uri="{BB962C8B-B14F-4D97-AF65-F5344CB8AC3E}">
-        <p14:creationId xmlns:p14="http://schemas.microsoft.com/office/powerpoint/2010/main" val="840534476"/>
+        <p14:creationId xmlns:p14="http://schemas.microsoft.com/office/powerpoint/2010/main" val="1612915968"/>
       </p:ext>
     </p:extLst>
   </p:cSld>
@@ -6082,7 +6082,7 @@
           <p:cNvPr id="1" name="">
             <a:extLst xmlns:a="http://schemas.openxmlformats.org/drawingml/2006/main">
               <a:ext uri="{FF2B5EF4-FFF2-40B4-BE49-F238E27FC236}">
-                <a16:creationId xmlns:a16="http://schemas.microsoft.com/office/drawing/2014/main" id="{1A68F24C-9BE1-4BE5-954A-6FF71EB73487}"/>
+                <a16:creationId xmlns:a16="http://schemas.microsoft.com/office/drawing/2014/main" id="{AE29389D-F769-467C-8A29-B9C6862C80A4}"/>
               </a:ext>
             </a:extLst>
           </p:cNvPr>
@@ -6132,7 +6132,7 @@
           <p:cNvPr id="2" name="">
             <a:extLst xmlns:a="http://schemas.openxmlformats.org/drawingml/2006/main">
               <a:ext uri="{FF2B5EF4-FFF2-40B4-BE49-F238E27FC236}">
-                <a16:creationId xmlns:a16="http://schemas.microsoft.com/office/drawing/2014/main" id="{EF6D1A64-4C39-4B0A-B68A-0AAF48D9B137}"/>
+                <a16:creationId xmlns:a16="http://schemas.microsoft.com/office/drawing/2014/main" id="{6AE5630A-5EF6-4FB1-B1C0-EEDA0CD2569E}"/>
               </a:ext>
             </a:extLst>
           </p:cNvPr>
@@ -6172,7 +6172,7 @@
                   <a:srgbClr val="101820"/>
                 </a:solidFill>
               </a:rPr>
-              <a:t>インポート商品はSupplier在庫を参照する</a:t>
+              <a:t>インポート商品はサプライヤー在庫を参照する</a:t>
             </a:r>
           </a:p>
         </p:txBody>
@@ -6182,7 +6182,7 @@
           <p:cNvPr id="3" name="">
             <a:extLst xmlns:a="http://schemas.openxmlformats.org/drawingml/2006/main">
               <a:ext uri="{FF2B5EF4-FFF2-40B4-BE49-F238E27FC236}">
-                <a16:creationId xmlns:a16="http://schemas.microsoft.com/office/drawing/2014/main" id="{593825A4-3AB0-4EEF-AA58-BB92105EE376}"/>
+                <a16:creationId xmlns:a16="http://schemas.microsoft.com/office/drawing/2014/main" id="{0E5E0FD1-81C8-4F5A-AB5E-832233211499}"/>
               </a:ext>
             </a:extLst>
           </p:cNvPr>
@@ -6222,7 +6222,7 @@
                   <a:srgbClr val="52615B"/>
                 </a:solidFill>
               </a:rPr>
-              <a:t>Retailerの利用可能在庫はSupplier起点で反映され、Shopify checkoutでもSupplier在庫が確認されます。</a:t>
+              <a:t>小売業者の利用可能在庫はサプライヤー起点で反映され、Shopify checkoutでもサプライヤー在庫が確認されます。</a:t>
             </a:r>
           </a:p>
         </p:txBody>
@@ -6232,7 +6232,7 @@
           <p:cNvPr id="4" name="">
             <a:extLst xmlns:a="http://schemas.openxmlformats.org/drawingml/2006/main">
               <a:ext uri="{FF2B5EF4-FFF2-40B4-BE49-F238E27FC236}">
-                <a16:creationId xmlns:a16="http://schemas.microsoft.com/office/drawing/2014/main" id="{1BBC420E-FF8E-4876-8492-A6708D23154A}"/>
+                <a16:creationId xmlns:a16="http://schemas.microsoft.com/office/drawing/2014/main" id="{9F210360-E487-410C-8CE9-1DECE68D35FE}"/>
               </a:ext>
             </a:extLst>
           </p:cNvPr>
@@ -6263,7 +6263,7 @@
           <p:cNvPr id="5" name="">
             <a:extLst xmlns:a="http://schemas.openxmlformats.org/drawingml/2006/main">
               <a:ext uri="{FF2B5EF4-FFF2-40B4-BE49-F238E27FC236}">
-                <a16:creationId xmlns:a16="http://schemas.microsoft.com/office/drawing/2014/main" id="{27FA1FBA-9C22-4FC3-9ACE-8B376D5781EC}"/>
+                <a16:creationId xmlns:a16="http://schemas.microsoft.com/office/drawing/2014/main" id="{314E5771-435B-40E5-8B6F-9433F8B6835D}"/>
               </a:ext>
             </a:extLst>
           </p:cNvPr>
@@ -6309,7 +6309,7 @@
                   <a:srgbClr val="101820"/>
                 </a:solidFill>
               </a:rPr>
-              <a:t>Supplier在庫</a:t>
+              <a:t>サプライヤー在庫</a:t>
             </a:r>
           </a:p>
         </p:txBody>
@@ -6319,7 +6319,7 @@
           <p:cNvPr id="6" name="">
             <a:extLst xmlns:a="http://schemas.openxmlformats.org/drawingml/2006/main">
               <a:ext uri="{FF2B5EF4-FFF2-40B4-BE49-F238E27FC236}">
-                <a16:creationId xmlns:a16="http://schemas.microsoft.com/office/drawing/2014/main" id="{51B6210E-3D2C-4A74-802C-5B0EBFA9B410}"/>
+                <a16:creationId xmlns:a16="http://schemas.microsoft.com/office/drawing/2014/main" id="{919ABB70-740C-4CF2-B203-1F78ADB2E745}"/>
               </a:ext>
             </a:extLst>
           </p:cNvPr>
@@ -6359,7 +6359,7 @@
                   <a:srgbClr val="52615B"/>
                 </a:solidFill>
               </a:rPr>
-              <a:t>Supplierのオンライン販売可能在庫がRetailer在庫に反映されます。</a:t>
+              <a:t>サプライヤーのオンライン販売可能在庫が小売業者在庫に反映されます。</a:t>
             </a:r>
           </a:p>
         </p:txBody>
@@ -6369,7 +6369,7 @@
           <p:cNvPr id="7" name="">
             <a:extLst xmlns:a="http://schemas.openxmlformats.org/drawingml/2006/main">
               <a:ext uri="{FF2B5EF4-FFF2-40B4-BE49-F238E27FC236}">
-                <a16:creationId xmlns:a16="http://schemas.microsoft.com/office/drawing/2014/main" id="{D6C21B1C-6DA9-4A7C-BF74-98449225A46F}"/>
+                <a16:creationId xmlns:a16="http://schemas.microsoft.com/office/drawing/2014/main" id="{248DA18C-9D08-4A07-B89F-DD4834DCC82A}"/>
               </a:ext>
             </a:extLst>
           </p:cNvPr>
@@ -6419,7 +6419,7 @@
           <p:cNvPr id="8" name="">
             <a:extLst xmlns:a="http://schemas.openxmlformats.org/drawingml/2006/main">
               <a:ext uri="{FF2B5EF4-FFF2-40B4-BE49-F238E27FC236}">
-                <a16:creationId xmlns:a16="http://schemas.microsoft.com/office/drawing/2014/main" id="{D32444D7-95F7-44CC-A1A1-1976570F4347}"/>
+                <a16:creationId xmlns:a16="http://schemas.microsoft.com/office/drawing/2014/main" id="{CF775798-C284-433A-BF17-314E78A44A0E}"/>
               </a:ext>
             </a:extLst>
           </p:cNvPr>
@@ -6475,7 +6475,7 @@
           <p:cNvPr id="9" name="">
             <a:extLst xmlns:a="http://schemas.openxmlformats.org/drawingml/2006/main">
               <a:ext uri="{FF2B5EF4-FFF2-40B4-BE49-F238E27FC236}">
-                <a16:creationId xmlns:a16="http://schemas.microsoft.com/office/drawing/2014/main" id="{D595F452-6E64-4558-8BDF-C2163CEA28EF}"/>
+                <a16:creationId xmlns:a16="http://schemas.microsoft.com/office/drawing/2014/main" id="{2728783F-805C-48D1-BCBC-A6658DC70C7D}"/>
               </a:ext>
             </a:extLst>
           </p:cNvPr>
@@ -6515,7 +6515,7 @@
                   <a:srgbClr val="52615B"/>
                 </a:solidFill>
               </a:rPr>
-              <a:t>Supplierまたは接続Retailerでの購入が在庫を減らします。</a:t>
+              <a:t>サプライヤーまたは接続小売業者での購入が在庫を減らします。</a:t>
             </a:r>
           </a:p>
         </p:txBody>
@@ -6525,7 +6525,7 @@
           <p:cNvPr id="10" name="">
             <a:extLst xmlns:a="http://schemas.openxmlformats.org/drawingml/2006/main">
               <a:ext uri="{FF2B5EF4-FFF2-40B4-BE49-F238E27FC236}">
-                <a16:creationId xmlns:a16="http://schemas.microsoft.com/office/drawing/2014/main" id="{C198D912-CAA6-4805-853D-8E9CE0DFE6FE}"/>
+                <a16:creationId xmlns:a16="http://schemas.microsoft.com/office/drawing/2014/main" id="{EBC0BCC9-665B-45BD-BF59-8EE447317A8D}"/>
               </a:ext>
             </a:extLst>
           </p:cNvPr>
@@ -6575,7 +6575,7 @@
           <p:cNvPr id="11" name="">
             <a:extLst xmlns:a="http://schemas.openxmlformats.org/drawingml/2006/main">
               <a:ext uri="{FF2B5EF4-FFF2-40B4-BE49-F238E27FC236}">
-                <a16:creationId xmlns:a16="http://schemas.microsoft.com/office/drawing/2014/main" id="{2A8438AB-9087-4EB0-A118-7EF0C2310755}"/>
+                <a16:creationId xmlns:a16="http://schemas.microsoft.com/office/drawing/2014/main" id="{A82D58E8-9A11-4282-B2C2-816A1BBE63AC}"/>
               </a:ext>
             </a:extLst>
           </p:cNvPr>
@@ -6631,7 +6631,7 @@
           <p:cNvPr id="12" name="">
             <a:extLst xmlns:a="http://schemas.openxmlformats.org/drawingml/2006/main">
               <a:ext uri="{FF2B5EF4-FFF2-40B4-BE49-F238E27FC236}">
-                <a16:creationId xmlns:a16="http://schemas.microsoft.com/office/drawing/2014/main" id="{B3F3E32D-C7F6-4E84-B1DE-3E0F5C0725A0}"/>
+                <a16:creationId xmlns:a16="http://schemas.microsoft.com/office/drawing/2014/main" id="{21A5D8DA-C799-4548-A326-7321D77C4F8E}"/>
               </a:ext>
             </a:extLst>
           </p:cNvPr>
@@ -6681,7 +6681,7 @@
           <p:cNvPr id="13" name="">
             <a:extLst xmlns:a="http://schemas.openxmlformats.org/drawingml/2006/main">
               <a:ext uri="{FF2B5EF4-FFF2-40B4-BE49-F238E27FC236}">
-                <a16:creationId xmlns:a16="http://schemas.microsoft.com/office/drawing/2014/main" id="{109506AC-C379-429B-ABF9-BBE613AA442D}"/>
+                <a16:creationId xmlns:a16="http://schemas.microsoft.com/office/drawing/2014/main" id="{96F41F51-7141-4286-9C7F-00E98861E1A9}"/>
               </a:ext>
             </a:extLst>
           </p:cNvPr>
@@ -6731,7 +6731,7 @@
           <p:cNvPr id="14" name="">
             <a:extLst xmlns:a="http://schemas.openxmlformats.org/drawingml/2006/main">
               <a:ext uri="{FF2B5EF4-FFF2-40B4-BE49-F238E27FC236}">
-                <a16:creationId xmlns:a16="http://schemas.microsoft.com/office/drawing/2014/main" id="{7B4F2A17-3EDD-4ECB-B6C8-97355B4E2B8E}"/>
+                <a16:creationId xmlns:a16="http://schemas.microsoft.com/office/drawing/2014/main" id="{8FE1C008-F461-49F5-855E-1E07AF52479E}"/>
               </a:ext>
             </a:extLst>
           </p:cNvPr>
@@ -6787,7 +6787,7 @@
           <p:cNvPr id="15" name="">
             <a:extLst xmlns:a="http://schemas.openxmlformats.org/drawingml/2006/main">
               <a:ext uri="{FF2B5EF4-FFF2-40B4-BE49-F238E27FC236}">
-                <a16:creationId xmlns:a16="http://schemas.microsoft.com/office/drawing/2014/main" id="{9AB2183F-A4D4-47B5-A005-4CC3EAA08672}"/>
+                <a16:creationId xmlns:a16="http://schemas.microsoft.com/office/drawing/2014/main" id="{4BBFA709-C51A-4DAB-B243-6F715E3D1BF6}"/>
               </a:ext>
             </a:extLst>
           </p:cNvPr>
@@ -6827,7 +6827,7 @@
                   <a:srgbClr val="52615B"/>
                 </a:solidFill>
               </a:rPr>
-              <a:t>Shopify checkoutがSupplier在庫を確認します。</a:t>
+              <a:t>Shopify checkoutがサプライヤー在庫を確認します。</a:t>
             </a:r>
           </a:p>
         </p:txBody>
@@ -6837,7 +6837,7 @@
           <p:cNvPr id="16" name="">
             <a:extLst xmlns:a="http://schemas.openxmlformats.org/drawingml/2006/main">
               <a:ext uri="{FF2B5EF4-FFF2-40B4-BE49-F238E27FC236}">
-                <a16:creationId xmlns:a16="http://schemas.microsoft.com/office/drawing/2014/main" id="{FD89A7BC-FFB6-4B2A-91A6-E6FA9A1D72C7}"/>
+                <a16:creationId xmlns:a16="http://schemas.microsoft.com/office/drawing/2014/main" id="{9CD76351-5886-4283-ACC2-A69563035721}"/>
               </a:ext>
             </a:extLst>
           </p:cNvPr>
@@ -6887,7 +6887,7 @@
           <p:cNvPr id="17" name="">
             <a:extLst xmlns:a="http://schemas.openxmlformats.org/drawingml/2006/main">
               <a:ext uri="{FF2B5EF4-FFF2-40B4-BE49-F238E27FC236}">
-                <a16:creationId xmlns:a16="http://schemas.microsoft.com/office/drawing/2014/main" id="{A38DACB7-6E2B-4590-A19C-41F1FCB26F47}"/>
+                <a16:creationId xmlns:a16="http://schemas.microsoft.com/office/drawing/2014/main" id="{657A9794-6D2D-4825-AA5B-365C3E0EA61C}"/>
               </a:ext>
             </a:extLst>
           </p:cNvPr>
@@ -6943,7 +6943,7 @@
           <p:cNvPr id="18" name="">
             <a:extLst xmlns:a="http://schemas.openxmlformats.org/drawingml/2006/main">
               <a:ext uri="{FF2B5EF4-FFF2-40B4-BE49-F238E27FC236}">
-                <a16:creationId xmlns:a16="http://schemas.microsoft.com/office/drawing/2014/main" id="{B9C1FA17-EC8A-43FF-A80F-4583C5FC915C}"/>
+                <a16:creationId xmlns:a16="http://schemas.microsoft.com/office/drawing/2014/main" id="{BF9A4A1C-C3FC-4936-A7AC-E5DDAF3CDE16}"/>
               </a:ext>
             </a:extLst>
           </p:cNvPr>
@@ -6993,7 +6993,7 @@
           <p:cNvPr id="19" name="">
             <a:extLst xmlns:a="http://schemas.openxmlformats.org/drawingml/2006/main">
               <a:ext uri="{FF2B5EF4-FFF2-40B4-BE49-F238E27FC236}">
-                <a16:creationId xmlns:a16="http://schemas.microsoft.com/office/drawing/2014/main" id="{734C2424-2C28-4146-8284-454FF106A5FE}"/>
+                <a16:creationId xmlns:a16="http://schemas.microsoft.com/office/drawing/2014/main" id="{257876AA-6341-4E1B-BF70-667B58B617E4}"/>
               </a:ext>
             </a:extLst>
           </p:cNvPr>
@@ -7043,7 +7043,7 @@
           <p:cNvPr id="20" name="">
             <a:extLst xmlns:a="http://schemas.openxmlformats.org/drawingml/2006/main">
               <a:ext uri="{FF2B5EF4-FFF2-40B4-BE49-F238E27FC236}">
-                <a16:creationId xmlns:a16="http://schemas.microsoft.com/office/drawing/2014/main" id="{DD39B50A-9E56-4E7A-BBFA-A5A19B14128A}"/>
+                <a16:creationId xmlns:a16="http://schemas.microsoft.com/office/drawing/2014/main" id="{C875C458-9E6E-44D3-BDB2-DD4B1FE03CFC}"/>
               </a:ext>
             </a:extLst>
           </p:cNvPr>
@@ -7093,7 +7093,7 @@
           <p:cNvPr id="21" name="">
             <a:extLst xmlns:a="http://schemas.openxmlformats.org/drawingml/2006/main">
               <a:ext uri="{FF2B5EF4-FFF2-40B4-BE49-F238E27FC236}">
-                <a16:creationId xmlns:a16="http://schemas.microsoft.com/office/drawing/2014/main" id="{911207E0-2F26-4F94-A72E-B958F1BF0593}"/>
+                <a16:creationId xmlns:a16="http://schemas.microsoft.com/office/drawing/2014/main" id="{B397BD66-80CB-459D-AF11-8AF3A02B30A6}"/>
               </a:ext>
             </a:extLst>
           </p:cNvPr>
@@ -7143,7 +7143,7 @@
           <p:cNvPr id="22" name="">
             <a:extLst xmlns:a="http://schemas.openxmlformats.org/drawingml/2006/main">
               <a:ext uri="{FF2B5EF4-FFF2-40B4-BE49-F238E27FC236}">
-                <a16:creationId xmlns:a16="http://schemas.microsoft.com/office/drawing/2014/main" id="{142A47E0-7BFD-4A51-807C-689148883D50}"/>
+                <a16:creationId xmlns:a16="http://schemas.microsoft.com/office/drawing/2014/main" id="{5C0DB837-9E13-49AA-A552-84744F07377D}"/>
               </a:ext>
             </a:extLst>
           </p:cNvPr>
@@ -7174,7 +7174,7 @@
           <p:cNvPr id="23" name="">
             <a:extLst xmlns:a="http://schemas.openxmlformats.org/drawingml/2006/main">
               <a:ext uri="{FF2B5EF4-FFF2-40B4-BE49-F238E27FC236}">
-                <a16:creationId xmlns:a16="http://schemas.microsoft.com/office/drawing/2014/main" id="{A9AC2285-A4AE-4364-9B7A-E85CBF07ABC4}"/>
+                <a16:creationId xmlns:a16="http://schemas.microsoft.com/office/drawing/2014/main" id="{A4C4F75F-0529-41F5-ACBF-5B1122D3BDB7}"/>
               </a:ext>
             </a:extLst>
           </p:cNvPr>
@@ -7224,7 +7224,7 @@
           <p:cNvPr id="24" name="">
             <a:extLst xmlns:a="http://schemas.openxmlformats.org/drawingml/2006/main">
               <a:ext uri="{FF2B5EF4-FFF2-40B4-BE49-F238E27FC236}">
-                <a16:creationId xmlns:a16="http://schemas.microsoft.com/office/drawing/2014/main" id="{8BE76787-F2DA-42ED-AC99-30A72533B7F7}"/>
+                <a16:creationId xmlns:a16="http://schemas.microsoft.com/office/drawing/2014/main" id="{CC38BC90-B4F3-46F3-8715-A3DCAA69F13B}"/>
               </a:ext>
             </a:extLst>
           </p:cNvPr>
@@ -7272,7 +7272,7 @@
     </p:spTree>
     <p:extLst>
       <p:ext uri="{BB962C8B-B14F-4D97-AF65-F5344CB8AC3E}">
-        <p14:creationId xmlns:p14="http://schemas.microsoft.com/office/powerpoint/2010/main" val="1541908250"/>
+        <p14:creationId xmlns:p14="http://schemas.microsoft.com/office/powerpoint/2010/main" val="1888858768"/>
       </p:ext>
     </p:extLst>
   </p:cSld>
@@ -7303,7 +7303,7 @@
           <p:cNvPr id="1" name="">
             <a:extLst xmlns:a="http://schemas.openxmlformats.org/drawingml/2006/main">
               <a:ext uri="{FF2B5EF4-FFF2-40B4-BE49-F238E27FC236}">
-                <a16:creationId xmlns:a16="http://schemas.microsoft.com/office/drawing/2014/main" id="{E9E4FC8B-8FC1-40A7-B317-2B66BC076613}"/>
+                <a16:creationId xmlns:a16="http://schemas.microsoft.com/office/drawing/2014/main" id="{8B734422-1727-4733-BCD5-0741E2A4F6BA}"/>
               </a:ext>
             </a:extLst>
           </p:cNvPr>
@@ -7353,7 +7353,7 @@
           <p:cNvPr id="2" name="">
             <a:extLst xmlns:a="http://schemas.openxmlformats.org/drawingml/2006/main">
               <a:ext uri="{FF2B5EF4-FFF2-40B4-BE49-F238E27FC236}">
-                <a16:creationId xmlns:a16="http://schemas.microsoft.com/office/drawing/2014/main" id="{83FB97F5-8D67-4B02-8382-2B5F2DB14DE4}"/>
+                <a16:creationId xmlns:a16="http://schemas.microsoft.com/office/drawing/2014/main" id="{DE659F30-B53B-4227-96EE-3FDD33ABA3BF}"/>
               </a:ext>
             </a:extLst>
           </p:cNvPr>
@@ -7403,7 +7403,7 @@
           <p:cNvPr id="3" name="">
             <a:extLst xmlns:a="http://schemas.openxmlformats.org/drawingml/2006/main">
               <a:ext uri="{FF2B5EF4-FFF2-40B4-BE49-F238E27FC236}">
-                <a16:creationId xmlns:a16="http://schemas.microsoft.com/office/drawing/2014/main" id="{0F6E96CF-816C-409D-8211-8E1243DD7C28}"/>
+                <a16:creationId xmlns:a16="http://schemas.microsoft.com/office/drawing/2014/main" id="{8D2764A8-7E74-4BBC-A396-722229CAE59C}"/>
               </a:ext>
             </a:extLst>
           </p:cNvPr>
@@ -7443,7 +7443,7 @@
                   <a:srgbClr val="52615B"/>
                 </a:solidFill>
               </a:rPr>
-              <a:t>Supplierへ支払うcost priceと、購入者に見せるretail price / discountを分けて考えます。</a:t>
+              <a:t>サプライヤーへ支払うcost priceと、購入者に見せるretail price / discountを分けて考えます。</a:t>
             </a:r>
           </a:p>
         </p:txBody>
@@ -7453,7 +7453,7 @@
           <p:cNvPr id="4" name="">
             <a:extLst xmlns:a="http://schemas.openxmlformats.org/drawingml/2006/main">
               <a:ext uri="{FF2B5EF4-FFF2-40B4-BE49-F238E27FC236}">
-                <a16:creationId xmlns:a16="http://schemas.microsoft.com/office/drawing/2014/main" id="{C6989CA8-90D0-4D2F-B543-D65E8E3B9FDC}"/>
+                <a16:creationId xmlns:a16="http://schemas.microsoft.com/office/drawing/2014/main" id="{57F04C62-4568-46DC-8249-70EF717C9F1F}"/>
               </a:ext>
             </a:extLst>
           </p:cNvPr>
@@ -7484,7 +7484,7 @@
           <p:cNvPr id="5" name="">
             <a:extLst xmlns:a="http://schemas.openxmlformats.org/drawingml/2006/main">
               <a:ext uri="{FF2B5EF4-FFF2-40B4-BE49-F238E27FC236}">
-                <a16:creationId xmlns:a16="http://schemas.microsoft.com/office/drawing/2014/main" id="{D3C6CF29-5715-48E7-944E-27823A2444FD}"/>
+                <a16:creationId xmlns:a16="http://schemas.microsoft.com/office/drawing/2014/main" id="{107F09BC-7D82-4470-B8F5-10EA1B2628EB}"/>
               </a:ext>
             </a:extLst>
           </p:cNvPr>
@@ -7530,7 +7530,7 @@
                   <a:srgbClr val="004C3F"/>
                 </a:solidFill>
               </a:rPr>
-              <a:t>Supplier cost price</a:t>
+              <a:t>サプライヤーcost price</a:t>
             </a:r>
           </a:p>
         </p:txBody>
@@ -7540,7 +7540,7 @@
           <p:cNvPr id="6" name="">
             <a:extLst xmlns:a="http://schemas.openxmlformats.org/drawingml/2006/main">
               <a:ext uri="{FF2B5EF4-FFF2-40B4-BE49-F238E27FC236}">
-                <a16:creationId xmlns:a16="http://schemas.microsoft.com/office/drawing/2014/main" id="{555C1A62-C162-4767-B945-E6E31D2E7634}"/>
+                <a16:creationId xmlns:a16="http://schemas.microsoft.com/office/drawing/2014/main" id="{A8EAD8BB-A673-4DDF-920A-55A8D15C48A2}"/>
               </a:ext>
             </a:extLst>
           </p:cNvPr>
@@ -7580,7 +7580,7 @@
                   <a:srgbClr val="101820"/>
                 </a:solidFill>
               </a:rPr>
-              <a:t>Supplier price listから常時同期され、Retailerは編集できません。</a:t>
+              <a:t>サプライヤーprice listから常時同期され、小売業者は編集できません。</a:t>
             </a:r>
           </a:p>
         </p:txBody>
@@ -7590,7 +7590,7 @@
           <p:cNvPr id="7" name="">
             <a:extLst xmlns:a="http://schemas.openxmlformats.org/drawingml/2006/main">
               <a:ext uri="{FF2B5EF4-FFF2-40B4-BE49-F238E27FC236}">
-                <a16:creationId xmlns:a16="http://schemas.microsoft.com/office/drawing/2014/main" id="{9541C945-2619-4EFB-A84B-5529BE649BFE}"/>
+                <a16:creationId xmlns:a16="http://schemas.microsoft.com/office/drawing/2014/main" id="{99E78A9E-DE0F-4CE0-9F6B-0FF308E8A5AC}"/>
               </a:ext>
             </a:extLst>
           </p:cNvPr>
@@ -7636,7 +7636,7 @@
                   <a:srgbClr val="101820"/>
                 </a:solidFill>
               </a:rPr>
-              <a:t>Retailer retail price</a:t>
+              <a:t>小売業者retail price</a:t>
             </a:r>
           </a:p>
         </p:txBody>
@@ -7646,7 +7646,7 @@
           <p:cNvPr id="8" name="">
             <a:extLst xmlns:a="http://schemas.openxmlformats.org/drawingml/2006/main">
               <a:ext uri="{FF2B5EF4-FFF2-40B4-BE49-F238E27FC236}">
-                <a16:creationId xmlns:a16="http://schemas.microsoft.com/office/drawing/2014/main" id="{73054670-C0EE-427D-AB6A-DDE4CCE00FE5}"/>
+                <a16:creationId xmlns:a16="http://schemas.microsoft.com/office/drawing/2014/main" id="{A714C24C-ED71-4B1A-B7B2-7DC3CC91E9AA}"/>
               </a:ext>
             </a:extLst>
           </p:cNvPr>
@@ -7686,7 +7686,7 @@
                   <a:srgbClr val="101820"/>
                 </a:solidFill>
               </a:rPr>
-              <a:t>Retail price syncがONでなければ、購入者向け価格はRetailerが管理できます。</a:t>
+              <a:t>Retail price syncがONでなければ、購入者向け価格は小売業者が管理できます。</a:t>
             </a:r>
           </a:p>
         </p:txBody>
@@ -7696,7 +7696,7 @@
           <p:cNvPr id="9" name="">
             <a:extLst xmlns:a="http://schemas.openxmlformats.org/drawingml/2006/main">
               <a:ext uri="{FF2B5EF4-FFF2-40B4-BE49-F238E27FC236}">
-                <a16:creationId xmlns:a16="http://schemas.microsoft.com/office/drawing/2014/main" id="{0DEDBE15-DF82-4332-998D-FE33B7969D09}"/>
+                <a16:creationId xmlns:a16="http://schemas.microsoft.com/office/drawing/2014/main" id="{E2EC74E6-EF0E-4FD3-8F54-1644E90602E1}"/>
               </a:ext>
             </a:extLst>
           </p:cNvPr>
@@ -7746,7 +7746,7 @@
           <p:cNvPr id="10" name="">
             <a:extLst xmlns:a="http://schemas.openxmlformats.org/drawingml/2006/main">
               <a:ext uri="{FF2B5EF4-FFF2-40B4-BE49-F238E27FC236}">
-                <a16:creationId xmlns:a16="http://schemas.microsoft.com/office/drawing/2014/main" id="{6BDB6344-CCC7-4180-926F-673112E2FE71}"/>
+                <a16:creationId xmlns:a16="http://schemas.microsoft.com/office/drawing/2014/main" id="{BF5ABC6A-0A43-4074-93B6-E08F944C577E}"/>
               </a:ext>
             </a:extLst>
           </p:cNvPr>
@@ -7786,7 +7786,7 @@
                   <a:srgbClr val="52615B"/>
                 </a:solidFill>
               </a:rPr>
-              <a:t>RetailerのディスカウントはRetailer利益を減らしますが、Supplier cost priceは変えません。</a:t>
+              <a:t>小売業者のディスカウントは小売業者利益を減らしますが、サプライヤーcost priceは変えません。</a:t>
             </a:r>
           </a:p>
         </p:txBody>
@@ -7796,7 +7796,7 @@
           <p:cNvPr id="11" name="">
             <a:extLst xmlns:a="http://schemas.openxmlformats.org/drawingml/2006/main">
               <a:ext uri="{FF2B5EF4-FFF2-40B4-BE49-F238E27FC236}">
-                <a16:creationId xmlns:a16="http://schemas.microsoft.com/office/drawing/2014/main" id="{1F57A6B5-56DB-4E98-8C43-0CB9A7A6237D}"/>
+                <a16:creationId xmlns:a16="http://schemas.microsoft.com/office/drawing/2014/main" id="{A19DBF7D-107D-42EB-AD70-DA9556BA8D10}"/>
               </a:ext>
             </a:extLst>
           </p:cNvPr>
@@ -7827,7 +7827,7 @@
           <p:cNvPr id="12" name="">
             <a:extLst xmlns:a="http://schemas.openxmlformats.org/drawingml/2006/main">
               <a:ext uri="{FF2B5EF4-FFF2-40B4-BE49-F238E27FC236}">
-                <a16:creationId xmlns:a16="http://schemas.microsoft.com/office/drawing/2014/main" id="{7908BB18-65CF-4BF8-832F-4174DBB3F204}"/>
+                <a16:creationId xmlns:a16="http://schemas.microsoft.com/office/drawing/2014/main" id="{66518FC8-1423-457E-862F-C1BBBD7ADABF}"/>
               </a:ext>
             </a:extLst>
           </p:cNvPr>
@@ -7877,7 +7877,7 @@
           <p:cNvPr id="13" name="">
             <a:extLst xmlns:a="http://schemas.openxmlformats.org/drawingml/2006/main">
               <a:ext uri="{FF2B5EF4-FFF2-40B4-BE49-F238E27FC236}">
-                <a16:creationId xmlns:a16="http://schemas.microsoft.com/office/drawing/2014/main" id="{4879C037-7EF7-4207-9473-79F11097AFD7}"/>
+                <a16:creationId xmlns:a16="http://schemas.microsoft.com/office/drawing/2014/main" id="{3CF4E399-9A6B-48AF-84F8-72EF1BB85DAE}"/>
               </a:ext>
             </a:extLst>
           </p:cNvPr>
@@ -7925,7 +7925,7 @@
     </p:spTree>
     <p:extLst>
       <p:ext uri="{BB962C8B-B14F-4D97-AF65-F5344CB8AC3E}">
-        <p14:creationId xmlns:p14="http://schemas.microsoft.com/office/powerpoint/2010/main" val="1326227645"/>
+        <p14:creationId xmlns:p14="http://schemas.microsoft.com/office/powerpoint/2010/main" val="1333429347"/>
       </p:ext>
     </p:extLst>
   </p:cSld>
@@ -7956,7 +7956,7 @@
           <p:cNvPr id="1" name="">
             <a:extLst xmlns:a="http://schemas.openxmlformats.org/drawingml/2006/main">
               <a:ext uri="{FF2B5EF4-FFF2-40B4-BE49-F238E27FC236}">
-                <a16:creationId xmlns:a16="http://schemas.microsoft.com/office/drawing/2014/main" id="{40692E3D-E51A-47A8-A6D4-89EAA55D903A}"/>
+                <a16:creationId xmlns:a16="http://schemas.microsoft.com/office/drawing/2014/main" id="{38C0513C-A845-430D-9993-C834033DE048}"/>
               </a:ext>
             </a:extLst>
           </p:cNvPr>
@@ -8006,7 +8006,7 @@
           <p:cNvPr id="2" name="">
             <a:extLst xmlns:a="http://schemas.openxmlformats.org/drawingml/2006/main">
               <a:ext uri="{FF2B5EF4-FFF2-40B4-BE49-F238E27FC236}">
-                <a16:creationId xmlns:a16="http://schemas.microsoft.com/office/drawing/2014/main" id="{59E7D877-FF09-4E56-ACCC-DE4F3180EB4F}"/>
+                <a16:creationId xmlns:a16="http://schemas.microsoft.com/office/drawing/2014/main" id="{A6C7CEE9-64B0-40C0-A0B0-9EC872BC20D9}"/>
               </a:ext>
             </a:extLst>
           </p:cNvPr>
@@ -8056,7 +8056,7 @@
           <p:cNvPr id="3" name="">
             <a:extLst xmlns:a="http://schemas.openxmlformats.org/drawingml/2006/main">
               <a:ext uri="{FF2B5EF4-FFF2-40B4-BE49-F238E27FC236}">
-                <a16:creationId xmlns:a16="http://schemas.microsoft.com/office/drawing/2014/main" id="{E3BEAFAE-D295-45C5-85A8-F2D9DDCC82D2}"/>
+                <a16:creationId xmlns:a16="http://schemas.microsoft.com/office/drawing/2014/main" id="{718ABAC6-56C3-46AC-8ADA-35FF9FD3A00B}"/>
               </a:ext>
             </a:extLst>
           </p:cNvPr>
@@ -8096,7 +8096,7 @@
                   <a:srgbClr val="52615B"/>
                 </a:solidFill>
               </a:rPr>
-              <a:t>購入者に請求する送料と、SupplierがRetailerへ請求する送料を分けてモデル化します。</a:t>
+              <a:t>購入者に請求する送料と、サプライヤーが小売業者へ請求する送料を分けてモデル化します。</a:t>
             </a:r>
           </a:p>
         </p:txBody>
@@ -8106,7 +8106,7 @@
           <p:cNvPr id="4" name="">
             <a:extLst xmlns:a="http://schemas.openxmlformats.org/drawingml/2006/main">
               <a:ext uri="{FF2B5EF4-FFF2-40B4-BE49-F238E27FC236}">
-                <a16:creationId xmlns:a16="http://schemas.microsoft.com/office/drawing/2014/main" id="{B7EDA6A2-990E-4857-9D7E-0517D84BD165}"/>
+                <a16:creationId xmlns:a16="http://schemas.microsoft.com/office/drawing/2014/main" id="{8E7906B5-A867-41EB-9CF5-D05644B77A70}"/>
               </a:ext>
             </a:extLst>
           </p:cNvPr>
@@ -8137,7 +8137,7 @@
           <p:cNvPr id="5" name="">
             <a:extLst xmlns:a="http://schemas.openxmlformats.org/drawingml/2006/main">
               <a:ext uri="{FF2B5EF4-FFF2-40B4-BE49-F238E27FC236}">
-                <a16:creationId xmlns:a16="http://schemas.microsoft.com/office/drawing/2014/main" id="{63A63EA9-80A2-459A-84C7-520CB1CEFEBA}"/>
+                <a16:creationId xmlns:a16="http://schemas.microsoft.com/office/drawing/2014/main" id="{4E17F860-2E5B-4DE8-859B-9E9901CE8A8C}"/>
               </a:ext>
             </a:extLst>
           </p:cNvPr>
@@ -8183,7 +8183,7 @@
                   <a:srgbClr val="004C3F"/>
                 </a:solidFill>
               </a:rPr>
-              <a:t>SupplierがRetailerへ請求</a:t>
+              <a:t>サプライヤーが小売業者へ請求</a:t>
             </a:r>
           </a:p>
         </p:txBody>
@@ -8193,7 +8193,7 @@
           <p:cNvPr id="6" name="">
             <a:extLst xmlns:a="http://schemas.openxmlformats.org/drawingml/2006/main">
               <a:ext uri="{FF2B5EF4-FFF2-40B4-BE49-F238E27FC236}">
-                <a16:creationId xmlns:a16="http://schemas.microsoft.com/office/drawing/2014/main" id="{1A1852A6-B5A5-42ED-8441-05C540A51904}"/>
+                <a16:creationId xmlns:a16="http://schemas.microsoft.com/office/drawing/2014/main" id="{28DC3083-D0BD-473E-8636-1E6624497C02}"/>
               </a:ext>
             </a:extLst>
           </p:cNvPr>
@@ -8233,7 +8233,7 @@
                   <a:srgbClr val="101820"/>
                 </a:solidFill>
               </a:rPr>
-              <a:t>Supplier shipping ratesが、RetailerがSupplierへ支払う送料を決めます。</a:t>
+              <a:t>サプライヤー送料が、小売業者がサプライヤーへ支払う送料を決めます。</a:t>
             </a:r>
           </a:p>
         </p:txBody>
@@ -8243,7 +8243,7 @@
           <p:cNvPr id="7" name="">
             <a:extLst xmlns:a="http://schemas.openxmlformats.org/drawingml/2006/main">
               <a:ext uri="{FF2B5EF4-FFF2-40B4-BE49-F238E27FC236}">
-                <a16:creationId xmlns:a16="http://schemas.microsoft.com/office/drawing/2014/main" id="{8B43393F-6596-4E2D-9E09-FD38BEFFF164}"/>
+                <a16:creationId xmlns:a16="http://schemas.microsoft.com/office/drawing/2014/main" id="{36F95E53-7E37-429B-92EB-A0C9C04845C8}"/>
               </a:ext>
             </a:extLst>
           </p:cNvPr>
@@ -8289,7 +8289,7 @@
                   <a:srgbClr val="101820"/>
                 </a:solidFill>
               </a:rPr>
-              <a:t>Retailerが購入者へ請求</a:t>
+              <a:t>小売業者が購入者へ請求</a:t>
             </a:r>
           </a:p>
         </p:txBody>
@@ -8299,7 +8299,7 @@
           <p:cNvPr id="8" name="">
             <a:extLst xmlns:a="http://schemas.openxmlformats.org/drawingml/2006/main">
               <a:ext uri="{FF2B5EF4-FFF2-40B4-BE49-F238E27FC236}">
-                <a16:creationId xmlns:a16="http://schemas.microsoft.com/office/drawing/2014/main" id="{07A618D1-0515-415A-ABC4-0C89DB9B844F}"/>
+                <a16:creationId xmlns:a16="http://schemas.microsoft.com/office/drawing/2014/main" id="{12DDC93C-B74E-40FA-90D6-91B34D2F457C}"/>
               </a:ext>
             </a:extLst>
           </p:cNvPr>
@@ -8339,7 +8339,7 @@
                   <a:srgbClr val="101820"/>
                 </a:solidFill>
               </a:rPr>
-              <a:t>標準profileではSupplierレートを返し、custom profileでは別の購入者向け送料を設定できます。</a:t>
+              <a:t>標準profileではサプライヤーレートを返し、custom profileでは別の購入者向け送料を設定できます。</a:t>
             </a:r>
           </a:p>
         </p:txBody>
@@ -8349,7 +8349,7 @@
           <p:cNvPr id="9" name="">
             <a:extLst xmlns:a="http://schemas.openxmlformats.org/drawingml/2006/main">
               <a:ext uri="{FF2B5EF4-FFF2-40B4-BE49-F238E27FC236}">
-                <a16:creationId xmlns:a16="http://schemas.microsoft.com/office/drawing/2014/main" id="{6DD5B83F-5DE8-48AB-8F43-C23614BB4BC6}"/>
+                <a16:creationId xmlns:a16="http://schemas.microsoft.com/office/drawing/2014/main" id="{B92FC27D-1DBB-4D1C-859B-F500E16004FC}"/>
               </a:ext>
             </a:extLst>
           </p:cNvPr>
@@ -8399,7 +8399,7 @@
           <p:cNvPr id="10" name="">
             <a:extLst xmlns:a="http://schemas.openxmlformats.org/drawingml/2006/main">
               <a:ext uri="{FF2B5EF4-FFF2-40B4-BE49-F238E27FC236}">
-                <a16:creationId xmlns:a16="http://schemas.microsoft.com/office/drawing/2014/main" id="{085E3C8A-F542-4AF3-ACEB-F70FEB36A780}"/>
+                <a16:creationId xmlns:a16="http://schemas.microsoft.com/office/drawing/2014/main" id="{C7E5415E-E48D-4D05-A552-9E84BF24C8EC}"/>
               </a:ext>
             </a:extLst>
           </p:cNvPr>
@@ -8439,7 +8439,7 @@
                   <a:srgbClr val="52615B"/>
                 </a:solidFill>
               </a:rPr>
-              <a:t>送料差益または送料補助はRetailer側の経済性として扱います。</a:t>
+              <a:t>送料差益または送料補助は小売業者側の経済性として扱います。</a:t>
             </a:r>
           </a:p>
         </p:txBody>
@@ -8449,7 +8449,7 @@
           <p:cNvPr id="11" name="">
             <a:extLst xmlns:a="http://schemas.openxmlformats.org/drawingml/2006/main">
               <a:ext uri="{FF2B5EF4-FFF2-40B4-BE49-F238E27FC236}">
-                <a16:creationId xmlns:a16="http://schemas.microsoft.com/office/drawing/2014/main" id="{8A0A8486-B4CE-4279-8E83-32D159F9EFD6}"/>
+                <a16:creationId xmlns:a16="http://schemas.microsoft.com/office/drawing/2014/main" id="{C723C4E1-B5DB-4773-A3AD-6BD914679E34}"/>
               </a:ext>
             </a:extLst>
           </p:cNvPr>
@@ -8480,7 +8480,7 @@
           <p:cNvPr id="12" name="">
             <a:extLst xmlns:a="http://schemas.openxmlformats.org/drawingml/2006/main">
               <a:ext uri="{FF2B5EF4-FFF2-40B4-BE49-F238E27FC236}">
-                <a16:creationId xmlns:a16="http://schemas.microsoft.com/office/drawing/2014/main" id="{65715C54-AAE4-47D6-BE52-4BD088C92D1C}"/>
+                <a16:creationId xmlns:a16="http://schemas.microsoft.com/office/drawing/2014/main" id="{32BE6BC9-1A3E-4110-828C-562BBDADBE9D}"/>
               </a:ext>
             </a:extLst>
           </p:cNvPr>
@@ -8530,7 +8530,7 @@
           <p:cNvPr id="13" name="">
             <a:extLst xmlns:a="http://schemas.openxmlformats.org/drawingml/2006/main">
               <a:ext uri="{FF2B5EF4-FFF2-40B4-BE49-F238E27FC236}">
-                <a16:creationId xmlns:a16="http://schemas.microsoft.com/office/drawing/2014/main" id="{36A89FDF-A974-442C-870B-630A837EC33D}"/>
+                <a16:creationId xmlns:a16="http://schemas.microsoft.com/office/drawing/2014/main" id="{F3A7CADD-3E97-4624-A34B-47278A9FED77}"/>
               </a:ext>
             </a:extLst>
           </p:cNvPr>
@@ -8578,7 +8578,7 @@
     </p:spTree>
     <p:extLst>
       <p:ext uri="{BB962C8B-B14F-4D97-AF65-F5344CB8AC3E}">
-        <p14:creationId xmlns:p14="http://schemas.microsoft.com/office/powerpoint/2010/main" val="507634709"/>
+        <p14:creationId xmlns:p14="http://schemas.microsoft.com/office/powerpoint/2010/main" val="1165810676"/>
       </p:ext>
     </p:extLst>
   </p:cSld>
@@ -8609,7 +8609,7 @@
           <p:cNvPr id="1" name="">
             <a:extLst xmlns:a="http://schemas.openxmlformats.org/drawingml/2006/main">
               <a:ext uri="{FF2B5EF4-FFF2-40B4-BE49-F238E27FC236}">
-                <a16:creationId xmlns:a16="http://schemas.microsoft.com/office/drawing/2014/main" id="{B66B898E-E930-4424-962E-EFB9B2C559E7}"/>
+                <a16:creationId xmlns:a16="http://schemas.microsoft.com/office/drawing/2014/main" id="{65437201-5C8F-4B65-8D61-CAB67BACC734}"/>
               </a:ext>
             </a:extLst>
           </p:cNvPr>
@@ -8659,7 +8659,7 @@
           <p:cNvPr id="2" name="">
             <a:extLst xmlns:a="http://schemas.openxmlformats.org/drawingml/2006/main">
               <a:ext uri="{FF2B5EF4-FFF2-40B4-BE49-F238E27FC236}">
-                <a16:creationId xmlns:a16="http://schemas.microsoft.com/office/drawing/2014/main" id="{AFFD2BEC-8ED3-4B1E-A798-01FB3FE9909B}"/>
+                <a16:creationId xmlns:a16="http://schemas.microsoft.com/office/drawing/2014/main" id="{4B684A6E-538B-4314-924F-76DA0700A79C}"/>
               </a:ext>
             </a:extLst>
           </p:cNvPr>
@@ -8699,7 +8699,7 @@
                   <a:srgbClr val="101820"/>
                 </a:solidFill>
               </a:rPr>
-              <a:t>Supplier注文は支払いと不正チェック後に作られる</a:t>
+              <a:t>サプライヤー注文は支払いと不正チェック後に作られる</a:t>
             </a:r>
           </a:p>
         </p:txBody>
@@ -8709,7 +8709,7 @@
           <p:cNvPr id="3" name="">
             <a:extLst xmlns:a="http://schemas.openxmlformats.org/drawingml/2006/main">
               <a:ext uri="{FF2B5EF4-FFF2-40B4-BE49-F238E27FC236}">
-                <a16:creationId xmlns:a16="http://schemas.microsoft.com/office/drawing/2014/main" id="{4207FAEB-AC93-4A0D-9152-FF0EBBC91C19}"/>
+                <a16:creationId xmlns:a16="http://schemas.microsoft.com/office/drawing/2014/main" id="{B69BC0C5-07E0-4D54-8675-C5B28A85B9A5}"/>
               </a:ext>
             </a:extLst>
           </p:cNvPr>
@@ -8749,7 +8749,7 @@
                   <a:srgbClr val="52615B"/>
                 </a:solidFill>
               </a:rPr>
-              <a:t>Retailer注文が先に作成され、その後CollectiveがSupplier注文とfulfillment orderをリンクします。</a:t>
+              <a:t>小売業者注文が先に作成され、その後Collectiveがサプライヤー注文とfulfillment orderをリンクします。</a:t>
             </a:r>
           </a:p>
         </p:txBody>
@@ -8759,7 +8759,7 @@
           <p:cNvPr id="4" name="">
             <a:extLst xmlns:a="http://schemas.openxmlformats.org/drawingml/2006/main">
               <a:ext uri="{FF2B5EF4-FFF2-40B4-BE49-F238E27FC236}">
-                <a16:creationId xmlns:a16="http://schemas.microsoft.com/office/drawing/2014/main" id="{2E685656-8CB0-40D3-B583-CF6BE17EAD99}"/>
+                <a16:creationId xmlns:a16="http://schemas.microsoft.com/office/drawing/2014/main" id="{39BE93E5-15AC-484F-84D0-A821B2C5DE21}"/>
               </a:ext>
             </a:extLst>
           </p:cNvPr>
@@ -8790,7 +8790,7 @@
           <p:cNvPr id="5" name="">
             <a:extLst xmlns:a="http://schemas.openxmlformats.org/drawingml/2006/main">
               <a:ext uri="{FF2B5EF4-FFF2-40B4-BE49-F238E27FC236}">
-                <a16:creationId xmlns:a16="http://schemas.microsoft.com/office/drawing/2014/main" id="{0719BFBA-0FEA-4C7F-86FB-75573B73A24A}"/>
+                <a16:creationId xmlns:a16="http://schemas.microsoft.com/office/drawing/2014/main" id="{B0A5D920-4375-46A6-86D8-C72B6396D6FC}"/>
               </a:ext>
             </a:extLst>
           </p:cNvPr>
@@ -8846,7 +8846,7 @@
           <p:cNvPr id="6" name="">
             <a:extLst xmlns:a="http://schemas.openxmlformats.org/drawingml/2006/main">
               <a:ext uri="{FF2B5EF4-FFF2-40B4-BE49-F238E27FC236}">
-                <a16:creationId xmlns:a16="http://schemas.microsoft.com/office/drawing/2014/main" id="{3C0EFDA7-4963-4DAD-9D6B-EBBE6E99258C}"/>
+                <a16:creationId xmlns:a16="http://schemas.microsoft.com/office/drawing/2014/main" id="{ADDA32DF-C042-4AEA-863F-EE457DD1BE5D}"/>
               </a:ext>
             </a:extLst>
           </p:cNvPr>
@@ -8886,7 +8886,7 @@
                   <a:srgbClr val="101820"/>
                 </a:solidFill>
               </a:rPr>
-              <a:t>購入者がRetailerでcheckout</a:t>
+              <a:t>購入者が小売業者でcheckout</a:t>
             </a:r>
           </a:p>
         </p:txBody>
@@ -8896,7 +8896,7 @@
           <p:cNvPr id="7" name="">
             <a:extLst xmlns:a="http://schemas.openxmlformats.org/drawingml/2006/main">
               <a:ext uri="{FF2B5EF4-FFF2-40B4-BE49-F238E27FC236}">
-                <a16:creationId xmlns:a16="http://schemas.microsoft.com/office/drawing/2014/main" id="{C34F8AB8-80FC-432D-B9F0-F94D61106F35}"/>
+                <a16:creationId xmlns:a16="http://schemas.microsoft.com/office/drawing/2014/main" id="{5A463A28-CF4F-4591-AA89-3DF6E8B67371}"/>
               </a:ext>
             </a:extLst>
           </p:cNvPr>
@@ -8936,7 +8936,7 @@
                   <a:srgbClr val="52615B"/>
                 </a:solidFill>
               </a:rPr>
-              <a:t>Retailer注文にShopify Collectiveタグが付きます。</a:t>
+              <a:t>小売業者注文にShopify Collectiveタグが付きます。</a:t>
             </a:r>
           </a:p>
         </p:txBody>
@@ -8946,7 +8946,7 @@
           <p:cNvPr id="8" name="">
             <a:extLst xmlns:a="http://schemas.openxmlformats.org/drawingml/2006/main">
               <a:ext uri="{FF2B5EF4-FFF2-40B4-BE49-F238E27FC236}">
-                <a16:creationId xmlns:a16="http://schemas.microsoft.com/office/drawing/2014/main" id="{C4EDFEE7-BAFD-443B-9674-BC4745391841}"/>
+                <a16:creationId xmlns:a16="http://schemas.microsoft.com/office/drawing/2014/main" id="{2A643649-464F-40FF-AD0A-FC3D969DA722}"/>
               </a:ext>
             </a:extLst>
           </p:cNvPr>
@@ -8996,7 +8996,7 @@
           <p:cNvPr id="9" name="">
             <a:extLst xmlns:a="http://schemas.openxmlformats.org/drawingml/2006/main">
               <a:ext uri="{FF2B5EF4-FFF2-40B4-BE49-F238E27FC236}">
-                <a16:creationId xmlns:a16="http://schemas.microsoft.com/office/drawing/2014/main" id="{8ABAC611-46E9-4D67-81E9-B0A6D1DE6253}"/>
+                <a16:creationId xmlns:a16="http://schemas.microsoft.com/office/drawing/2014/main" id="{0CA52810-5BC4-4D9F-BDF4-D8E34A9416CA}"/>
               </a:ext>
             </a:extLst>
           </p:cNvPr>
@@ -9052,7 +9052,7 @@
           <p:cNvPr id="10" name="">
             <a:extLst xmlns:a="http://schemas.openxmlformats.org/drawingml/2006/main">
               <a:ext uri="{FF2B5EF4-FFF2-40B4-BE49-F238E27FC236}">
-                <a16:creationId xmlns:a16="http://schemas.microsoft.com/office/drawing/2014/main" id="{1D404FA9-9E2F-4ABC-842E-7DB777603A61}"/>
+                <a16:creationId xmlns:a16="http://schemas.microsoft.com/office/drawing/2014/main" id="{55F6854B-2A01-428C-B460-BC485D542E32}"/>
               </a:ext>
             </a:extLst>
           </p:cNvPr>
@@ -9102,7 +9102,7 @@
           <p:cNvPr id="11" name="">
             <a:extLst xmlns:a="http://schemas.openxmlformats.org/drawingml/2006/main">
               <a:ext uri="{FF2B5EF4-FFF2-40B4-BE49-F238E27FC236}">
-                <a16:creationId xmlns:a16="http://schemas.microsoft.com/office/drawing/2014/main" id="{D62D701F-3238-443D-9FF1-E682BFA3D834}"/>
+                <a16:creationId xmlns:a16="http://schemas.microsoft.com/office/drawing/2014/main" id="{52DCAEED-433F-4E04-8347-51B48B8C09F5}"/>
               </a:ext>
             </a:extLst>
           </p:cNvPr>
@@ -9152,7 +9152,7 @@
           <p:cNvPr id="12" name="">
             <a:extLst xmlns:a="http://schemas.openxmlformats.org/drawingml/2006/main">
               <a:ext uri="{FF2B5EF4-FFF2-40B4-BE49-F238E27FC236}">
-                <a16:creationId xmlns:a16="http://schemas.microsoft.com/office/drawing/2014/main" id="{07A27564-CBA3-4239-938C-8158FFE97CFE}"/>
+                <a16:creationId xmlns:a16="http://schemas.microsoft.com/office/drawing/2014/main" id="{CC0963D5-86DE-4453-A60B-4A55E9D4A11D}"/>
               </a:ext>
             </a:extLst>
           </p:cNvPr>
@@ -9202,7 +9202,7 @@
           <p:cNvPr id="13" name="">
             <a:extLst xmlns:a="http://schemas.openxmlformats.org/drawingml/2006/main">
               <a:ext uri="{FF2B5EF4-FFF2-40B4-BE49-F238E27FC236}">
-                <a16:creationId xmlns:a16="http://schemas.microsoft.com/office/drawing/2014/main" id="{C72E88CA-1A25-483B-A066-7D957BEF6C2C}"/>
+                <a16:creationId xmlns:a16="http://schemas.microsoft.com/office/drawing/2014/main" id="{35D5045F-A3E5-4703-A0F2-70BADF90F45C}"/>
               </a:ext>
             </a:extLst>
           </p:cNvPr>
@@ -9258,7 +9258,7 @@
           <p:cNvPr id="14" name="">
             <a:extLst xmlns:a="http://schemas.openxmlformats.org/drawingml/2006/main">
               <a:ext uri="{FF2B5EF4-FFF2-40B4-BE49-F238E27FC236}">
-                <a16:creationId xmlns:a16="http://schemas.microsoft.com/office/drawing/2014/main" id="{36CB69AC-E66C-490C-895F-B1A15DEFEF48}"/>
+                <a16:creationId xmlns:a16="http://schemas.microsoft.com/office/drawing/2014/main" id="{58C33CFB-A225-4ADB-97F7-A0F8FC24DE96}"/>
               </a:ext>
             </a:extLst>
           </p:cNvPr>
@@ -9298,7 +9298,7 @@
                   <a:srgbClr val="101820"/>
                 </a:solidFill>
               </a:rPr>
-              <a:t>Supplier注文を作成</a:t>
+              <a:t>サプライヤー注文を作成</a:t>
             </a:r>
           </a:p>
         </p:txBody>
@@ -9308,7 +9308,7 @@
           <p:cNvPr id="15" name="">
             <a:extLst xmlns:a="http://schemas.openxmlformats.org/drawingml/2006/main">
               <a:ext uri="{FF2B5EF4-FFF2-40B4-BE49-F238E27FC236}">
-                <a16:creationId xmlns:a16="http://schemas.microsoft.com/office/drawing/2014/main" id="{2107DDB6-3DFB-45DD-83EC-2732B912A121}"/>
+                <a16:creationId xmlns:a16="http://schemas.microsoft.com/office/drawing/2014/main" id="{8A146E66-4B13-49E4-9684-5463FFB4FE0A}"/>
               </a:ext>
             </a:extLst>
           </p:cNvPr>
@@ -9348,7 +9348,7 @@
                   <a:srgbClr val="52615B"/>
                 </a:solidFill>
               </a:rPr>
-              <a:t>Fulfillment requestを送り、Retailer fulfillmentとSupplier注文をリンクします。</a:t>
+              <a:t>Fulfillment requestを送り、小売業者fulfillmentとサプライヤー注文をリンクします。</a:t>
             </a:r>
           </a:p>
         </p:txBody>
@@ -9358,7 +9358,7 @@
           <p:cNvPr id="16" name="">
             <a:extLst xmlns:a="http://schemas.openxmlformats.org/drawingml/2006/main">
               <a:ext uri="{FF2B5EF4-FFF2-40B4-BE49-F238E27FC236}">
-                <a16:creationId xmlns:a16="http://schemas.microsoft.com/office/drawing/2014/main" id="{F639A0E5-5B21-4CCF-9BFC-EB51701A4D20}"/>
+                <a16:creationId xmlns:a16="http://schemas.microsoft.com/office/drawing/2014/main" id="{84AE468C-AD5F-476A-B591-30A6DB75F834}"/>
               </a:ext>
             </a:extLst>
           </p:cNvPr>
@@ -9408,7 +9408,7 @@
           <p:cNvPr id="17" name="">
             <a:extLst xmlns:a="http://schemas.openxmlformats.org/drawingml/2006/main">
               <a:ext uri="{FF2B5EF4-FFF2-40B4-BE49-F238E27FC236}">
-                <a16:creationId xmlns:a16="http://schemas.microsoft.com/office/drawing/2014/main" id="{619A0651-CDF1-44EF-A2DC-6D1EF7904A34}"/>
+                <a16:creationId xmlns:a16="http://schemas.microsoft.com/office/drawing/2014/main" id="{96473C72-6183-4EE6-A960-2DB2C7089721}"/>
               </a:ext>
             </a:extLst>
           </p:cNvPr>
@@ -9464,7 +9464,7 @@
           <p:cNvPr id="18" name="">
             <a:extLst xmlns:a="http://schemas.openxmlformats.org/drawingml/2006/main">
               <a:ext uri="{FF2B5EF4-FFF2-40B4-BE49-F238E27FC236}">
-                <a16:creationId xmlns:a16="http://schemas.microsoft.com/office/drawing/2014/main" id="{BA8DF578-55C2-4359-A8C6-59AD1D160AC1}"/>
+                <a16:creationId xmlns:a16="http://schemas.microsoft.com/office/drawing/2014/main" id="{DE042AEE-419D-423B-8AEC-BAEB19EA5527}"/>
               </a:ext>
             </a:extLst>
           </p:cNvPr>
@@ -9504,7 +9504,7 @@
                   <a:srgbClr val="101820"/>
                 </a:solidFill>
               </a:rPr>
-              <a:t>Supplierが顧客へ出荷</a:t>
+              <a:t>サプライヤーが顧客へ出荷</a:t>
             </a:r>
           </a:p>
         </p:txBody>
@@ -9514,7 +9514,7 @@
           <p:cNvPr id="19" name="">
             <a:extLst xmlns:a="http://schemas.openxmlformats.org/drawingml/2006/main">
               <a:ext uri="{FF2B5EF4-FFF2-40B4-BE49-F238E27FC236}">
-                <a16:creationId xmlns:a16="http://schemas.microsoft.com/office/drawing/2014/main" id="{410903D1-EDBC-4D06-968B-FEAC19458D98}"/>
+                <a16:creationId xmlns:a16="http://schemas.microsoft.com/office/drawing/2014/main" id="{D39928E7-676D-4DF0-B91F-3CB543655B76}"/>
               </a:ext>
             </a:extLst>
           </p:cNvPr>
@@ -9554,7 +9554,7 @@
                   <a:srgbClr val="52615B"/>
                 </a:solidFill>
               </a:rPr>
-              <a:t>SupplierはRetailerではなくエンド顧客へ直接フルフィルメントします。</a:t>
+              <a:t>サプライヤーは小売業者ではなくエンド顧客へ直接フルフィルメントします。</a:t>
             </a:r>
           </a:p>
         </p:txBody>
@@ -9564,7 +9564,7 @@
           <p:cNvPr id="20" name="">
             <a:extLst xmlns:a="http://schemas.openxmlformats.org/drawingml/2006/main">
               <a:ext uri="{FF2B5EF4-FFF2-40B4-BE49-F238E27FC236}">
-                <a16:creationId xmlns:a16="http://schemas.microsoft.com/office/drawing/2014/main" id="{B9F9D4F6-9481-46E3-8C40-E6305117DAE5}"/>
+                <a16:creationId xmlns:a16="http://schemas.microsoft.com/office/drawing/2014/main" id="{B87E2E58-BC2E-4280-92A0-7FE6304CFA6F}"/>
               </a:ext>
             </a:extLst>
           </p:cNvPr>
@@ -9614,7 +9614,7 @@
           <p:cNvPr id="21" name="">
             <a:extLst xmlns:a="http://schemas.openxmlformats.org/drawingml/2006/main">
               <a:ext uri="{FF2B5EF4-FFF2-40B4-BE49-F238E27FC236}">
-                <a16:creationId xmlns:a16="http://schemas.microsoft.com/office/drawing/2014/main" id="{AA47D1AC-26A0-4C50-9A63-2FBCA995C228}"/>
+                <a16:creationId xmlns:a16="http://schemas.microsoft.com/office/drawing/2014/main" id="{CBBFA25E-D6BF-41EA-9864-D00C91EBA472}"/>
               </a:ext>
             </a:extLst>
           </p:cNvPr>
@@ -9670,7 +9670,7 @@
           <p:cNvPr id="22" name="">
             <a:extLst xmlns:a="http://schemas.openxmlformats.org/drawingml/2006/main">
               <a:ext uri="{FF2B5EF4-FFF2-40B4-BE49-F238E27FC236}">
-                <a16:creationId xmlns:a16="http://schemas.microsoft.com/office/drawing/2014/main" id="{D650E7C6-DD9A-4CDD-B2CF-1283FF247780}"/>
+                <a16:creationId xmlns:a16="http://schemas.microsoft.com/office/drawing/2014/main" id="{73F766F8-4B54-4548-943B-2B33C8103B42}"/>
               </a:ext>
             </a:extLst>
           </p:cNvPr>
@@ -9710,7 +9710,7 @@
                   <a:srgbClr val="101820"/>
                 </a:solidFill>
               </a:rPr>
-              <a:t>状態をRetailerへ同期</a:t>
+              <a:t>状態を小売業者へ同期</a:t>
             </a:r>
           </a:p>
         </p:txBody>
@@ -9720,7 +9720,7 @@
           <p:cNvPr id="23" name="">
             <a:extLst xmlns:a="http://schemas.openxmlformats.org/drawingml/2006/main">
               <a:ext uri="{FF2B5EF4-FFF2-40B4-BE49-F238E27FC236}">
-                <a16:creationId xmlns:a16="http://schemas.microsoft.com/office/drawing/2014/main" id="{A5C1EC7B-FF8F-469D-9B24-AFF294C03639}"/>
+                <a16:creationId xmlns:a16="http://schemas.microsoft.com/office/drawing/2014/main" id="{8E96FA17-6648-4FCE-9898-07D6B5151E3A}"/>
               </a:ext>
             </a:extLst>
           </p:cNvPr>
@@ -9760,7 +9760,7 @@
                   <a:srgbClr val="52615B"/>
                 </a:solidFill>
               </a:rPr>
-              <a:t>FulfillmentとtrackingがRetailer注文へ反映されます。</a:t>
+              <a:t>Fulfillmentとtrackingが小売業者注文へ反映されます。</a:t>
             </a:r>
           </a:p>
         </p:txBody>
@@ -9770,7 +9770,7 @@
           <p:cNvPr id="24" name="">
             <a:extLst xmlns:a="http://schemas.openxmlformats.org/drawingml/2006/main">
               <a:ext uri="{FF2B5EF4-FFF2-40B4-BE49-F238E27FC236}">
-                <a16:creationId xmlns:a16="http://schemas.microsoft.com/office/drawing/2014/main" id="{F6DD93AF-5D6F-4B2A-969F-EB6D84DEBC53}"/>
+                <a16:creationId xmlns:a16="http://schemas.microsoft.com/office/drawing/2014/main" id="{D0C82D14-C173-4139-9836-7DD04C611BEA}"/>
               </a:ext>
             </a:extLst>
           </p:cNvPr>
@@ -9801,7 +9801,7 @@
           <p:cNvPr id="25" name="">
             <a:extLst xmlns:a="http://schemas.openxmlformats.org/drawingml/2006/main">
               <a:ext uri="{FF2B5EF4-FFF2-40B4-BE49-F238E27FC236}">
-                <a16:creationId xmlns:a16="http://schemas.microsoft.com/office/drawing/2014/main" id="{92DDE993-0A98-460A-9C5D-96D8D72527A7}"/>
+                <a16:creationId xmlns:a16="http://schemas.microsoft.com/office/drawing/2014/main" id="{7AF5934A-7769-4F5F-9335-46BC9C034FDA}"/>
               </a:ext>
             </a:extLst>
           </p:cNvPr>
@@ -9851,7 +9851,7 @@
           <p:cNvPr id="26" name="">
             <a:extLst xmlns:a="http://schemas.openxmlformats.org/drawingml/2006/main">
               <a:ext uri="{FF2B5EF4-FFF2-40B4-BE49-F238E27FC236}">
-                <a16:creationId xmlns:a16="http://schemas.microsoft.com/office/drawing/2014/main" id="{5632C503-5F92-4654-A5B3-AB968E1BFA96}"/>
+                <a16:creationId xmlns:a16="http://schemas.microsoft.com/office/drawing/2014/main" id="{595628DC-9435-41F1-A39A-87BE2A73F16F}"/>
               </a:ext>
             </a:extLst>
           </p:cNvPr>
@@ -9899,7 +9899,7 @@
     </p:spTree>
     <p:extLst>
       <p:ext uri="{BB962C8B-B14F-4D97-AF65-F5344CB8AC3E}">
-        <p14:creationId xmlns:p14="http://schemas.microsoft.com/office/powerpoint/2010/main" val="2049739093"/>
+        <p14:creationId xmlns:p14="http://schemas.microsoft.com/office/powerpoint/2010/main" val="143365893"/>
       </p:ext>
     </p:extLst>
   </p:cSld>
@@ -9930,7 +9930,7 @@
           <p:cNvPr id="1" name="">
             <a:extLst xmlns:a="http://schemas.openxmlformats.org/drawingml/2006/main">
               <a:ext uri="{FF2B5EF4-FFF2-40B4-BE49-F238E27FC236}">
-                <a16:creationId xmlns:a16="http://schemas.microsoft.com/office/drawing/2014/main" id="{95D93093-2EFE-4020-AE17-5FCFA36717A0}"/>
+                <a16:creationId xmlns:a16="http://schemas.microsoft.com/office/drawing/2014/main" id="{713B04AE-AF66-4BE1-918D-59C3500F318F}"/>
               </a:ext>
             </a:extLst>
           </p:cNvPr>
@@ -9980,7 +9980,7 @@
           <p:cNvPr id="2" name="">
             <a:extLst xmlns:a="http://schemas.openxmlformats.org/drawingml/2006/main">
               <a:ext uri="{FF2B5EF4-FFF2-40B4-BE49-F238E27FC236}">
-                <a16:creationId xmlns:a16="http://schemas.microsoft.com/office/drawing/2014/main" id="{CD8771BB-5457-49C4-93D0-2A3B8B22A95E}"/>
+                <a16:creationId xmlns:a16="http://schemas.microsoft.com/office/drawing/2014/main" id="{C8B885C2-2EB5-4AA9-A9FE-E0E80F9046E3}"/>
               </a:ext>
             </a:extLst>
           </p:cNvPr>
@@ -10030,7 +10030,7 @@
           <p:cNvPr id="3" name="">
             <a:extLst xmlns:a="http://schemas.openxmlformats.org/drawingml/2006/main">
               <a:ext uri="{FF2B5EF4-FFF2-40B4-BE49-F238E27FC236}">
-                <a16:creationId xmlns:a16="http://schemas.microsoft.com/office/drawing/2014/main" id="{699CFC64-BD2C-4F85-BE43-3C1A3161D967}"/>
+                <a16:creationId xmlns:a16="http://schemas.microsoft.com/office/drawing/2014/main" id="{F29A0C19-66A7-4197-AE47-DB7FE00D38E5}"/>
               </a:ext>
             </a:extLst>
           </p:cNvPr>
@@ -10070,7 +10070,7 @@
                   <a:srgbClr val="52615B"/>
                 </a:solidFill>
               </a:rPr>
-              <a:t>自動支払いがONの場合、Retailer残高からdebitされ、Supplierフルフィルメント後にSupplier残高へcreditされます。</a:t>
+              <a:t>自動支払いがONの場合、小売業者残高からdebitされ、サプライヤーフルフィルメント後にサプライヤー残高へcreditされます。</a:t>
             </a:r>
           </a:p>
         </p:txBody>
@@ -10080,7 +10080,7 @@
           <p:cNvPr id="4" name="">
             <a:extLst xmlns:a="http://schemas.openxmlformats.org/drawingml/2006/main">
               <a:ext uri="{FF2B5EF4-FFF2-40B4-BE49-F238E27FC236}">
-                <a16:creationId xmlns:a16="http://schemas.microsoft.com/office/drawing/2014/main" id="{BD43482F-ED8D-4642-B05D-8EA123A18CE2}"/>
+                <a16:creationId xmlns:a16="http://schemas.microsoft.com/office/drawing/2014/main" id="{79EA08A1-6C70-48A0-86EE-D02521A86EFC}"/>
               </a:ext>
             </a:extLst>
           </p:cNvPr>
@@ -10111,7 +10111,7 @@
           <p:cNvPr id="5" name="">
             <a:extLst xmlns:a="http://schemas.openxmlformats.org/drawingml/2006/main">
               <a:ext uri="{FF2B5EF4-FFF2-40B4-BE49-F238E27FC236}">
-                <a16:creationId xmlns:a16="http://schemas.microsoft.com/office/drawing/2014/main" id="{E099A51C-EB67-443E-82A2-C960CCD2C9F0}"/>
+                <a16:creationId xmlns:a16="http://schemas.microsoft.com/office/drawing/2014/main" id="{2D74CD3A-B447-45D3-A04F-001930DDDD88}"/>
               </a:ext>
             </a:extLst>
           </p:cNvPr>
@@ -10167,7 +10167,7 @@
           <p:cNvPr id="6" name="">
             <a:extLst xmlns:a="http://schemas.openxmlformats.org/drawingml/2006/main">
               <a:ext uri="{FF2B5EF4-FFF2-40B4-BE49-F238E27FC236}">
-                <a16:creationId xmlns:a16="http://schemas.microsoft.com/office/drawing/2014/main" id="{5B341291-C045-4BE5-B905-8FB379173CC9}"/>
+                <a16:creationId xmlns:a16="http://schemas.microsoft.com/office/drawing/2014/main" id="{4C90B4AA-BB0E-46E0-9C52-AB1F65B6AD9F}"/>
               </a:ext>
             </a:extLst>
           </p:cNvPr>
@@ -10207,7 +10207,7 @@
                   <a:srgbClr val="101820"/>
                 </a:solidFill>
               </a:rPr>
-              <a:t>Retailer注文が支払い済み</a:t>
+              <a:t>小売業者注文が支払い済み</a:t>
             </a:r>
           </a:p>
         </p:txBody>
@@ -10217,7 +10217,7 @@
           <p:cNvPr id="7" name="">
             <a:extLst xmlns:a="http://schemas.openxmlformats.org/drawingml/2006/main">
               <a:ext uri="{FF2B5EF4-FFF2-40B4-BE49-F238E27FC236}">
-                <a16:creationId xmlns:a16="http://schemas.microsoft.com/office/drawing/2014/main" id="{177E9351-C4F4-489F-B252-F8B15629F472}"/>
+                <a16:creationId xmlns:a16="http://schemas.microsoft.com/office/drawing/2014/main" id="{0E6132F3-260A-4D18-A063-3D788F8A2E34}"/>
               </a:ext>
             </a:extLst>
           </p:cNvPr>
@@ -10257,7 +10257,7 @@
                   <a:srgbClr val="52615B"/>
                 </a:solidFill>
               </a:rPr>
-              <a:t>Mark paidによりSupplier支払い用のdebitが発生する場合があります。</a:t>
+              <a:t>Mark paidによりサプライヤー支払い用のdebitが発生する場合があります。</a:t>
             </a:r>
           </a:p>
         </p:txBody>
@@ -10267,7 +10267,7 @@
           <p:cNvPr id="8" name="">
             <a:extLst xmlns:a="http://schemas.openxmlformats.org/drawingml/2006/main">
               <a:ext uri="{FF2B5EF4-FFF2-40B4-BE49-F238E27FC236}">
-                <a16:creationId xmlns:a16="http://schemas.microsoft.com/office/drawing/2014/main" id="{2CAF2738-F500-4B67-ACCF-A474402268EF}"/>
+                <a16:creationId xmlns:a16="http://schemas.microsoft.com/office/drawing/2014/main" id="{54606AAA-A9C1-44C8-99D0-3D65F7164533}"/>
               </a:ext>
             </a:extLst>
           </p:cNvPr>
@@ -10317,7 +10317,7 @@
           <p:cNvPr id="9" name="">
             <a:extLst xmlns:a="http://schemas.openxmlformats.org/drawingml/2006/main">
               <a:ext uri="{FF2B5EF4-FFF2-40B4-BE49-F238E27FC236}">
-                <a16:creationId xmlns:a16="http://schemas.microsoft.com/office/drawing/2014/main" id="{5A2858A0-029D-47C3-B353-439B7335018D}"/>
+                <a16:creationId xmlns:a16="http://schemas.microsoft.com/office/drawing/2014/main" id="{FB11AA08-FCB8-452D-A53A-2379F579A4E8}"/>
               </a:ext>
             </a:extLst>
           </p:cNvPr>
@@ -10373,7 +10373,7 @@
           <p:cNvPr id="10" name="">
             <a:extLst xmlns:a="http://schemas.openxmlformats.org/drawingml/2006/main">
               <a:ext uri="{FF2B5EF4-FFF2-40B4-BE49-F238E27FC236}">
-                <a16:creationId xmlns:a16="http://schemas.microsoft.com/office/drawing/2014/main" id="{41A31A82-2A03-4C5F-8D6A-A0C5D708FB12}"/>
+                <a16:creationId xmlns:a16="http://schemas.microsoft.com/office/drawing/2014/main" id="{55B8DD23-EA56-4E6C-AB84-13405B5D9BFD}"/>
               </a:ext>
             </a:extLst>
           </p:cNvPr>
@@ -10413,7 +10413,7 @@
                   <a:srgbClr val="101820"/>
                 </a:solidFill>
               </a:rPr>
-              <a:t>Supplierがfulfill</a:t>
+              <a:t>サプライヤーがfulfill</a:t>
             </a:r>
           </a:p>
         </p:txBody>
@@ -10423,7 +10423,7 @@
           <p:cNvPr id="11" name="">
             <a:extLst xmlns:a="http://schemas.openxmlformats.org/drawingml/2006/main">
               <a:ext uri="{FF2B5EF4-FFF2-40B4-BE49-F238E27FC236}">
-                <a16:creationId xmlns:a16="http://schemas.microsoft.com/office/drawing/2014/main" id="{30CFBAB9-4C8A-48CB-97A4-8F42DE6DE266}"/>
+                <a16:creationId xmlns:a16="http://schemas.microsoft.com/office/drawing/2014/main" id="{BD73E4DC-56E6-405E-A237-7A32D7304083}"/>
               </a:ext>
             </a:extLst>
           </p:cNvPr>
@@ -10463,7 +10463,7 @@
                   <a:srgbClr val="52615B"/>
                 </a:solidFill>
               </a:rPr>
-              <a:t>Supplier側のフルフィルメント後にSupplierへcreditされます。</a:t>
+              <a:t>サプライヤー側のフルフィルメント後にサプライヤーへcreditされます。</a:t>
             </a:r>
           </a:p>
         </p:txBody>
@@ -10473,7 +10473,7 @@
           <p:cNvPr id="12" name="">
             <a:extLst xmlns:a="http://schemas.openxmlformats.org/drawingml/2006/main">
               <a:ext uri="{FF2B5EF4-FFF2-40B4-BE49-F238E27FC236}">
-                <a16:creationId xmlns:a16="http://schemas.microsoft.com/office/drawing/2014/main" id="{63B2A919-F905-4687-AC08-686943EC6B80}"/>
+                <a16:creationId xmlns:a16="http://schemas.microsoft.com/office/drawing/2014/main" id="{30A130F4-35AC-46F7-B12C-0F89A12BEF03}"/>
               </a:ext>
             </a:extLst>
           </p:cNvPr>
@@ -10523,7 +10523,7 @@
           <p:cNvPr id="13" name="">
             <a:extLst xmlns:a="http://schemas.openxmlformats.org/drawingml/2006/main">
               <a:ext uri="{FF2B5EF4-FFF2-40B4-BE49-F238E27FC236}">
-                <a16:creationId xmlns:a16="http://schemas.microsoft.com/office/drawing/2014/main" id="{B0FBC1FF-1EA0-4BB9-8FF0-7D131D1EB81D}"/>
+                <a16:creationId xmlns:a16="http://schemas.microsoft.com/office/drawing/2014/main" id="{F7F3706E-1117-404C-93EB-8ED679991828}"/>
               </a:ext>
             </a:extLst>
           </p:cNvPr>
@@ -10579,7 +10579,7 @@
           <p:cNvPr id="14" name="">
             <a:extLst xmlns:a="http://schemas.openxmlformats.org/drawingml/2006/main">
               <a:ext uri="{FF2B5EF4-FFF2-40B4-BE49-F238E27FC236}">
-                <a16:creationId xmlns:a16="http://schemas.microsoft.com/office/drawing/2014/main" id="{39A4ABD6-9283-4784-BCA0-22061999BF85}"/>
+                <a16:creationId xmlns:a16="http://schemas.microsoft.com/office/drawing/2014/main" id="{7C12EDF0-BE7B-4BE6-8069-256137626F46}"/>
               </a:ext>
             </a:extLst>
           </p:cNvPr>
@@ -10629,7 +10629,7 @@
           <p:cNvPr id="15" name="">
             <a:extLst xmlns:a="http://schemas.openxmlformats.org/drawingml/2006/main">
               <a:ext uri="{FF2B5EF4-FFF2-40B4-BE49-F238E27FC236}">
-                <a16:creationId xmlns:a16="http://schemas.microsoft.com/office/drawing/2014/main" id="{3051B781-7228-475A-8CB7-F6775392275A}"/>
+                <a16:creationId xmlns:a16="http://schemas.microsoft.com/office/drawing/2014/main" id="{40C11F05-7617-4B34-B80A-C93C610FA825}"/>
               </a:ext>
             </a:extLst>
           </p:cNvPr>
@@ -10679,7 +10679,7 @@
           <p:cNvPr id="16" name="">
             <a:extLst xmlns:a="http://schemas.openxmlformats.org/drawingml/2006/main">
               <a:ext uri="{FF2B5EF4-FFF2-40B4-BE49-F238E27FC236}">
-                <a16:creationId xmlns:a16="http://schemas.microsoft.com/office/drawing/2014/main" id="{DEE8B329-C221-4BE2-8603-1AF5AAC8EA73}"/>
+                <a16:creationId xmlns:a16="http://schemas.microsoft.com/office/drawing/2014/main" id="{B7A88216-556E-436E-BD4A-F60BC0687701}"/>
               </a:ext>
             </a:extLst>
           </p:cNvPr>
@@ -10729,7 +10729,7 @@
           <p:cNvPr id="17" name="">
             <a:extLst xmlns:a="http://schemas.openxmlformats.org/drawingml/2006/main">
               <a:ext uri="{FF2B5EF4-FFF2-40B4-BE49-F238E27FC236}">
-                <a16:creationId xmlns:a16="http://schemas.microsoft.com/office/drawing/2014/main" id="{15C002D7-118F-41A5-B375-5A8AF1763859}"/>
+                <a16:creationId xmlns:a16="http://schemas.microsoft.com/office/drawing/2014/main" id="{739486AC-CB9F-4A91-90B3-B6ABA02DD3F8}"/>
               </a:ext>
             </a:extLst>
           </p:cNvPr>
@@ -10785,7 +10785,7 @@
           <p:cNvPr id="18" name="">
             <a:extLst xmlns:a="http://schemas.openxmlformats.org/drawingml/2006/main">
               <a:ext uri="{FF2B5EF4-FFF2-40B4-BE49-F238E27FC236}">
-                <a16:creationId xmlns:a16="http://schemas.microsoft.com/office/drawing/2014/main" id="{142C0679-9F56-4E20-9C87-4E9E049B712B}"/>
+                <a16:creationId xmlns:a16="http://schemas.microsoft.com/office/drawing/2014/main" id="{6AC8F328-F918-48E1-9DB5-6F04058FBE36}"/>
               </a:ext>
             </a:extLst>
           </p:cNvPr>
@@ -10835,7 +10835,7 @@
           <p:cNvPr id="19" name="">
             <a:extLst xmlns:a="http://schemas.openxmlformats.org/drawingml/2006/main">
               <a:ext uri="{FF2B5EF4-FFF2-40B4-BE49-F238E27FC236}">
-                <a16:creationId xmlns:a16="http://schemas.microsoft.com/office/drawing/2014/main" id="{768548D4-D821-48DA-8461-83941AA78095}"/>
+                <a16:creationId xmlns:a16="http://schemas.microsoft.com/office/drawing/2014/main" id="{372045DE-AEF6-4D0C-A902-6A7947C97649}"/>
               </a:ext>
             </a:extLst>
           </p:cNvPr>
@@ -10885,7 +10885,7 @@
           <p:cNvPr id="20" name="">
             <a:extLst xmlns:a="http://schemas.openxmlformats.org/drawingml/2006/main">
               <a:ext uri="{FF2B5EF4-FFF2-40B4-BE49-F238E27FC236}">
-                <a16:creationId xmlns:a16="http://schemas.microsoft.com/office/drawing/2014/main" id="{3575F1F8-096F-4D32-9924-1D42EB8271A8}"/>
+                <a16:creationId xmlns:a16="http://schemas.microsoft.com/office/drawing/2014/main" id="{8A973AEC-6785-495A-A1C2-74CAB88B93AD}"/>
               </a:ext>
             </a:extLst>
           </p:cNvPr>
@@ -10916,7 +10916,7 @@
           <p:cNvPr id="21" name="">
             <a:extLst xmlns:a="http://schemas.openxmlformats.org/drawingml/2006/main">
               <a:ext uri="{FF2B5EF4-FFF2-40B4-BE49-F238E27FC236}">
-                <a16:creationId xmlns:a16="http://schemas.microsoft.com/office/drawing/2014/main" id="{3BBCD8FC-7BE5-42BC-8A68-675B05C0B16B}"/>
+                <a16:creationId xmlns:a16="http://schemas.microsoft.com/office/drawing/2014/main" id="{141A2F48-6403-4A8B-B1E3-113D26EEA0E5}"/>
               </a:ext>
             </a:extLst>
           </p:cNvPr>
@@ -10966,7 +10966,7 @@
           <p:cNvPr id="22" name="">
             <a:extLst xmlns:a="http://schemas.openxmlformats.org/drawingml/2006/main">
               <a:ext uri="{FF2B5EF4-FFF2-40B4-BE49-F238E27FC236}">
-                <a16:creationId xmlns:a16="http://schemas.microsoft.com/office/drawing/2014/main" id="{886E38F5-680D-4845-932B-A58F0C6E6AC9}"/>
+                <a16:creationId xmlns:a16="http://schemas.microsoft.com/office/drawing/2014/main" id="{F7C6078E-4CB4-4A89-84D9-10091D911F5A}"/>
               </a:ext>
             </a:extLst>
           </p:cNvPr>
@@ -11014,7 +11014,7 @@
     </p:spTree>
     <p:extLst>
       <p:ext uri="{BB962C8B-B14F-4D97-AF65-F5344CB8AC3E}">
-        <p14:creationId xmlns:p14="http://schemas.microsoft.com/office/powerpoint/2010/main" val="2011813926"/>
+        <p14:creationId xmlns:p14="http://schemas.microsoft.com/office/powerpoint/2010/main" val="1028498912"/>
       </p:ext>
     </p:extLst>
   </p:cSld>
@@ -11045,7 +11045,7 @@
           <p:cNvPr id="1" name="">
             <a:extLst xmlns:a="http://schemas.openxmlformats.org/drawingml/2006/main">
               <a:ext uri="{FF2B5EF4-FFF2-40B4-BE49-F238E27FC236}">
-                <a16:creationId xmlns:a16="http://schemas.microsoft.com/office/drawing/2014/main" id="{2799BA31-2B2B-459A-B2B7-54489FB00BAE}"/>
+                <a16:creationId xmlns:a16="http://schemas.microsoft.com/office/drawing/2014/main" id="{56A0B160-16FD-4D2C-ABCC-FAED23339D85}"/>
               </a:ext>
             </a:extLst>
           </p:cNvPr>
@@ -11095,7 +11095,7 @@
           <p:cNvPr id="2" name="">
             <a:extLst xmlns:a="http://schemas.openxmlformats.org/drawingml/2006/main">
               <a:ext uri="{FF2B5EF4-FFF2-40B4-BE49-F238E27FC236}">
-                <a16:creationId xmlns:a16="http://schemas.microsoft.com/office/drawing/2014/main" id="{422795C9-42F3-4075-823B-F30A1D54D6D0}"/>
+                <a16:creationId xmlns:a16="http://schemas.microsoft.com/office/drawing/2014/main" id="{B5BD8F6B-F883-41C2-8BCC-32F287ADE23A}"/>
               </a:ext>
             </a:extLst>
           </p:cNvPr>
@@ -11145,7 +11145,7 @@
           <p:cNvPr id="3" name="">
             <a:extLst xmlns:a="http://schemas.openxmlformats.org/drawingml/2006/main">
               <a:ext uri="{FF2B5EF4-FFF2-40B4-BE49-F238E27FC236}">
-                <a16:creationId xmlns:a16="http://schemas.microsoft.com/office/drawing/2014/main" id="{21FE6A08-6652-4A83-9BB3-CE84CEAF8994}"/>
+                <a16:creationId xmlns:a16="http://schemas.microsoft.com/office/drawing/2014/main" id="{48FB2032-8AB1-415C-A8EF-5140B21CF866}"/>
               </a:ext>
             </a:extLst>
           </p:cNvPr>
@@ -11185,7 +11185,7 @@
                   <a:srgbClr val="52615B"/>
                 </a:solidFill>
               </a:rPr>
-              <a:t>支払い済みか、フルフィル済みか、Retailerの返品設定が何かによって処理が変わります。</a:t>
+              <a:t>支払い済みか、フルフィル済みか、小売業者の返品設定が何かによって処理が変わります。</a:t>
             </a:r>
           </a:p>
         </p:txBody>
@@ -11195,7 +11195,7 @@
           <p:cNvPr id="4" name="">
             <a:extLst xmlns:a="http://schemas.openxmlformats.org/drawingml/2006/main">
               <a:ext uri="{FF2B5EF4-FFF2-40B4-BE49-F238E27FC236}">
-                <a16:creationId xmlns:a16="http://schemas.microsoft.com/office/drawing/2014/main" id="{4F0ADF1C-C5C2-4C48-9BF7-182575C9BF25}"/>
+                <a16:creationId xmlns:a16="http://schemas.microsoft.com/office/drawing/2014/main" id="{FD40A866-582F-4E24-BCED-BEEBD7F9AD89}"/>
               </a:ext>
             </a:extLst>
           </p:cNvPr>
@@ -11226,7 +11226,7 @@
           <p:cNvPr id="5" name="">
             <a:extLst xmlns:a="http://schemas.openxmlformats.org/drawingml/2006/main">
               <a:ext uri="{FF2B5EF4-FFF2-40B4-BE49-F238E27FC236}">
-                <a16:creationId xmlns:a16="http://schemas.microsoft.com/office/drawing/2014/main" id="{C5975839-D571-407D-AFCD-D4A29579C299}"/>
+                <a16:creationId xmlns:a16="http://schemas.microsoft.com/office/drawing/2014/main" id="{57CAB728-6042-46BF-9017-96F5C325C3F8}"/>
               </a:ext>
             </a:extLst>
           </p:cNvPr>
@@ -11282,7 +11282,7 @@
           <p:cNvPr id="6" name="">
             <a:extLst xmlns:a="http://schemas.openxmlformats.org/drawingml/2006/main">
               <a:ext uri="{FF2B5EF4-FFF2-40B4-BE49-F238E27FC236}">
-                <a16:creationId xmlns:a16="http://schemas.microsoft.com/office/drawing/2014/main" id="{52E8846C-632F-411A-AB44-5FAA6786AB48}"/>
+                <a16:creationId xmlns:a16="http://schemas.microsoft.com/office/drawing/2014/main" id="{2F3299EB-88D4-4900-BC3C-0A7C75CCCF2C}"/>
               </a:ext>
             </a:extLst>
           </p:cNvPr>
@@ -11328,7 +11328,7 @@
                   <a:srgbClr val="FFFFFF"/>
                 </a:solidFill>
               </a:rPr>
-              <a:t>Retailer action</a:t>
+              <a:t>小売業者 action</a:t>
             </a:r>
           </a:p>
         </p:txBody>
@@ -11338,7 +11338,7 @@
           <p:cNvPr id="7" name="">
             <a:extLst xmlns:a="http://schemas.openxmlformats.org/drawingml/2006/main">
               <a:ext uri="{FF2B5EF4-FFF2-40B4-BE49-F238E27FC236}">
-                <a16:creationId xmlns:a16="http://schemas.microsoft.com/office/drawing/2014/main" id="{310187EB-91DA-432F-8781-2AE424D3AA74}"/>
+                <a16:creationId xmlns:a16="http://schemas.microsoft.com/office/drawing/2014/main" id="{82D7D664-6AF3-4296-84E4-00367F58F88B}"/>
               </a:ext>
             </a:extLst>
           </p:cNvPr>
@@ -11384,7 +11384,7 @@
                   <a:srgbClr val="FFFFFF"/>
                 </a:solidFill>
               </a:rPr>
-              <a:t>Supplier action</a:t>
+              <a:t>サプライヤー action</a:t>
             </a:r>
           </a:p>
         </p:txBody>
@@ -11394,7 +11394,7 @@
           <p:cNvPr id="8" name="">
             <a:extLst xmlns:a="http://schemas.openxmlformats.org/drawingml/2006/main">
               <a:ext uri="{FF2B5EF4-FFF2-40B4-BE49-F238E27FC236}">
-                <a16:creationId xmlns:a16="http://schemas.microsoft.com/office/drawing/2014/main" id="{2AA3A6A1-AB43-45F5-A50E-85880B9F1334}"/>
+                <a16:creationId xmlns:a16="http://schemas.microsoft.com/office/drawing/2014/main" id="{D1E15994-E77C-40BE-B522-C25D5EC60FEB}"/>
               </a:ext>
             </a:extLst>
           </p:cNvPr>
@@ -11450,7 +11450,7 @@
           <p:cNvPr id="9" name="">
             <a:extLst xmlns:a="http://schemas.openxmlformats.org/drawingml/2006/main">
               <a:ext uri="{FF2B5EF4-FFF2-40B4-BE49-F238E27FC236}">
-                <a16:creationId xmlns:a16="http://schemas.microsoft.com/office/drawing/2014/main" id="{8F1B3AD7-05DA-4DE9-BC79-4E632B8C2AD1}"/>
+                <a16:creationId xmlns:a16="http://schemas.microsoft.com/office/drawing/2014/main" id="{1F43FD61-6A75-4845-AA8E-5E5734467069}"/>
               </a:ext>
             </a:extLst>
           </p:cNvPr>
@@ -11506,7 +11506,7 @@
           <p:cNvPr id="10" name="">
             <a:extLst xmlns:a="http://schemas.openxmlformats.org/drawingml/2006/main">
               <a:ext uri="{FF2B5EF4-FFF2-40B4-BE49-F238E27FC236}">
-                <a16:creationId xmlns:a16="http://schemas.microsoft.com/office/drawing/2014/main" id="{5392CBEB-71A0-471B-80BD-852356387772}"/>
+                <a16:creationId xmlns:a16="http://schemas.microsoft.com/office/drawing/2014/main" id="{6A970B31-A07B-4250-9F1F-724BF2825483}"/>
               </a:ext>
             </a:extLst>
           </p:cNvPr>
@@ -11562,7 +11562,7 @@
           <p:cNvPr id="11" name="">
             <a:extLst xmlns:a="http://schemas.openxmlformats.org/drawingml/2006/main">
               <a:ext uri="{FF2B5EF4-FFF2-40B4-BE49-F238E27FC236}">
-                <a16:creationId xmlns:a16="http://schemas.microsoft.com/office/drawing/2014/main" id="{77A6885A-99EF-4267-A15C-C41915A26CBB}"/>
+                <a16:creationId xmlns:a16="http://schemas.microsoft.com/office/drawing/2014/main" id="{9A4DF86B-DC8E-430B-A274-B83C4ED71FF2}"/>
               </a:ext>
             </a:extLst>
           </p:cNvPr>
@@ -11618,7 +11618,7 @@
           <p:cNvPr id="12" name="">
             <a:extLst xmlns:a="http://schemas.openxmlformats.org/drawingml/2006/main">
               <a:ext uri="{FF2B5EF4-FFF2-40B4-BE49-F238E27FC236}">
-                <a16:creationId xmlns:a16="http://schemas.microsoft.com/office/drawing/2014/main" id="{DFA211A6-266E-41AE-85D5-3F9A876384E4}"/>
+                <a16:creationId xmlns:a16="http://schemas.microsoft.com/office/drawing/2014/main" id="{338478A9-7CC3-48E5-A18D-7E905D9E2161}"/>
               </a:ext>
             </a:extLst>
           </p:cNvPr>
@@ -11674,7 +11674,7 @@
           <p:cNvPr id="13" name="">
             <a:extLst xmlns:a="http://schemas.openxmlformats.org/drawingml/2006/main">
               <a:ext uri="{FF2B5EF4-FFF2-40B4-BE49-F238E27FC236}">
-                <a16:creationId xmlns:a16="http://schemas.microsoft.com/office/drawing/2014/main" id="{B5991326-793E-4587-A8BB-AA6A05345651}"/>
+                <a16:creationId xmlns:a16="http://schemas.microsoft.com/office/drawing/2014/main" id="{512020AE-5E01-4C66-B7AF-32627824C36A}"/>
               </a:ext>
             </a:extLst>
           </p:cNvPr>
@@ -11730,7 +11730,7 @@
           <p:cNvPr id="14" name="">
             <a:extLst xmlns:a="http://schemas.openxmlformats.org/drawingml/2006/main">
               <a:ext uri="{FF2B5EF4-FFF2-40B4-BE49-F238E27FC236}">
-                <a16:creationId xmlns:a16="http://schemas.microsoft.com/office/drawing/2014/main" id="{13123844-7907-4DAA-A703-94BC1C80121B}"/>
+                <a16:creationId xmlns:a16="http://schemas.microsoft.com/office/drawing/2014/main" id="{435FED45-1D22-45AD-BC0D-918DC7CB3B82}"/>
               </a:ext>
             </a:extLst>
           </p:cNvPr>
@@ -11776,7 +11776,7 @@
                   <a:srgbClr val="101820"/>
                 </a:solidFill>
               </a:rPr>
-              <a:t>Supplierへcancel request</a:t>
+              <a:t>サプライヤーへcancel request</a:t>
             </a:r>
           </a:p>
         </p:txBody>
@@ -11786,7 +11786,7 @@
           <p:cNvPr id="15" name="">
             <a:extLst xmlns:a="http://schemas.openxmlformats.org/drawingml/2006/main">
               <a:ext uri="{FF2B5EF4-FFF2-40B4-BE49-F238E27FC236}">
-                <a16:creationId xmlns:a16="http://schemas.microsoft.com/office/drawing/2014/main" id="{66B0969F-0156-49F4-B5C0-480392971FE9}"/>
+                <a16:creationId xmlns:a16="http://schemas.microsoft.com/office/drawing/2014/main" id="{3A7C0560-230B-472A-A97C-DD5C88A23CD0}"/>
               </a:ext>
             </a:extLst>
           </p:cNvPr>
@@ -11842,7 +11842,7 @@
           <p:cNvPr id="16" name="">
             <a:extLst xmlns:a="http://schemas.openxmlformats.org/drawingml/2006/main">
               <a:ext uri="{FF2B5EF4-FFF2-40B4-BE49-F238E27FC236}">
-                <a16:creationId xmlns:a16="http://schemas.microsoft.com/office/drawing/2014/main" id="{35E07CDF-A4BB-4B47-91C9-2C66EA8F9465}"/>
+                <a16:creationId xmlns:a16="http://schemas.microsoft.com/office/drawing/2014/main" id="{EDD1257E-CDB5-463A-86C2-7020080BFD7D}"/>
               </a:ext>
             </a:extLst>
           </p:cNvPr>
@@ -11898,7 +11898,7 @@
           <p:cNvPr id="17" name="">
             <a:extLst xmlns:a="http://schemas.openxmlformats.org/drawingml/2006/main">
               <a:ext uri="{FF2B5EF4-FFF2-40B4-BE49-F238E27FC236}">
-                <a16:creationId xmlns:a16="http://schemas.microsoft.com/office/drawing/2014/main" id="{C6AD98B9-8914-4E40-A347-A2FB280A71FB}"/>
+                <a16:creationId xmlns:a16="http://schemas.microsoft.com/office/drawing/2014/main" id="{17A19C4D-28FF-4C3F-AA28-808E26468E48}"/>
               </a:ext>
             </a:extLst>
           </p:cNvPr>
@@ -11944,7 +11944,7 @@
                   <a:srgbClr val="004C3F"/>
                 </a:solidFill>
               </a:rPr>
-              <a:t>Supplier cancel</a:t>
+              <a:t>サプライヤーcancel</a:t>
             </a:r>
           </a:p>
         </p:txBody>
@@ -11954,7 +11954,7 @@
           <p:cNvPr id="18" name="">
             <a:extLst xmlns:a="http://schemas.openxmlformats.org/drawingml/2006/main">
               <a:ext uri="{FF2B5EF4-FFF2-40B4-BE49-F238E27FC236}">
-                <a16:creationId xmlns:a16="http://schemas.microsoft.com/office/drawing/2014/main" id="{8C009E9E-194C-4538-B488-78418C898C7F}"/>
+                <a16:creationId xmlns:a16="http://schemas.microsoft.com/office/drawing/2014/main" id="{C4999DF1-8E54-4CB3-AFE1-B3E956BABBF3}"/>
               </a:ext>
             </a:extLst>
           </p:cNvPr>
@@ -12000,7 +12000,7 @@
                   <a:srgbClr val="101820"/>
                 </a:solidFill>
               </a:rPr>
-              <a:t>Retailer注文が自動更新</a:t>
+              <a:t>小売業者注文が自動更新</a:t>
             </a:r>
           </a:p>
         </p:txBody>
@@ -12010,7 +12010,7 @@
           <p:cNvPr id="19" name="">
             <a:extLst xmlns:a="http://schemas.openxmlformats.org/drawingml/2006/main">
               <a:ext uri="{FF2B5EF4-FFF2-40B4-BE49-F238E27FC236}">
-                <a16:creationId xmlns:a16="http://schemas.microsoft.com/office/drawing/2014/main" id="{3812896F-8672-4FF8-B505-80134B332828}"/>
+                <a16:creationId xmlns:a16="http://schemas.microsoft.com/office/drawing/2014/main" id="{105FDE99-83B4-44D1-863A-ECB9D2AF862E}"/>
               </a:ext>
             </a:extLst>
           </p:cNvPr>
@@ -12066,7 +12066,7 @@
           <p:cNvPr id="20" name="">
             <a:extLst xmlns:a="http://schemas.openxmlformats.org/drawingml/2006/main">
               <a:ext uri="{FF2B5EF4-FFF2-40B4-BE49-F238E27FC236}">
-                <a16:creationId xmlns:a16="http://schemas.microsoft.com/office/drawing/2014/main" id="{98676116-08C6-4872-8F0A-D9284F0CBB07}"/>
+                <a16:creationId xmlns:a16="http://schemas.microsoft.com/office/drawing/2014/main" id="{5DCD2772-EBAB-484B-B764-8D8DC551DB3F}"/>
               </a:ext>
             </a:extLst>
           </p:cNvPr>
@@ -12122,7 +12122,7 @@
           <p:cNvPr id="21" name="">
             <a:extLst xmlns:a="http://schemas.openxmlformats.org/drawingml/2006/main">
               <a:ext uri="{FF2B5EF4-FFF2-40B4-BE49-F238E27FC236}">
-                <a16:creationId xmlns:a16="http://schemas.microsoft.com/office/drawing/2014/main" id="{0907EC87-F523-4BFF-A5F7-8B5AC5F69A32}"/>
+                <a16:creationId xmlns:a16="http://schemas.microsoft.com/office/drawing/2014/main" id="{6D275AFF-F33F-43CE-8D2A-65C0936A6DDA}"/>
               </a:ext>
             </a:extLst>
           </p:cNvPr>
@@ -12178,7 +12178,7 @@
           <p:cNvPr id="22" name="">
             <a:extLst xmlns:a="http://schemas.openxmlformats.org/drawingml/2006/main">
               <a:ext uri="{FF2B5EF4-FFF2-40B4-BE49-F238E27FC236}">
-                <a16:creationId xmlns:a16="http://schemas.microsoft.com/office/drawing/2014/main" id="{F09C1E5E-2A39-45F9-B044-F9DFF399C657}"/>
+                <a16:creationId xmlns:a16="http://schemas.microsoft.com/office/drawing/2014/main" id="{462E4986-8F75-4A3A-B618-ABB212A56185}"/>
               </a:ext>
             </a:extLst>
           </p:cNvPr>
@@ -12234,7 +12234,7 @@
           <p:cNvPr id="23" name="">
             <a:extLst xmlns:a="http://schemas.openxmlformats.org/drawingml/2006/main">
               <a:ext uri="{FF2B5EF4-FFF2-40B4-BE49-F238E27FC236}">
-                <a16:creationId xmlns:a16="http://schemas.microsoft.com/office/drawing/2014/main" id="{2288D955-2D17-4C17-B678-2B878FE3F534}"/>
+                <a16:creationId xmlns:a16="http://schemas.microsoft.com/office/drawing/2014/main" id="{678589AB-EB08-4530-85ED-3EAA7506338B}"/>
               </a:ext>
             </a:extLst>
           </p:cNvPr>
@@ -12290,7 +12290,7 @@
           <p:cNvPr id="24" name="">
             <a:extLst xmlns:a="http://schemas.openxmlformats.org/drawingml/2006/main">
               <a:ext uri="{FF2B5EF4-FFF2-40B4-BE49-F238E27FC236}">
-                <a16:creationId xmlns:a16="http://schemas.microsoft.com/office/drawing/2014/main" id="{73C652DB-783E-491B-BE10-9A71DD6DBE07}"/>
+                <a16:creationId xmlns:a16="http://schemas.microsoft.com/office/drawing/2014/main" id="{56AED328-07D3-45B8-9841-382677D7A98F}"/>
               </a:ext>
             </a:extLst>
           </p:cNvPr>
@@ -12346,7 +12346,7 @@
           <p:cNvPr id="25" name="">
             <a:extLst xmlns:a="http://schemas.openxmlformats.org/drawingml/2006/main">
               <a:ext uri="{FF2B5EF4-FFF2-40B4-BE49-F238E27FC236}">
-                <a16:creationId xmlns:a16="http://schemas.microsoft.com/office/drawing/2014/main" id="{5641C61D-7ECB-406A-BC70-E0A9E63393EC}"/>
+                <a16:creationId xmlns:a16="http://schemas.microsoft.com/office/drawing/2014/main" id="{EB2EFB6E-A386-46A2-A3E0-4669C015843D}"/>
               </a:ext>
             </a:extLst>
           </p:cNvPr>
@@ -12377,7 +12377,7 @@
           <p:cNvPr id="26" name="">
             <a:extLst xmlns:a="http://schemas.openxmlformats.org/drawingml/2006/main">
               <a:ext uri="{FF2B5EF4-FFF2-40B4-BE49-F238E27FC236}">
-                <a16:creationId xmlns:a16="http://schemas.microsoft.com/office/drawing/2014/main" id="{E1CBE960-F87D-48A3-9C63-E4991FF90246}"/>
+                <a16:creationId xmlns:a16="http://schemas.microsoft.com/office/drawing/2014/main" id="{55221C2B-2DF1-453E-ABDF-F48EA8BA4456}"/>
               </a:ext>
             </a:extLst>
           </p:cNvPr>
@@ -12427,7 +12427,7 @@
           <p:cNvPr id="27" name="">
             <a:extLst xmlns:a="http://schemas.openxmlformats.org/drawingml/2006/main">
               <a:ext uri="{FF2B5EF4-FFF2-40B4-BE49-F238E27FC236}">
-                <a16:creationId xmlns:a16="http://schemas.microsoft.com/office/drawing/2014/main" id="{BC5ACA6F-4A20-4C72-B66E-69B3317D0E83}"/>
+                <a16:creationId xmlns:a16="http://schemas.microsoft.com/office/drawing/2014/main" id="{EE3025A7-3745-4DA7-95BA-B2FF234E6EAD}"/>
               </a:ext>
             </a:extLst>
           </p:cNvPr>
@@ -12475,7 +12475,7 @@
     </p:spTree>
     <p:extLst>
       <p:ext uri="{BB962C8B-B14F-4D97-AF65-F5344CB8AC3E}">
-        <p14:creationId xmlns:p14="http://schemas.microsoft.com/office/powerpoint/2010/main" val="329313596"/>
+        <p14:creationId xmlns:p14="http://schemas.microsoft.com/office/powerpoint/2010/main" val="1569291471"/>
       </p:ext>
     </p:extLst>
   </p:cSld>

</xml_diff>

<commit_message>
Add Collective Shopify Payments FAQ
</commit_message>
<xml_diff>
--- a/products/shopify-collective/ja/shopify-collective-architecture-ja.pptx
+++ b/products/shopify-collective/ja/shopify-collective-architecture-ja.pptx
@@ -2713,6 +2713,106 @@
       </p:sp>
       <p:sp>
         <p:nvSpPr>
+          <p:cNvPr id="16" name="">
+            <a:extLst xmlns:a="http://schemas.openxmlformats.org/drawingml/2006/main">
+              <a:ext uri="{FF2B5EF4-FFF2-40B4-BE49-F238E27FC236}">
+                <a16:creationId xmlns:a16="http://schemas.microsoft.com/office/drawing/2014/main" id="{605E7568-2889-4B3F-8446-73310480EC86}"/>
+              </a:ext>
+            </a:extLst>
+          </p:cNvPr>
+          <p:cNvSpPr>
+            <a:spLocks xmlns:a="http://schemas.openxmlformats.org/drawingml/2006/main" noGrp="1"/>
+          </p:cNvSpPr>
+          <p:nvPr/>
+        </p:nvSpPr>
+        <p:spPr>
+          <a:xfrm xmlns:a="http://schemas.openxmlformats.org/drawingml/2006/main">
+            <a:off x="609600" y="5010150"/>
+            <a:ext cx="10972800" cy="361950"/>
+          </a:xfrm>
+          <a:prstGeom xmlns:a="http://schemas.openxmlformats.org/drawingml/2006/main" prst="rect">
+            <a:avLst/>
+          </a:prstGeom>
+          <a:noFill xmlns:a="http://schemas.openxmlformats.org/drawingml/2006/main"/>
+          <a:ln xmlns:a="http://schemas.openxmlformats.org/drawingml/2006/main" w="0">
+            <a:noFill/>
+            <a:prstDash val="solid"/>
+          </a:ln>
+        </p:spPr>
+        <p:txBody>
+          <a:bodyPr xmlns:a="http://schemas.openxmlformats.org/drawingml/2006/main"/>
+          <a:lstStyle xmlns:a="http://schemas.openxmlformats.org/drawingml/2006/main"/>
+          <a:p xmlns:a="http://schemas.openxmlformats.org/drawingml/2006/main">
+            <a:pPr algn="l">
+              <a:defRPr sz="1350" b="1">
+                <a:solidFill>
+                  <a:srgbClr val="004C3F"/>
+                </a:solidFill>
+              </a:defRPr>
+            </a:pPr>
+            <a:r>
+              <a:rPr sz="1350" b="1">
+                <a:solidFill>
+                  <a:srgbClr val="004C3F"/>
+                </a:solidFill>
+              </a:rPr>
+              <a:t>Shopify Payments利用有無で何が違う?</a:t>
+            </a:r>
+          </a:p>
+        </p:txBody>
+      </p:sp>
+      <p:sp>
+        <p:nvSpPr>
+          <p:cNvPr id="17" name="">
+            <a:extLst xmlns:a="http://schemas.openxmlformats.org/drawingml/2006/main">
+              <a:ext uri="{FF2B5EF4-FFF2-40B4-BE49-F238E27FC236}">
+                <a16:creationId xmlns:a16="http://schemas.microsoft.com/office/drawing/2014/main" id="{CA753E90-B523-4A3C-8FE2-A590CEA46F69}"/>
+              </a:ext>
+            </a:extLst>
+          </p:cNvPr>
+          <p:cNvSpPr>
+            <a:spLocks xmlns:a="http://schemas.openxmlformats.org/drawingml/2006/main" noGrp="1"/>
+          </p:cNvSpPr>
+          <p:nvPr/>
+        </p:nvSpPr>
+        <p:spPr>
+          <a:xfrm xmlns:a="http://schemas.openxmlformats.org/drawingml/2006/main">
+            <a:off x="609600" y="5410200"/>
+            <a:ext cx="10972800" cy="628650"/>
+          </a:xfrm>
+          <a:prstGeom xmlns:a="http://schemas.openxmlformats.org/drawingml/2006/main" prst="rect">
+            <a:avLst/>
+          </a:prstGeom>
+          <a:noFill xmlns:a="http://schemas.openxmlformats.org/drawingml/2006/main"/>
+          <a:ln xmlns:a="http://schemas.openxmlformats.org/drawingml/2006/main" w="0">
+            <a:noFill/>
+            <a:prstDash val="solid"/>
+          </a:ln>
+        </p:spPr>
+        <p:txBody>
+          <a:bodyPr xmlns:a="http://schemas.openxmlformats.org/drawingml/2006/main"/>
+          <a:lstStyle xmlns:a="http://schemas.openxmlformats.org/drawingml/2006/main"/>
+          <a:p xmlns:a="http://schemas.openxmlformats.org/drawingml/2006/main">
+            <a:pPr algn="l">
+              <a:defRPr sz="1088" b="0">
+                <a:solidFill>
+                  <a:srgbClr val="52615B"/>
+                </a:solidFill>
+              </a:defRPr>
+            </a:pPr>
+            <a:r>
+              <a:rPr sz="1088" b="0">
+                <a:solidFill>
+                  <a:srgbClr val="52615B"/>
+                </a:solidFill>
+              </a:rPr>
+              <a:t>注文データは基本同じです。小売業者注文後、支払い・不正チェックを経てサプライヤー注文/fulfillmentが作成・リンクされます。Automatic Payments対象ならdebit/credit adjustmentを照合し、対象外なら支払いはmanual/pendingとして別途精算します。</a:t>
+            </a:r>
+          </a:p>
+        </p:txBody>
+      </p:sp>
+      <p:sp>
+        <p:nvSpPr>
           <p:cNvPr id="13" name="">
             <a:extLst xmlns:a="http://schemas.openxmlformats.org/drawingml/2006/main">
               <a:ext uri="{FF2B5EF4-FFF2-40B4-BE49-F238E27FC236}">

</xml_diff>